<commit_message>
Add project proposal and presentation deck
Proposal: data, plan of action, evaluation methodology, timeline, and
hardware capture track (drone/LiDAR/thermal), formatted to the course
proposal guidelines. Presentation: 18-slide deck covering the same
material plus the build-vs-Meshy branch discussion, merged with the
Blender/Unity scripting plan from the earlier prototyping deck.
</commit_message>
<xml_diff>
--- a/presentation.pptx
+++ b/presentation.pptx
@@ -5,26 +5,26 @@
     <p:sldMasterId id="2147483648" r:id="rId1"/>
   </p:sldMasterIdLst>
   <p:sldIdLst>
-    <p:sldId id="256" r:id="rId7"/>
-    <p:sldId id="257" r:id="rId8"/>
-    <p:sldId id="258" r:id="rId9"/>
-    <p:sldId id="259" r:id="rId10"/>
-    <p:sldId id="260" r:id="rId11"/>
-    <p:sldId id="261" r:id="rId12"/>
-    <p:sldId id="262" r:id="rId13"/>
-    <p:sldId id="263" r:id="rId14"/>
-    <p:sldId id="264" r:id="rId15"/>
-    <p:sldId id="265" r:id="rId16"/>
-    <p:sldId id="266" r:id="rId17"/>
-    <p:sldId id="267" r:id="rId18"/>
-    <p:sldId id="268" r:id="rId19"/>
-    <p:sldId id="269" r:id="rId20"/>
-    <p:sldId id="270" r:id="rId21"/>
-    <p:sldId id="271" r:id="rId22"/>
-    <p:sldId id="272" r:id="rId23"/>
-    <p:sldId id="273" r:id="rId24"/>
+    <p:sldId id="256" r:id="rId2"/>
+    <p:sldId id="257" r:id="rId3"/>
+    <p:sldId id="258" r:id="rId4"/>
+    <p:sldId id="259" r:id="rId5"/>
+    <p:sldId id="260" r:id="rId6"/>
+    <p:sldId id="261" r:id="rId7"/>
+    <p:sldId id="262" r:id="rId8"/>
+    <p:sldId id="263" r:id="rId9"/>
+    <p:sldId id="264" r:id="rId10"/>
+    <p:sldId id="265" r:id="rId11"/>
+    <p:sldId id="266" r:id="rId12"/>
+    <p:sldId id="267" r:id="rId13"/>
+    <p:sldId id="268" r:id="rId14"/>
+    <p:sldId id="269" r:id="rId15"/>
+    <p:sldId id="270" r:id="rId16"/>
+    <p:sldId id="271" r:id="rId17"/>
+    <p:sldId id="272" r:id="rId18"/>
+    <p:sldId id="273" r:id="rId19"/>
   </p:sldIdLst>
-  <p:sldSz cx="12191695" cy="6858000" type="screen4x3"/>
+  <p:sldSz cx="12192000" cy="6858000"/>
   <p:notesSz cx="6858000" cy="9144000"/>
   <p:defaultTextStyle>
     <a:defPPr>
@@ -121,7 +121,52 @@
       </a:defRPr>
     </a:lvl9pPr>
   </p:defaultTextStyle>
+  <p:extLst>
+    <p:ext uri="{EFAFB233-063F-42B5-8137-9DF3F51BA10A}">
+      <p15:sldGuideLst xmlns:p15="http://schemas.microsoft.com/office/powerpoint/2012/main">
+        <p15:guide id="1" orient="horz" pos="2160">
+          <p15:clr>
+            <a:srgbClr val="A4A3A4"/>
+          </p15:clr>
+        </p15:guide>
+        <p15:guide id="2" pos="2880">
+          <p15:clr>
+            <a:srgbClr val="A4A3A4"/>
+          </p15:clr>
+        </p15:guide>
+      </p15:sldGuideLst>
+    </p:ext>
+  </p:extLst>
 </p:presentation>
+</file>
+
+<file path=ppt/changesInfos/changesInfo1.xml><?xml version="1.0" encoding="utf-8"?>
+<pc:chgInfo xmlns:a="http://schemas.openxmlformats.org/drawingml/2006/main" xmlns:r="http://schemas.openxmlformats.org/officeDocument/2006/relationships" xmlns:ac="http://schemas.microsoft.com/office/drawing/2013/main/command" xmlns:pc="http://schemas.microsoft.com/office/powerpoint/2013/main/command">
+  <pc:docChgLst>
+    <pc:chgData name="Salcido O'ferra, Cesar" userId="9d6d544b-1422-4a76-8f1b-6459aa5ae530" providerId="ADAL" clId="{EB7CE27A-5EC2-5202-99F6-B24EC35CCE99}"/>
+    <pc:docChg chg="modSld">
+      <pc:chgData name="Salcido O'ferra, Cesar" userId="9d6d544b-1422-4a76-8f1b-6459aa5ae530" providerId="ADAL" clId="{EB7CE27A-5EC2-5202-99F6-B24EC35CCE99}" dt="2026-09-25T18:59:02.872" v="1" actId="20577"/>
+      <pc:docMkLst>
+        <pc:docMk/>
+      </pc:docMkLst>
+      <pc:sldChg chg="modSp mod">
+        <pc:chgData name="Salcido O'ferra, Cesar" userId="9d6d544b-1422-4a76-8f1b-6459aa5ae530" providerId="ADAL" clId="{EB7CE27A-5EC2-5202-99F6-B24EC35CCE99}" dt="2026-09-25T18:59:02.872" v="1" actId="20577"/>
+        <pc:sldMkLst>
+          <pc:docMk/>
+          <pc:sldMk cId="0" sldId="272"/>
+        </pc:sldMkLst>
+        <pc:spChg chg="mod">
+          <ac:chgData name="Salcido O'ferra, Cesar" userId="9d6d544b-1422-4a76-8f1b-6459aa5ae530" providerId="ADAL" clId="{EB7CE27A-5EC2-5202-99F6-B24EC35CCE99}" dt="2026-09-25T18:59:02.872" v="1" actId="20577"/>
+          <ac:spMkLst>
+            <pc:docMk/>
+            <pc:sldMk cId="0" sldId="272"/>
+            <ac:spMk id="5" creationId="{00000000-0000-0000-0000-000000000000}"/>
+          </ac:spMkLst>
+        </pc:spChg>
+      </pc:sldChg>
+    </pc:docChg>
+  </pc:docChgLst>
+</pc:chgInfo>
 </file>
 
 <file path=ppt/slideLayouts/slideLayout1.xml><?xml version="1.0" encoding="utf-8"?>
@@ -162,10 +207,9 @@
           <a:lstStyle/>
           <a:p>
             <a:r>
-              <a:rPr lang="en-US" smtClean="0"/>
+              <a:rPr lang="en-US"/>
               <a:t>Click to edit Master title style</a:t>
             </a:r>
-            <a:endParaRPr lang="en-US"/>
           </a:p>
         </p:txBody>
       </p:sp>
@@ -281,10 +325,9 @@
           </a:lstStyle>
           <a:p>
             <a:r>
-              <a:rPr lang="en-US" smtClean="0"/>
+              <a:rPr lang="en-US"/>
               <a:t>Click to edit Master subtitle style</a:t>
             </a:r>
-            <a:endParaRPr lang="en-US"/>
           </a:p>
         </p:txBody>
       </p:sp>
@@ -305,7 +348,7 @@
           <a:p>
             <a:fld id="{5BCAD085-E8A6-8845-BD4E-CB4CCA059FC4}" type="datetimeFigureOut">
               <a:rPr lang="en-US" smtClean="0"/>
-              <a:t>1/27/13</a:t>
+              <a:t>9/25/26</a:t>
             </a:fld>
             <a:endParaRPr lang="en-US"/>
           </a:p>
@@ -399,10 +442,9 @@
           <a:lstStyle/>
           <a:p>
             <a:r>
-              <a:rPr lang="en-US" smtClean="0"/>
+              <a:rPr lang="en-US"/>
               <a:t>Click to edit Master title style</a:t>
             </a:r>
-            <a:endParaRPr lang="en-US"/>
           </a:p>
         </p:txBody>
       </p:sp>
@@ -423,38 +465,37 @@
           <a:p>
             <a:pPr lvl="0"/>
             <a:r>
-              <a:rPr lang="en-US" smtClean="0"/>
+              <a:rPr lang="en-US"/>
               <a:t>Click to edit Master text styles</a:t>
             </a:r>
           </a:p>
           <a:p>
             <a:pPr lvl="1"/>
             <a:r>
-              <a:rPr lang="en-US" smtClean="0"/>
+              <a:rPr lang="en-US"/>
               <a:t>Second level</a:t>
             </a:r>
           </a:p>
           <a:p>
             <a:pPr lvl="2"/>
             <a:r>
-              <a:rPr lang="en-US" smtClean="0"/>
+              <a:rPr lang="en-US"/>
               <a:t>Third level</a:t>
             </a:r>
           </a:p>
           <a:p>
             <a:pPr lvl="3"/>
             <a:r>
-              <a:rPr lang="en-US" smtClean="0"/>
+              <a:rPr lang="en-US"/>
               <a:t>Fourth level</a:t>
             </a:r>
           </a:p>
           <a:p>
             <a:pPr lvl="4"/>
             <a:r>
-              <a:rPr lang="en-US" smtClean="0"/>
+              <a:rPr lang="en-US"/>
               <a:t>Fifth level</a:t>
             </a:r>
-            <a:endParaRPr lang="en-US"/>
           </a:p>
         </p:txBody>
       </p:sp>
@@ -475,7 +516,7 @@
           <a:p>
             <a:fld id="{5BCAD085-E8A6-8845-BD4E-CB4CCA059FC4}" type="datetimeFigureOut">
               <a:rPr lang="en-US" smtClean="0"/>
-              <a:t>1/27/13</a:t>
+              <a:t>9/25/26</a:t>
             </a:fld>
             <a:endParaRPr lang="en-US"/>
           </a:p>
@@ -574,10 +615,9 @@
           <a:lstStyle/>
           <a:p>
             <a:r>
-              <a:rPr lang="en-US" smtClean="0"/>
+              <a:rPr lang="en-US"/>
               <a:t>Click to edit Master title style</a:t>
             </a:r>
-            <a:endParaRPr lang="en-US"/>
           </a:p>
         </p:txBody>
       </p:sp>
@@ -603,38 +643,37 @@
           <a:p>
             <a:pPr lvl="0"/>
             <a:r>
-              <a:rPr lang="en-US" smtClean="0"/>
+              <a:rPr lang="en-US"/>
               <a:t>Click to edit Master text styles</a:t>
             </a:r>
           </a:p>
           <a:p>
             <a:pPr lvl="1"/>
             <a:r>
-              <a:rPr lang="en-US" smtClean="0"/>
+              <a:rPr lang="en-US"/>
               <a:t>Second level</a:t>
             </a:r>
           </a:p>
           <a:p>
             <a:pPr lvl="2"/>
             <a:r>
-              <a:rPr lang="en-US" smtClean="0"/>
+              <a:rPr lang="en-US"/>
               <a:t>Third level</a:t>
             </a:r>
           </a:p>
           <a:p>
             <a:pPr lvl="3"/>
             <a:r>
-              <a:rPr lang="en-US" smtClean="0"/>
+              <a:rPr lang="en-US"/>
               <a:t>Fourth level</a:t>
             </a:r>
           </a:p>
           <a:p>
             <a:pPr lvl="4"/>
             <a:r>
-              <a:rPr lang="en-US" smtClean="0"/>
+              <a:rPr lang="en-US"/>
               <a:t>Fifth level</a:t>
             </a:r>
-            <a:endParaRPr lang="en-US"/>
           </a:p>
         </p:txBody>
       </p:sp>
@@ -655,7 +694,7 @@
           <a:p>
             <a:fld id="{5BCAD085-E8A6-8845-BD4E-CB4CCA059FC4}" type="datetimeFigureOut">
               <a:rPr lang="en-US" smtClean="0"/>
-              <a:t>1/27/13</a:t>
+              <a:t>9/25/26</a:t>
             </a:fld>
             <a:endParaRPr lang="en-US"/>
           </a:p>
@@ -749,10 +788,9 @@
           <a:lstStyle/>
           <a:p>
             <a:r>
-              <a:rPr lang="en-US" smtClean="0"/>
+              <a:rPr lang="en-US"/>
               <a:t>Click to edit Master title style</a:t>
             </a:r>
-            <a:endParaRPr lang="en-US"/>
           </a:p>
         </p:txBody>
       </p:sp>
@@ -773,38 +811,37 @@
           <a:p>
             <a:pPr lvl="0"/>
             <a:r>
-              <a:rPr lang="en-US" smtClean="0"/>
+              <a:rPr lang="en-US"/>
               <a:t>Click to edit Master text styles</a:t>
             </a:r>
           </a:p>
           <a:p>
             <a:pPr lvl="1"/>
             <a:r>
-              <a:rPr lang="en-US" smtClean="0"/>
+              <a:rPr lang="en-US"/>
               <a:t>Second level</a:t>
             </a:r>
           </a:p>
           <a:p>
             <a:pPr lvl="2"/>
             <a:r>
-              <a:rPr lang="en-US" smtClean="0"/>
+              <a:rPr lang="en-US"/>
               <a:t>Third level</a:t>
             </a:r>
           </a:p>
           <a:p>
             <a:pPr lvl="3"/>
             <a:r>
-              <a:rPr lang="en-US" smtClean="0"/>
+              <a:rPr lang="en-US"/>
               <a:t>Fourth level</a:t>
             </a:r>
           </a:p>
           <a:p>
             <a:pPr lvl="4"/>
             <a:r>
-              <a:rPr lang="en-US" smtClean="0"/>
+              <a:rPr lang="en-US"/>
               <a:t>Fifth level</a:t>
             </a:r>
-            <a:endParaRPr lang="en-US"/>
           </a:p>
         </p:txBody>
       </p:sp>
@@ -825,7 +862,7 @@
           <a:p>
             <a:fld id="{5BCAD085-E8A6-8845-BD4E-CB4CCA059FC4}" type="datetimeFigureOut">
               <a:rPr lang="en-US" smtClean="0"/>
-              <a:t>1/27/13</a:t>
+              <a:t>9/25/26</a:t>
             </a:fld>
             <a:endParaRPr lang="en-US"/>
           </a:p>
@@ -928,10 +965,9 @@
           </a:lstStyle>
           <a:p>
             <a:r>
-              <a:rPr lang="en-US" smtClean="0"/>
+              <a:rPr lang="en-US"/>
               <a:t>Click to edit Master title style</a:t>
             </a:r>
-            <a:endParaRPr lang="en-US"/>
           </a:p>
         </p:txBody>
       </p:sp>
@@ -1048,7 +1084,7 @@
           <a:p>
             <a:pPr lvl="0"/>
             <a:r>
-              <a:rPr lang="en-US" smtClean="0"/>
+              <a:rPr lang="en-US"/>
               <a:t>Click to edit Master text styles</a:t>
             </a:r>
           </a:p>
@@ -1071,7 +1107,7 @@
           <a:p>
             <a:fld id="{5BCAD085-E8A6-8845-BD4E-CB4CCA059FC4}" type="datetimeFigureOut">
               <a:rPr lang="en-US" smtClean="0"/>
-              <a:t>1/27/13</a:t>
+              <a:t>9/25/26</a:t>
             </a:fld>
             <a:endParaRPr lang="en-US"/>
           </a:p>
@@ -1165,10 +1201,9 @@
           <a:lstStyle/>
           <a:p>
             <a:r>
-              <a:rPr lang="en-US" smtClean="0"/>
+              <a:rPr lang="en-US"/>
               <a:t>Click to edit Master title style</a:t>
             </a:r>
-            <a:endParaRPr lang="en-US"/>
           </a:p>
         </p:txBody>
       </p:sp>
@@ -1222,38 +1257,37 @@
           <a:p>
             <a:pPr lvl="0"/>
             <a:r>
-              <a:rPr lang="en-US" smtClean="0"/>
+              <a:rPr lang="en-US"/>
               <a:t>Click to edit Master text styles</a:t>
             </a:r>
           </a:p>
           <a:p>
             <a:pPr lvl="1"/>
             <a:r>
-              <a:rPr lang="en-US" smtClean="0"/>
+              <a:rPr lang="en-US"/>
               <a:t>Second level</a:t>
             </a:r>
           </a:p>
           <a:p>
             <a:pPr lvl="2"/>
             <a:r>
-              <a:rPr lang="en-US" smtClean="0"/>
+              <a:rPr lang="en-US"/>
               <a:t>Third level</a:t>
             </a:r>
           </a:p>
           <a:p>
             <a:pPr lvl="3"/>
             <a:r>
-              <a:rPr lang="en-US" smtClean="0"/>
+              <a:rPr lang="en-US"/>
               <a:t>Fourth level</a:t>
             </a:r>
           </a:p>
           <a:p>
             <a:pPr lvl="4"/>
             <a:r>
-              <a:rPr lang="en-US" smtClean="0"/>
+              <a:rPr lang="en-US"/>
               <a:t>Fifth level</a:t>
             </a:r>
-            <a:endParaRPr lang="en-US"/>
           </a:p>
         </p:txBody>
       </p:sp>
@@ -1307,38 +1341,37 @@
           <a:p>
             <a:pPr lvl="0"/>
             <a:r>
-              <a:rPr lang="en-US" smtClean="0"/>
+              <a:rPr lang="en-US"/>
               <a:t>Click to edit Master text styles</a:t>
             </a:r>
           </a:p>
           <a:p>
             <a:pPr lvl="1"/>
             <a:r>
-              <a:rPr lang="en-US" smtClean="0"/>
+              <a:rPr lang="en-US"/>
               <a:t>Second level</a:t>
             </a:r>
           </a:p>
           <a:p>
             <a:pPr lvl="2"/>
             <a:r>
-              <a:rPr lang="en-US" smtClean="0"/>
+              <a:rPr lang="en-US"/>
               <a:t>Third level</a:t>
             </a:r>
           </a:p>
           <a:p>
             <a:pPr lvl="3"/>
             <a:r>
-              <a:rPr lang="en-US" smtClean="0"/>
+              <a:rPr lang="en-US"/>
               <a:t>Fourth level</a:t>
             </a:r>
           </a:p>
           <a:p>
             <a:pPr lvl="4"/>
             <a:r>
-              <a:rPr lang="en-US" smtClean="0"/>
+              <a:rPr lang="en-US"/>
               <a:t>Fifth level</a:t>
             </a:r>
-            <a:endParaRPr lang="en-US"/>
           </a:p>
         </p:txBody>
       </p:sp>
@@ -1359,7 +1392,7 @@
           <a:p>
             <a:fld id="{5BCAD085-E8A6-8845-BD4E-CB4CCA059FC4}" type="datetimeFigureOut">
               <a:rPr lang="en-US" smtClean="0"/>
-              <a:t>1/27/13</a:t>
+              <a:t>9/25/26</a:t>
             </a:fld>
             <a:endParaRPr lang="en-US"/>
           </a:p>
@@ -1457,10 +1490,9 @@
           </a:lstStyle>
           <a:p>
             <a:r>
-              <a:rPr lang="en-US" smtClean="0"/>
+              <a:rPr lang="en-US"/>
               <a:t>Click to edit Master title style</a:t>
             </a:r>
-            <a:endParaRPr lang="en-US"/>
           </a:p>
         </p:txBody>
       </p:sp>
@@ -1523,7 +1555,7 @@
           <a:p>
             <a:pPr lvl="0"/>
             <a:r>
-              <a:rPr lang="en-US" smtClean="0"/>
+              <a:rPr lang="en-US"/>
               <a:t>Click to edit Master text styles</a:t>
             </a:r>
           </a:p>
@@ -1579,38 +1611,37 @@
           <a:p>
             <a:pPr lvl="0"/>
             <a:r>
-              <a:rPr lang="en-US" smtClean="0"/>
+              <a:rPr lang="en-US"/>
               <a:t>Click to edit Master text styles</a:t>
             </a:r>
           </a:p>
           <a:p>
             <a:pPr lvl="1"/>
             <a:r>
-              <a:rPr lang="en-US" smtClean="0"/>
+              <a:rPr lang="en-US"/>
               <a:t>Second level</a:t>
             </a:r>
           </a:p>
           <a:p>
             <a:pPr lvl="2"/>
             <a:r>
-              <a:rPr lang="en-US" smtClean="0"/>
+              <a:rPr lang="en-US"/>
               <a:t>Third level</a:t>
             </a:r>
           </a:p>
           <a:p>
             <a:pPr lvl="3"/>
             <a:r>
-              <a:rPr lang="en-US" smtClean="0"/>
+              <a:rPr lang="en-US"/>
               <a:t>Fourth level</a:t>
             </a:r>
           </a:p>
           <a:p>
             <a:pPr lvl="4"/>
             <a:r>
-              <a:rPr lang="en-US" smtClean="0"/>
+              <a:rPr lang="en-US"/>
               <a:t>Fifth level</a:t>
             </a:r>
-            <a:endParaRPr lang="en-US"/>
           </a:p>
         </p:txBody>
       </p:sp>
@@ -1673,7 +1704,7 @@
           <a:p>
             <a:pPr lvl="0"/>
             <a:r>
-              <a:rPr lang="en-US" smtClean="0"/>
+              <a:rPr lang="en-US"/>
               <a:t>Click to edit Master text styles</a:t>
             </a:r>
           </a:p>
@@ -1729,38 +1760,37 @@
           <a:p>
             <a:pPr lvl="0"/>
             <a:r>
-              <a:rPr lang="en-US" smtClean="0"/>
+              <a:rPr lang="en-US"/>
               <a:t>Click to edit Master text styles</a:t>
             </a:r>
           </a:p>
           <a:p>
             <a:pPr lvl="1"/>
             <a:r>
-              <a:rPr lang="en-US" smtClean="0"/>
+              <a:rPr lang="en-US"/>
               <a:t>Second level</a:t>
             </a:r>
           </a:p>
           <a:p>
             <a:pPr lvl="2"/>
             <a:r>
-              <a:rPr lang="en-US" smtClean="0"/>
+              <a:rPr lang="en-US"/>
               <a:t>Third level</a:t>
             </a:r>
           </a:p>
           <a:p>
             <a:pPr lvl="3"/>
             <a:r>
-              <a:rPr lang="en-US" smtClean="0"/>
+              <a:rPr lang="en-US"/>
               <a:t>Fourth level</a:t>
             </a:r>
           </a:p>
           <a:p>
             <a:pPr lvl="4"/>
             <a:r>
-              <a:rPr lang="en-US" smtClean="0"/>
+              <a:rPr lang="en-US"/>
               <a:t>Fifth level</a:t>
             </a:r>
-            <a:endParaRPr lang="en-US"/>
           </a:p>
         </p:txBody>
       </p:sp>
@@ -1781,7 +1811,7 @@
           <a:p>
             <a:fld id="{5BCAD085-E8A6-8845-BD4E-CB4CCA059FC4}" type="datetimeFigureOut">
               <a:rPr lang="en-US" smtClean="0"/>
-              <a:t>1/27/13</a:t>
+              <a:t>9/25/26</a:t>
             </a:fld>
             <a:endParaRPr lang="en-US"/>
           </a:p>
@@ -1875,10 +1905,9 @@
           <a:lstStyle/>
           <a:p>
             <a:r>
-              <a:rPr lang="en-US" smtClean="0"/>
+              <a:rPr lang="en-US"/>
               <a:t>Click to edit Master title style</a:t>
             </a:r>
-            <a:endParaRPr lang="en-US"/>
           </a:p>
         </p:txBody>
       </p:sp>
@@ -1899,7 +1928,7 @@
           <a:p>
             <a:fld id="{5BCAD085-E8A6-8845-BD4E-CB4CCA059FC4}" type="datetimeFigureOut">
               <a:rPr lang="en-US" smtClean="0"/>
-              <a:t>1/27/13</a:t>
+              <a:t>9/25/26</a:t>
             </a:fld>
             <a:endParaRPr lang="en-US"/>
           </a:p>
@@ -1994,7 +2023,7 @@
           <a:p>
             <a:fld id="{5BCAD085-E8A6-8845-BD4E-CB4CCA059FC4}" type="datetimeFigureOut">
               <a:rPr lang="en-US" smtClean="0"/>
-              <a:t>1/27/13</a:t>
+              <a:t>9/25/26</a:t>
             </a:fld>
             <a:endParaRPr lang="en-US"/>
           </a:p>
@@ -2097,10 +2126,9 @@
           </a:lstStyle>
           <a:p>
             <a:r>
-              <a:rPr lang="en-US" smtClean="0"/>
+              <a:rPr lang="en-US"/>
               <a:t>Click to edit Master title style</a:t>
             </a:r>
-            <a:endParaRPr lang="en-US"/>
           </a:p>
         </p:txBody>
       </p:sp>
@@ -2154,38 +2182,37 @@
           <a:p>
             <a:pPr lvl="0"/>
             <a:r>
-              <a:rPr lang="en-US" smtClean="0"/>
+              <a:rPr lang="en-US"/>
               <a:t>Click to edit Master text styles</a:t>
             </a:r>
           </a:p>
           <a:p>
             <a:pPr lvl="1"/>
             <a:r>
-              <a:rPr lang="en-US" smtClean="0"/>
+              <a:rPr lang="en-US"/>
               <a:t>Second level</a:t>
             </a:r>
           </a:p>
           <a:p>
             <a:pPr lvl="2"/>
             <a:r>
-              <a:rPr lang="en-US" smtClean="0"/>
+              <a:rPr lang="en-US"/>
               <a:t>Third level</a:t>
             </a:r>
           </a:p>
           <a:p>
             <a:pPr lvl="3"/>
             <a:r>
-              <a:rPr lang="en-US" smtClean="0"/>
+              <a:rPr lang="en-US"/>
               <a:t>Fourth level</a:t>
             </a:r>
           </a:p>
           <a:p>
             <a:pPr lvl="4"/>
             <a:r>
-              <a:rPr lang="en-US" smtClean="0"/>
+              <a:rPr lang="en-US"/>
               <a:t>Fifth level</a:t>
             </a:r>
-            <a:endParaRPr lang="en-US"/>
           </a:p>
         </p:txBody>
       </p:sp>
@@ -2248,7 +2275,7 @@
           <a:p>
             <a:pPr lvl="0"/>
             <a:r>
-              <a:rPr lang="en-US" smtClean="0"/>
+              <a:rPr lang="en-US"/>
               <a:t>Click to edit Master text styles</a:t>
             </a:r>
           </a:p>
@@ -2271,7 +2298,7 @@
           <a:p>
             <a:fld id="{5BCAD085-E8A6-8845-BD4E-CB4CCA059FC4}" type="datetimeFigureOut">
               <a:rPr lang="en-US" smtClean="0"/>
-              <a:t>1/27/13</a:t>
+              <a:t>9/25/26</a:t>
             </a:fld>
             <a:endParaRPr lang="en-US"/>
           </a:p>
@@ -2374,10 +2401,9 @@
           </a:lstStyle>
           <a:p>
             <a:r>
-              <a:rPr lang="en-US" smtClean="0"/>
+              <a:rPr lang="en-US"/>
               <a:t>Click to edit Master title style</a:t>
             </a:r>
-            <a:endParaRPr lang="en-US"/>
           </a:p>
         </p:txBody>
       </p:sp>
@@ -2501,7 +2527,7 @@
           <a:p>
             <a:pPr lvl="0"/>
             <a:r>
-              <a:rPr lang="en-US" smtClean="0"/>
+              <a:rPr lang="en-US"/>
               <a:t>Click to edit Master text styles</a:t>
             </a:r>
           </a:p>
@@ -2524,7 +2550,7 @@
           <a:p>
             <a:fld id="{5BCAD085-E8A6-8845-BD4E-CB4CCA059FC4}" type="datetimeFigureOut">
               <a:rPr lang="en-US" smtClean="0"/>
-              <a:t>1/27/13</a:t>
+              <a:t>9/25/26</a:t>
             </a:fld>
             <a:endParaRPr lang="en-US"/>
           </a:p>
@@ -2633,10 +2659,9 @@
           <a:lstStyle/>
           <a:p>
             <a:r>
-              <a:rPr lang="en-US" smtClean="0"/>
+              <a:rPr lang="en-US"/>
               <a:t>Click to edit Master title style</a:t>
             </a:r>
-            <a:endParaRPr lang="en-US"/>
           </a:p>
         </p:txBody>
       </p:sp>
@@ -2667,38 +2692,37 @@
           <a:p>
             <a:pPr lvl="0"/>
             <a:r>
-              <a:rPr lang="en-US" smtClean="0"/>
+              <a:rPr lang="en-US"/>
               <a:t>Click to edit Master text styles</a:t>
             </a:r>
           </a:p>
           <a:p>
             <a:pPr lvl="1"/>
             <a:r>
-              <a:rPr lang="en-US" smtClean="0"/>
+              <a:rPr lang="en-US"/>
               <a:t>Second level</a:t>
             </a:r>
           </a:p>
           <a:p>
             <a:pPr lvl="2"/>
             <a:r>
-              <a:rPr lang="en-US" smtClean="0"/>
+              <a:rPr lang="en-US"/>
               <a:t>Third level</a:t>
             </a:r>
           </a:p>
           <a:p>
             <a:pPr lvl="3"/>
             <a:r>
-              <a:rPr lang="en-US" smtClean="0"/>
+              <a:rPr lang="en-US"/>
               <a:t>Fourth level</a:t>
             </a:r>
           </a:p>
           <a:p>
             <a:pPr lvl="4"/>
             <a:r>
-              <a:rPr lang="en-US" smtClean="0"/>
+              <a:rPr lang="en-US"/>
               <a:t>Fifth level</a:t>
             </a:r>
-            <a:endParaRPr lang="en-US"/>
           </a:p>
         </p:txBody>
       </p:sp>
@@ -2737,7 +2761,7 @@
           <a:p>
             <a:fld id="{5BCAD085-E8A6-8845-BD4E-CB4CCA059FC4}" type="datetimeFigureOut">
               <a:rPr lang="en-US" smtClean="0"/>
-              <a:t>1/27/13</a:t>
+              <a:t>9/25/26</a:t>
             </a:fld>
             <a:endParaRPr lang="en-US"/>
           </a:p>
@@ -3096,7 +3120,7 @@
 </file>
 
 <file path=ppt/slides/slide1.xml><?xml version="1.0" encoding="utf-8"?>
-<p:sld xmlns:a="http://schemas.openxmlformats.org/drawingml/2006/main" xmlns:p="http://schemas.openxmlformats.org/presentationml/2006/main" xmlns:r="http://schemas.openxmlformats.org/officeDocument/2006/relationships">
+<p:sld xmlns:a="http://schemas.openxmlformats.org/drawingml/2006/main" xmlns:r="http://schemas.openxmlformats.org/officeDocument/2006/relationships" xmlns:p="http://schemas.openxmlformats.org/presentationml/2006/main">
   <p:cSld>
     <p:bg>
       <p:bgPr>
@@ -3112,7 +3136,14 @@
         <p:cNvGrpSpPr/>
         <p:nvPr/>
       </p:nvGrpSpPr>
-      <p:grpSpPr/>
+      <p:grpSpPr>
+        <a:xfrm>
+          <a:off x="0" y="0"/>
+          <a:ext cx="0" cy="0"/>
+          <a:chOff x="0" y="0"/>
+          <a:chExt cx="0" cy="0"/>
+        </a:xfrm>
+      </p:grpSpPr>
       <p:sp>
         <p:nvSpPr>
           <p:cNvPr id="2" name="TextBox 1"/>
@@ -3221,7 +3252,7 @@
 </file>
 
 <file path=ppt/slides/slide10.xml><?xml version="1.0" encoding="utf-8"?>
-<p:sld xmlns:a="http://schemas.openxmlformats.org/drawingml/2006/main" xmlns:p="http://schemas.openxmlformats.org/presentationml/2006/main" xmlns:r="http://schemas.openxmlformats.org/officeDocument/2006/relationships">
+<p:sld xmlns:a="http://schemas.openxmlformats.org/drawingml/2006/main" xmlns:r="http://schemas.openxmlformats.org/officeDocument/2006/relationships" xmlns:p="http://schemas.openxmlformats.org/presentationml/2006/main">
   <p:cSld>
     <p:bg>
       <p:bgPr>
@@ -3237,7 +3268,14 @@
         <p:cNvGrpSpPr/>
         <p:nvPr/>
       </p:nvGrpSpPr>
-      <p:grpSpPr/>
+      <p:grpSpPr>
+        <a:xfrm>
+          <a:off x="0" y="0"/>
+          <a:ext cx="0" cy="0"/>
+          <a:chOff x="0" y="0"/>
+          <a:chExt cx="0" cy="0"/>
+        </a:xfrm>
+      </p:grpSpPr>
       <p:sp>
         <p:nvSpPr>
           <p:cNvPr id="2" name="Rectangle 1"/>
@@ -3278,6 +3316,7 @@
           <a:lstStyle/>
           <a:p>
             <a:pPr algn="ctr"/>
+            <a:endParaRPr/>
           </a:p>
         </p:txBody>
       </p:sp>
@@ -3354,6 +3393,7 @@
           <a:lstStyle/>
           <a:p>
             <a:pPr algn="ctr"/>
+            <a:endParaRPr/>
           </a:p>
         </p:txBody>
       </p:sp>
@@ -3494,7 +3534,7 @@
           <a:lstStyle/>
           <a:p>
             <a:r>
-              <a:rPr sz="1400" i="1" b="1">
+              <a:rPr sz="1400" b="1" i="1">
                 <a:solidFill>
                   <a:srgbClr val="993300"/>
                 </a:solidFill>
@@ -3513,7 +3553,7 @@
 </file>
 
 <file path=ppt/slides/slide11.xml><?xml version="1.0" encoding="utf-8"?>
-<p:sld xmlns:a="http://schemas.openxmlformats.org/drawingml/2006/main" xmlns:p="http://schemas.openxmlformats.org/presentationml/2006/main" xmlns:r="http://schemas.openxmlformats.org/officeDocument/2006/relationships">
+<p:sld xmlns:a="http://schemas.openxmlformats.org/drawingml/2006/main" xmlns:r="http://schemas.openxmlformats.org/officeDocument/2006/relationships" xmlns:p="http://schemas.openxmlformats.org/presentationml/2006/main">
   <p:cSld>
     <p:bg>
       <p:bgPr>
@@ -3529,7 +3569,14 @@
         <p:cNvGrpSpPr/>
         <p:nvPr/>
       </p:nvGrpSpPr>
-      <p:grpSpPr/>
+      <p:grpSpPr>
+        <a:xfrm>
+          <a:off x="0" y="0"/>
+          <a:ext cx="0" cy="0"/>
+          <a:chOff x="0" y="0"/>
+          <a:chExt cx="0" cy="0"/>
+        </a:xfrm>
+      </p:grpSpPr>
       <p:sp>
         <p:nvSpPr>
           <p:cNvPr id="2" name="Rectangle 1"/>
@@ -3570,6 +3617,7 @@
           <a:lstStyle/>
           <a:p>
             <a:pPr algn="ctr"/>
+            <a:endParaRPr/>
           </a:p>
         </p:txBody>
       </p:sp>
@@ -3646,6 +3694,7 @@
           <a:lstStyle/>
           <a:p>
             <a:pPr algn="ctr"/>
+            <a:endParaRPr/>
           </a:p>
         </p:txBody>
       </p:sp>
@@ -3888,7 +3937,7 @@
 </file>
 
 <file path=ppt/slides/slide12.xml><?xml version="1.0" encoding="utf-8"?>
-<p:sld xmlns:a="http://schemas.openxmlformats.org/drawingml/2006/main" xmlns:p="http://schemas.openxmlformats.org/presentationml/2006/main" xmlns:r="http://schemas.openxmlformats.org/officeDocument/2006/relationships">
+<p:sld xmlns:a="http://schemas.openxmlformats.org/drawingml/2006/main" xmlns:r="http://schemas.openxmlformats.org/officeDocument/2006/relationships" xmlns:p="http://schemas.openxmlformats.org/presentationml/2006/main">
   <p:cSld>
     <p:bg>
       <p:bgPr>
@@ -3904,7 +3953,14 @@
         <p:cNvGrpSpPr/>
         <p:nvPr/>
       </p:nvGrpSpPr>
-      <p:grpSpPr/>
+      <p:grpSpPr>
+        <a:xfrm>
+          <a:off x="0" y="0"/>
+          <a:ext cx="0" cy="0"/>
+          <a:chOff x="0" y="0"/>
+          <a:chExt cx="0" cy="0"/>
+        </a:xfrm>
+      </p:grpSpPr>
       <p:sp>
         <p:nvSpPr>
           <p:cNvPr id="2" name="Rectangle 1"/>
@@ -3945,6 +4001,7 @@
           <a:lstStyle/>
           <a:p>
             <a:pPr algn="ctr"/>
+            <a:endParaRPr/>
           </a:p>
         </p:txBody>
       </p:sp>
@@ -4021,6 +4078,7 @@
           <a:lstStyle/>
           <a:p>
             <a:pPr algn="ctr"/>
+            <a:endParaRPr/>
           </a:p>
         </p:txBody>
       </p:sp>
@@ -4148,7 +4206,7 @@
 </file>
 
 <file path=ppt/slides/slide13.xml><?xml version="1.0" encoding="utf-8"?>
-<p:sld xmlns:a="http://schemas.openxmlformats.org/drawingml/2006/main" xmlns:p="http://schemas.openxmlformats.org/presentationml/2006/main" xmlns:r="http://schemas.openxmlformats.org/officeDocument/2006/relationships">
+<p:sld xmlns:a="http://schemas.openxmlformats.org/drawingml/2006/main" xmlns:r="http://schemas.openxmlformats.org/officeDocument/2006/relationships" xmlns:p="http://schemas.openxmlformats.org/presentationml/2006/main">
   <p:cSld>
     <p:bg>
       <p:bgPr>
@@ -4164,7 +4222,14 @@
         <p:cNvGrpSpPr/>
         <p:nvPr/>
       </p:nvGrpSpPr>
-      <p:grpSpPr/>
+      <p:grpSpPr>
+        <a:xfrm>
+          <a:off x="0" y="0"/>
+          <a:ext cx="0" cy="0"/>
+          <a:chOff x="0" y="0"/>
+          <a:chExt cx="0" cy="0"/>
+        </a:xfrm>
+      </p:grpSpPr>
       <p:sp>
         <p:nvSpPr>
           <p:cNvPr id="2" name="Rectangle 1"/>
@@ -4205,6 +4270,7 @@
           <a:lstStyle/>
           <a:p>
             <a:pPr algn="ctr"/>
+            <a:endParaRPr/>
           </a:p>
         </p:txBody>
       </p:sp>
@@ -4281,6 +4347,7 @@
           <a:lstStyle/>
           <a:p>
             <a:pPr algn="ctr"/>
+            <a:endParaRPr/>
           </a:p>
         </p:txBody>
       </p:sp>
@@ -4395,7 +4462,7 @@
 </file>
 
 <file path=ppt/slides/slide14.xml><?xml version="1.0" encoding="utf-8"?>
-<p:sld xmlns:a="http://schemas.openxmlformats.org/drawingml/2006/main" xmlns:p="http://schemas.openxmlformats.org/presentationml/2006/main" xmlns:r="http://schemas.openxmlformats.org/officeDocument/2006/relationships">
+<p:sld xmlns:a="http://schemas.openxmlformats.org/drawingml/2006/main" xmlns:r="http://schemas.openxmlformats.org/officeDocument/2006/relationships" xmlns:p="http://schemas.openxmlformats.org/presentationml/2006/main">
   <p:cSld>
     <p:bg>
       <p:bgPr>
@@ -4411,7 +4478,14 @@
         <p:cNvGrpSpPr/>
         <p:nvPr/>
       </p:nvGrpSpPr>
-      <p:grpSpPr/>
+      <p:grpSpPr>
+        <a:xfrm>
+          <a:off x="0" y="0"/>
+          <a:ext cx="0" cy="0"/>
+          <a:chOff x="0" y="0"/>
+          <a:chExt cx="0" cy="0"/>
+        </a:xfrm>
+      </p:grpSpPr>
       <p:sp>
         <p:nvSpPr>
           <p:cNvPr id="2" name="Rectangle 1"/>
@@ -4452,6 +4526,7 @@
           <a:lstStyle/>
           <a:p>
             <a:pPr algn="ctr"/>
+            <a:endParaRPr/>
           </a:p>
         </p:txBody>
       </p:sp>
@@ -4528,6 +4603,7 @@
           <a:lstStyle/>
           <a:p>
             <a:pPr algn="ctr"/>
+            <a:endParaRPr/>
           </a:p>
         </p:txBody>
       </p:sp>
@@ -4655,7 +4731,7 @@
 </file>
 
 <file path=ppt/slides/slide15.xml><?xml version="1.0" encoding="utf-8"?>
-<p:sld xmlns:a="http://schemas.openxmlformats.org/drawingml/2006/main" xmlns:p="http://schemas.openxmlformats.org/presentationml/2006/main" xmlns:r="http://schemas.openxmlformats.org/officeDocument/2006/relationships">
+<p:sld xmlns:a="http://schemas.openxmlformats.org/drawingml/2006/main" xmlns:r="http://schemas.openxmlformats.org/officeDocument/2006/relationships" xmlns:p="http://schemas.openxmlformats.org/presentationml/2006/main">
   <p:cSld>
     <p:bg>
       <p:bgPr>
@@ -4671,7 +4747,14 @@
         <p:cNvGrpSpPr/>
         <p:nvPr/>
       </p:nvGrpSpPr>
-      <p:grpSpPr/>
+      <p:grpSpPr>
+        <a:xfrm>
+          <a:off x="0" y="0"/>
+          <a:ext cx="0" cy="0"/>
+          <a:chOff x="0" y="0"/>
+          <a:chExt cx="0" cy="0"/>
+        </a:xfrm>
+      </p:grpSpPr>
       <p:sp>
         <p:nvSpPr>
           <p:cNvPr id="2" name="Rectangle 1"/>
@@ -4712,6 +4795,7 @@
           <a:lstStyle/>
           <a:p>
             <a:pPr algn="ctr"/>
+            <a:endParaRPr/>
           </a:p>
         </p:txBody>
       </p:sp>
@@ -4788,6 +4872,7 @@
           <a:lstStyle/>
           <a:p>
             <a:pPr algn="ctr"/>
+            <a:endParaRPr/>
           </a:p>
         </p:txBody>
       </p:sp>
@@ -4814,7 +4899,7 @@
           <a:lstStyle/>
           <a:p>
             <a:r>
-              <a:rPr b="1" sz="1900">
+              <a:rPr sz="1900" b="1">
                 <a:solidFill>
                   <a:srgbClr val="E05A2E"/>
                 </a:solidFill>
@@ -4880,7 +4965,7 @@
           <a:lstStyle/>
           <a:p>
             <a:r>
-              <a:rPr b="1" sz="1900">
+              <a:rPr sz="1900" b="1">
                 <a:solidFill>
                   <a:srgbClr val="E05A2E"/>
                 </a:solidFill>
@@ -4946,7 +5031,7 @@
           <a:lstStyle/>
           <a:p>
             <a:r>
-              <a:rPr b="1" sz="1900">
+              <a:rPr sz="1900" b="1">
                 <a:solidFill>
                   <a:srgbClr val="E05A2E"/>
                 </a:solidFill>
@@ -5012,7 +5097,7 @@
           <a:lstStyle/>
           <a:p>
             <a:r>
-              <a:rPr b="1" sz="1900">
+              <a:rPr sz="1900" b="1">
                 <a:solidFill>
                   <a:srgbClr val="E05A2E"/>
                 </a:solidFill>
@@ -5078,7 +5163,7 @@
           <a:lstStyle/>
           <a:p>
             <a:r>
-              <a:rPr b="1" sz="1900">
+              <a:rPr sz="1900" b="1">
                 <a:solidFill>
                   <a:srgbClr val="E05A2E"/>
                 </a:solidFill>
@@ -5144,7 +5229,7 @@
           <a:lstStyle/>
           <a:p>
             <a:r>
-              <a:rPr b="1" sz="1900">
+              <a:rPr sz="1900" b="1">
                 <a:solidFill>
                   <a:srgbClr val="E05A2E"/>
                 </a:solidFill>
@@ -5196,7 +5281,7 @@
 </file>
 
 <file path=ppt/slides/slide16.xml><?xml version="1.0" encoding="utf-8"?>
-<p:sld xmlns:a="http://schemas.openxmlformats.org/drawingml/2006/main" xmlns:p="http://schemas.openxmlformats.org/presentationml/2006/main" xmlns:r="http://schemas.openxmlformats.org/officeDocument/2006/relationships">
+<p:sld xmlns:a="http://schemas.openxmlformats.org/drawingml/2006/main" xmlns:r="http://schemas.openxmlformats.org/officeDocument/2006/relationships" xmlns:p="http://schemas.openxmlformats.org/presentationml/2006/main">
   <p:cSld>
     <p:bg>
       <p:bgPr>
@@ -5212,7 +5297,14 @@
         <p:cNvGrpSpPr/>
         <p:nvPr/>
       </p:nvGrpSpPr>
-      <p:grpSpPr/>
+      <p:grpSpPr>
+        <a:xfrm>
+          <a:off x="0" y="0"/>
+          <a:ext cx="0" cy="0"/>
+          <a:chOff x="0" y="0"/>
+          <a:chExt cx="0" cy="0"/>
+        </a:xfrm>
+      </p:grpSpPr>
       <p:sp>
         <p:nvSpPr>
           <p:cNvPr id="2" name="Rectangle 1"/>
@@ -5253,6 +5345,7 @@
           <a:lstStyle/>
           <a:p>
             <a:pPr algn="ctr"/>
+            <a:endParaRPr/>
           </a:p>
         </p:txBody>
       </p:sp>
@@ -5329,6 +5422,7 @@
           <a:lstStyle/>
           <a:p>
             <a:pPr algn="ctr"/>
+            <a:endParaRPr/>
           </a:p>
         </p:txBody>
       </p:sp>
@@ -5456,7 +5550,7 @@
 </file>
 
 <file path=ppt/slides/slide17.xml><?xml version="1.0" encoding="utf-8"?>
-<p:sld xmlns:a="http://schemas.openxmlformats.org/drawingml/2006/main" xmlns:p="http://schemas.openxmlformats.org/presentationml/2006/main" xmlns:r="http://schemas.openxmlformats.org/officeDocument/2006/relationships">
+<p:sld xmlns:a="http://schemas.openxmlformats.org/drawingml/2006/main" xmlns:r="http://schemas.openxmlformats.org/officeDocument/2006/relationships" xmlns:p="http://schemas.openxmlformats.org/presentationml/2006/main">
   <p:cSld>
     <p:bg>
       <p:bgPr>
@@ -5472,7 +5566,14 @@
         <p:cNvGrpSpPr/>
         <p:nvPr/>
       </p:nvGrpSpPr>
-      <p:grpSpPr/>
+      <p:grpSpPr>
+        <a:xfrm>
+          <a:off x="0" y="0"/>
+          <a:ext cx="0" cy="0"/>
+          <a:chOff x="0" y="0"/>
+          <a:chExt cx="0" cy="0"/>
+        </a:xfrm>
+      </p:grpSpPr>
       <p:sp>
         <p:nvSpPr>
           <p:cNvPr id="2" name="Rectangle 1"/>
@@ -5513,6 +5614,7 @@
           <a:lstStyle/>
           <a:p>
             <a:pPr algn="ctr"/>
+            <a:endParaRPr/>
           </a:p>
         </p:txBody>
       </p:sp>
@@ -5589,6 +5691,7 @@
           <a:lstStyle/>
           <a:p>
             <a:pPr algn="ctr"/>
+            <a:endParaRPr/>
           </a:p>
         </p:txBody>
       </p:sp>
@@ -5601,7 +5704,7 @@
         <p:spPr>
           <a:xfrm>
             <a:off x="685800" y="1645920"/>
-            <a:ext cx="10607040" cy="3931920"/>
+            <a:ext cx="10607040" cy="1066959"/>
           </a:xfrm>
           <a:prstGeom prst="rect">
             <a:avLst/>
@@ -5620,15 +5723,15 @@
               </a:spcAft>
             </a:pPr>
             <a:r>
-              <a:rPr sz="2500" b="1">
+              <a:rPr sz="2500" b="1" dirty="0">
                 <a:solidFill>
                   <a:srgbClr val="E05A2E"/>
                 </a:solidFill>
               </a:rPr>
-              <a:t>●  [Name]</a:t>
-            </a:r>
-            <a:r>
-              <a:rPr sz="2500" b="0">
+              <a:t>●  Cesar Salcido</a:t>
+            </a:r>
+            <a:r>
+              <a:rPr sz="2500" b="0" dirty="0">
                 <a:solidFill>
                   <a:srgbClr val="14182B"/>
                 </a:solidFill>
@@ -5643,43 +5746,28 @@
               </a:spcAft>
             </a:pPr>
             <a:r>
-              <a:rPr sz="2500" b="1">
+              <a:rPr sz="2500" b="1" dirty="0">
                 <a:solidFill>
                   <a:srgbClr val="E05A2E"/>
                 </a:solidFill>
               </a:rPr>
-              <a:t>●  [Name]</a:t>
-            </a:r>
-            <a:r>
-              <a:rPr sz="2500" b="0">
+              <a:t>●  Daniel Silva</a:t>
+            </a:r>
+            <a:r>
+              <a:rPr lang="en-US" sz="2500" b="1" dirty="0">
+                <a:solidFill>
+                  <a:srgbClr val="E05A2E"/>
+                </a:solidFill>
+              </a:rPr>
+              <a:t>s</a:t>
+            </a:r>
+            <a:r>
+              <a:rPr sz="2500" b="0" dirty="0">
                 <a:solidFill>
                   <a:srgbClr val="14182B"/>
                 </a:solidFill>
               </a:rPr>
               <a:t>  — Desktop app GUI + Unity Editor package</a:t>
-            </a:r>
-          </a:p>
-          <a:p>
-            <a:pPr>
-              <a:spcAft>
-                <a:spcPts val="1600"/>
-              </a:spcAft>
-            </a:pPr>
-            <a:r>
-              <a:rPr sz="2500" b="1">
-                <a:solidFill>
-                  <a:srgbClr val="E05A2E"/>
-                </a:solidFill>
-              </a:rPr>
-              <a:t>●  [Name]</a:t>
-            </a:r>
-            <a:r>
-              <a:rPr sz="2500" b="0">
-                <a:solidFill>
-                  <a:srgbClr val="14182B"/>
-                </a:solidFill>
-              </a:rPr>
-              <a:t>  — Classifier + hardware/mapping integration (if 3rd member)</a:t>
             </a:r>
           </a:p>
         </p:txBody>
@@ -5693,7 +5781,7 @@
 </file>
 
 <file path=ppt/slides/slide18.xml><?xml version="1.0" encoding="utf-8"?>
-<p:sld xmlns:a="http://schemas.openxmlformats.org/drawingml/2006/main" xmlns:p="http://schemas.openxmlformats.org/presentationml/2006/main" xmlns:r="http://schemas.openxmlformats.org/officeDocument/2006/relationships">
+<p:sld xmlns:a="http://schemas.openxmlformats.org/drawingml/2006/main" xmlns:r="http://schemas.openxmlformats.org/officeDocument/2006/relationships" xmlns:p="http://schemas.openxmlformats.org/presentationml/2006/main">
   <p:cSld>
     <p:bg>
       <p:bgPr>
@@ -5709,7 +5797,14 @@
         <p:cNvGrpSpPr/>
         <p:nvPr/>
       </p:nvGrpSpPr>
-      <p:grpSpPr/>
+      <p:grpSpPr>
+        <a:xfrm>
+          <a:off x="0" y="0"/>
+          <a:ext cx="0" cy="0"/>
+          <a:chOff x="0" y="0"/>
+          <a:chExt cx="0" cy="0"/>
+        </a:xfrm>
+      </p:grpSpPr>
       <p:sp>
         <p:nvSpPr>
           <p:cNvPr id="2" name="TextBox 1"/>
@@ -5785,7 +5880,7 @@
 </file>
 
 <file path=ppt/slides/slide2.xml><?xml version="1.0" encoding="utf-8"?>
-<p:sld xmlns:a="http://schemas.openxmlformats.org/drawingml/2006/main" xmlns:p="http://schemas.openxmlformats.org/presentationml/2006/main" xmlns:r="http://schemas.openxmlformats.org/officeDocument/2006/relationships">
+<p:sld xmlns:a="http://schemas.openxmlformats.org/drawingml/2006/main" xmlns:r="http://schemas.openxmlformats.org/officeDocument/2006/relationships" xmlns:p="http://schemas.openxmlformats.org/presentationml/2006/main">
   <p:cSld>
     <p:bg>
       <p:bgPr>
@@ -5801,7 +5896,14 @@
         <p:cNvGrpSpPr/>
         <p:nvPr/>
       </p:nvGrpSpPr>
-      <p:grpSpPr/>
+      <p:grpSpPr>
+        <a:xfrm>
+          <a:off x="0" y="0"/>
+          <a:ext cx="0" cy="0"/>
+          <a:chOff x="0" y="0"/>
+          <a:chExt cx="0" cy="0"/>
+        </a:xfrm>
+      </p:grpSpPr>
       <p:sp>
         <p:nvSpPr>
           <p:cNvPr id="2" name="Rectangle 1"/>
@@ -5842,6 +5944,7 @@
           <a:lstStyle/>
           <a:p>
             <a:pPr algn="ctr"/>
+            <a:endParaRPr/>
           </a:p>
         </p:txBody>
       </p:sp>
@@ -5918,6 +6021,7 @@
           <a:lstStyle/>
           <a:p>
             <a:pPr algn="ctr"/>
+            <a:endParaRPr/>
           </a:p>
         </p:txBody>
       </p:sp>
@@ -6045,7 +6149,7 @@
 </file>
 
 <file path=ppt/slides/slide3.xml><?xml version="1.0" encoding="utf-8"?>
-<p:sld xmlns:a="http://schemas.openxmlformats.org/drawingml/2006/main" xmlns:p="http://schemas.openxmlformats.org/presentationml/2006/main" xmlns:r="http://schemas.openxmlformats.org/officeDocument/2006/relationships">
+<p:sld xmlns:a="http://schemas.openxmlformats.org/drawingml/2006/main" xmlns:r="http://schemas.openxmlformats.org/officeDocument/2006/relationships" xmlns:p="http://schemas.openxmlformats.org/presentationml/2006/main">
   <p:cSld>
     <p:bg>
       <p:bgPr>
@@ -6061,7 +6165,14 @@
         <p:cNvGrpSpPr/>
         <p:nvPr/>
       </p:nvGrpSpPr>
-      <p:grpSpPr/>
+      <p:grpSpPr>
+        <a:xfrm>
+          <a:off x="0" y="0"/>
+          <a:ext cx="0" cy="0"/>
+          <a:chOff x="0" y="0"/>
+          <a:chExt cx="0" cy="0"/>
+        </a:xfrm>
+      </p:grpSpPr>
       <p:sp>
         <p:nvSpPr>
           <p:cNvPr id="2" name="Rectangle 1"/>
@@ -6102,6 +6213,7 @@
           <a:lstStyle/>
           <a:p>
             <a:pPr algn="ctr"/>
+            <a:endParaRPr/>
           </a:p>
         </p:txBody>
       </p:sp>
@@ -6178,6 +6290,7 @@
           <a:lstStyle/>
           <a:p>
             <a:pPr algn="ctr"/>
+            <a:endParaRPr/>
           </a:p>
         </p:txBody>
       </p:sp>
@@ -6282,7 +6395,7 @@
 </file>
 
 <file path=ppt/slides/slide4.xml><?xml version="1.0" encoding="utf-8"?>
-<p:sld xmlns:a="http://schemas.openxmlformats.org/drawingml/2006/main" xmlns:p="http://schemas.openxmlformats.org/presentationml/2006/main" xmlns:r="http://schemas.openxmlformats.org/officeDocument/2006/relationships">
+<p:sld xmlns:a="http://schemas.openxmlformats.org/drawingml/2006/main" xmlns:r="http://schemas.openxmlformats.org/officeDocument/2006/relationships" xmlns:p="http://schemas.openxmlformats.org/presentationml/2006/main">
   <p:cSld>
     <p:bg>
       <p:bgPr>
@@ -6298,7 +6411,14 @@
         <p:cNvGrpSpPr/>
         <p:nvPr/>
       </p:nvGrpSpPr>
-      <p:grpSpPr/>
+      <p:grpSpPr>
+        <a:xfrm>
+          <a:off x="0" y="0"/>
+          <a:ext cx="0" cy="0"/>
+          <a:chOff x="0" y="0"/>
+          <a:chExt cx="0" cy="0"/>
+        </a:xfrm>
+      </p:grpSpPr>
       <p:sp>
         <p:nvSpPr>
           <p:cNvPr id="2" name="Rectangle 1"/>
@@ -6339,6 +6459,7 @@
           <a:lstStyle/>
           <a:p>
             <a:pPr algn="ctr"/>
+            <a:endParaRPr/>
           </a:p>
         </p:txBody>
       </p:sp>
@@ -6417,7 +6538,7 @@
 </file>
 
 <file path=ppt/slides/slide5.xml><?xml version="1.0" encoding="utf-8"?>
-<p:sld xmlns:a="http://schemas.openxmlformats.org/drawingml/2006/main" xmlns:p="http://schemas.openxmlformats.org/presentationml/2006/main" xmlns:r="http://schemas.openxmlformats.org/officeDocument/2006/relationships">
+<p:sld xmlns:a="http://schemas.openxmlformats.org/drawingml/2006/main" xmlns:r="http://schemas.openxmlformats.org/officeDocument/2006/relationships" xmlns:p="http://schemas.openxmlformats.org/presentationml/2006/main">
   <p:cSld>
     <p:bg>
       <p:bgPr>
@@ -6433,7 +6554,14 @@
         <p:cNvGrpSpPr/>
         <p:nvPr/>
       </p:nvGrpSpPr>
-      <p:grpSpPr/>
+      <p:grpSpPr>
+        <a:xfrm>
+          <a:off x="0" y="0"/>
+          <a:ext cx="0" cy="0"/>
+          <a:chOff x="0" y="0"/>
+          <a:chExt cx="0" cy="0"/>
+        </a:xfrm>
+      </p:grpSpPr>
       <p:sp>
         <p:nvSpPr>
           <p:cNvPr id="2" name="Rectangle 1"/>
@@ -6474,6 +6602,7 @@
           <a:lstStyle/>
           <a:p>
             <a:pPr algn="ctr"/>
+            <a:endParaRPr/>
           </a:p>
         </p:txBody>
       </p:sp>
@@ -6550,6 +6679,7 @@
           <a:lstStyle/>
           <a:p>
             <a:pPr algn="ctr"/>
+            <a:endParaRPr/>
           </a:p>
         </p:txBody>
       </p:sp>
@@ -6654,7 +6784,7 @@
 </file>
 
 <file path=ppt/slides/slide6.xml><?xml version="1.0" encoding="utf-8"?>
-<p:sld xmlns:a="http://schemas.openxmlformats.org/drawingml/2006/main" xmlns:p="http://schemas.openxmlformats.org/presentationml/2006/main" xmlns:r="http://schemas.openxmlformats.org/officeDocument/2006/relationships">
+<p:sld xmlns:a="http://schemas.openxmlformats.org/drawingml/2006/main" xmlns:r="http://schemas.openxmlformats.org/officeDocument/2006/relationships" xmlns:p="http://schemas.openxmlformats.org/presentationml/2006/main">
   <p:cSld>
     <p:bg>
       <p:bgPr>
@@ -6670,7 +6800,14 @@
         <p:cNvGrpSpPr/>
         <p:nvPr/>
       </p:nvGrpSpPr>
-      <p:grpSpPr/>
+      <p:grpSpPr>
+        <a:xfrm>
+          <a:off x="0" y="0"/>
+          <a:ext cx="0" cy="0"/>
+          <a:chOff x="0" y="0"/>
+          <a:chExt cx="0" cy="0"/>
+        </a:xfrm>
+      </p:grpSpPr>
       <p:sp>
         <p:nvSpPr>
           <p:cNvPr id="2" name="Rectangle 1"/>
@@ -6711,6 +6848,7 @@
           <a:lstStyle/>
           <a:p>
             <a:pPr algn="ctr"/>
+            <a:endParaRPr/>
           </a:p>
         </p:txBody>
       </p:sp>
@@ -6787,6 +6925,7 @@
           <a:lstStyle/>
           <a:p>
             <a:pPr algn="ctr"/>
+            <a:endParaRPr/>
           </a:p>
         </p:txBody>
       </p:sp>
@@ -6914,7 +7053,7 @@
 </file>
 
 <file path=ppt/slides/slide7.xml><?xml version="1.0" encoding="utf-8"?>
-<p:sld xmlns:a="http://schemas.openxmlformats.org/drawingml/2006/main" xmlns:p="http://schemas.openxmlformats.org/presentationml/2006/main" xmlns:r="http://schemas.openxmlformats.org/officeDocument/2006/relationships">
+<p:sld xmlns:a="http://schemas.openxmlformats.org/drawingml/2006/main" xmlns:r="http://schemas.openxmlformats.org/officeDocument/2006/relationships" xmlns:p="http://schemas.openxmlformats.org/presentationml/2006/main">
   <p:cSld>
     <p:bg>
       <p:bgPr>
@@ -6930,7 +7069,14 @@
         <p:cNvGrpSpPr/>
         <p:nvPr/>
       </p:nvGrpSpPr>
-      <p:grpSpPr/>
+      <p:grpSpPr>
+        <a:xfrm>
+          <a:off x="0" y="0"/>
+          <a:ext cx="0" cy="0"/>
+          <a:chOff x="0" y="0"/>
+          <a:chExt cx="0" cy="0"/>
+        </a:xfrm>
+      </p:grpSpPr>
       <p:sp>
         <p:nvSpPr>
           <p:cNvPr id="2" name="Rectangle 1"/>
@@ -6971,6 +7117,7 @@
           <a:lstStyle/>
           <a:p>
             <a:pPr algn="ctr"/>
+            <a:endParaRPr/>
           </a:p>
         </p:txBody>
       </p:sp>
@@ -7047,6 +7194,7 @@
           <a:lstStyle/>
           <a:p>
             <a:pPr algn="ctr"/>
+            <a:endParaRPr/>
           </a:p>
         </p:txBody>
       </p:sp>
@@ -7174,7 +7322,7 @@
 </file>
 
 <file path=ppt/slides/slide8.xml><?xml version="1.0" encoding="utf-8"?>
-<p:sld xmlns:a="http://schemas.openxmlformats.org/drawingml/2006/main" xmlns:p="http://schemas.openxmlformats.org/presentationml/2006/main" xmlns:r="http://schemas.openxmlformats.org/officeDocument/2006/relationships">
+<p:sld xmlns:a="http://schemas.openxmlformats.org/drawingml/2006/main" xmlns:r="http://schemas.openxmlformats.org/officeDocument/2006/relationships" xmlns:p="http://schemas.openxmlformats.org/presentationml/2006/main">
   <p:cSld>
     <p:bg>
       <p:bgPr>
@@ -7190,7 +7338,14 @@
         <p:cNvGrpSpPr/>
         <p:nvPr/>
       </p:nvGrpSpPr>
-      <p:grpSpPr/>
+      <p:grpSpPr>
+        <a:xfrm>
+          <a:off x="0" y="0"/>
+          <a:ext cx="0" cy="0"/>
+          <a:chOff x="0" y="0"/>
+          <a:chExt cx="0" cy="0"/>
+        </a:xfrm>
+      </p:grpSpPr>
       <p:sp>
         <p:nvSpPr>
           <p:cNvPr id="2" name="Rectangle 1"/>
@@ -7231,6 +7386,7 @@
           <a:lstStyle/>
           <a:p>
             <a:pPr algn="ctr"/>
+            <a:endParaRPr/>
           </a:p>
         </p:txBody>
       </p:sp>
@@ -7307,6 +7463,7 @@
           <a:lstStyle/>
           <a:p>
             <a:pPr algn="ctr"/>
+            <a:endParaRPr/>
           </a:p>
         </p:txBody>
       </p:sp>
@@ -7434,7 +7591,7 @@
 </file>
 
 <file path=ppt/slides/slide9.xml><?xml version="1.0" encoding="utf-8"?>
-<p:sld xmlns:a="http://schemas.openxmlformats.org/drawingml/2006/main" xmlns:p="http://schemas.openxmlformats.org/presentationml/2006/main" xmlns:r="http://schemas.openxmlformats.org/officeDocument/2006/relationships">
+<p:sld xmlns:a="http://schemas.openxmlformats.org/drawingml/2006/main" xmlns:r="http://schemas.openxmlformats.org/officeDocument/2006/relationships" xmlns:p="http://schemas.openxmlformats.org/presentationml/2006/main">
   <p:cSld>
     <p:bg>
       <p:bgPr>
@@ -7450,7 +7607,14 @@
         <p:cNvGrpSpPr/>
         <p:nvPr/>
       </p:nvGrpSpPr>
-      <p:grpSpPr/>
+      <p:grpSpPr>
+        <a:xfrm>
+          <a:off x="0" y="0"/>
+          <a:ext cx="0" cy="0"/>
+          <a:chOff x="0" y="0"/>
+          <a:chExt cx="0" cy="0"/>
+        </a:xfrm>
+      </p:grpSpPr>
       <p:sp>
         <p:nvSpPr>
           <p:cNvPr id="2" name="Rectangle 1"/>
@@ -7491,6 +7655,7 @@
           <a:lstStyle/>
           <a:p>
             <a:pPr algn="ctr"/>
+            <a:endParaRPr/>
           </a:p>
         </p:txBody>
       </p:sp>
@@ -7567,6 +7732,7 @@
           <a:lstStyle/>
           <a:p>
             <a:pPr algn="ctr"/>
+            <a:endParaRPr/>
           </a:p>
         </p:txBody>
       </p:sp>
@@ -7685,7 +7851,7 @@
           <a:lstStyle/>
           <a:p>
             <a:r>
-              <a:rPr sz="1400" i="1" b="1">
+              <a:rPr sz="1400" b="1" i="1">
                 <a:solidFill>
                   <a:srgbClr val="993300"/>
                 </a:solidFill>

</xml_diff>

<commit_message>
Add Meshy efficiency/benchmark slide to presentation
</commit_message>
<xml_diff>
--- a/presentation.pptx
+++ b/presentation.pptx
@@ -5,26 +5,27 @@
     <p:sldMasterId id="2147483648" r:id="rId1"/>
   </p:sldMasterIdLst>
   <p:sldIdLst>
-    <p:sldId id="256" r:id="rId2"/>
-    <p:sldId id="257" r:id="rId3"/>
-    <p:sldId id="258" r:id="rId4"/>
-    <p:sldId id="259" r:id="rId5"/>
-    <p:sldId id="260" r:id="rId6"/>
-    <p:sldId id="261" r:id="rId7"/>
-    <p:sldId id="262" r:id="rId8"/>
-    <p:sldId id="263" r:id="rId9"/>
-    <p:sldId id="264" r:id="rId10"/>
-    <p:sldId id="265" r:id="rId11"/>
-    <p:sldId id="266" r:id="rId12"/>
-    <p:sldId id="267" r:id="rId13"/>
-    <p:sldId id="268" r:id="rId14"/>
-    <p:sldId id="269" r:id="rId15"/>
-    <p:sldId id="270" r:id="rId16"/>
-    <p:sldId id="271" r:id="rId17"/>
-    <p:sldId id="272" r:id="rId18"/>
-    <p:sldId id="273" r:id="rId19"/>
+    <p:sldId id="256" r:id="rId7"/>
+    <p:sldId id="257" r:id="rId8"/>
+    <p:sldId id="258" r:id="rId9"/>
+    <p:sldId id="259" r:id="rId10"/>
+    <p:sldId id="260" r:id="rId11"/>
+    <p:sldId id="261" r:id="rId12"/>
+    <p:sldId id="262" r:id="rId13"/>
+    <p:sldId id="263" r:id="rId14"/>
+    <p:sldId id="264" r:id="rId15"/>
+    <p:sldId id="265" r:id="rId16"/>
+    <p:sldId id="266" r:id="rId17"/>
+    <p:sldId id="267" r:id="rId18"/>
+    <p:sldId id="268" r:id="rId19"/>
+    <p:sldId id="269" r:id="rId20"/>
+    <p:sldId id="270" r:id="rId21"/>
+    <p:sldId id="271" r:id="rId22"/>
+    <p:sldId id="272" r:id="rId23"/>
+    <p:sldId id="273" r:id="rId24"/>
+    <p:sldId id="274" r:id="rId25"/>
   </p:sldIdLst>
-  <p:sldSz cx="12192000" cy="6858000"/>
+  <p:sldSz cx="12191695" cy="6858000" type="screen4x3"/>
   <p:notesSz cx="6858000" cy="9144000"/>
   <p:defaultTextStyle>
     <a:defPPr>
@@ -121,52 +122,7 @@
       </a:defRPr>
     </a:lvl9pPr>
   </p:defaultTextStyle>
-  <p:extLst>
-    <p:ext uri="{EFAFB233-063F-42B5-8137-9DF3F51BA10A}">
-      <p15:sldGuideLst xmlns:p15="http://schemas.microsoft.com/office/powerpoint/2012/main">
-        <p15:guide id="1" orient="horz" pos="2160">
-          <p15:clr>
-            <a:srgbClr val="A4A3A4"/>
-          </p15:clr>
-        </p15:guide>
-        <p15:guide id="2" pos="2880">
-          <p15:clr>
-            <a:srgbClr val="A4A3A4"/>
-          </p15:clr>
-        </p15:guide>
-      </p15:sldGuideLst>
-    </p:ext>
-  </p:extLst>
 </p:presentation>
-</file>
-
-<file path=ppt/changesInfos/changesInfo1.xml><?xml version="1.0" encoding="utf-8"?>
-<pc:chgInfo xmlns:a="http://schemas.openxmlformats.org/drawingml/2006/main" xmlns:r="http://schemas.openxmlformats.org/officeDocument/2006/relationships" xmlns:ac="http://schemas.microsoft.com/office/drawing/2013/main/command" xmlns:pc="http://schemas.microsoft.com/office/powerpoint/2013/main/command">
-  <pc:docChgLst>
-    <pc:chgData name="Salcido O'ferra, Cesar" userId="9d6d544b-1422-4a76-8f1b-6459aa5ae530" providerId="ADAL" clId="{EB7CE27A-5EC2-5202-99F6-B24EC35CCE99}"/>
-    <pc:docChg chg="modSld">
-      <pc:chgData name="Salcido O'ferra, Cesar" userId="9d6d544b-1422-4a76-8f1b-6459aa5ae530" providerId="ADAL" clId="{EB7CE27A-5EC2-5202-99F6-B24EC35CCE99}" dt="2026-09-25T18:59:02.872" v="1" actId="20577"/>
-      <pc:docMkLst>
-        <pc:docMk/>
-      </pc:docMkLst>
-      <pc:sldChg chg="modSp mod">
-        <pc:chgData name="Salcido O'ferra, Cesar" userId="9d6d544b-1422-4a76-8f1b-6459aa5ae530" providerId="ADAL" clId="{EB7CE27A-5EC2-5202-99F6-B24EC35CCE99}" dt="2026-09-25T18:59:02.872" v="1" actId="20577"/>
-        <pc:sldMkLst>
-          <pc:docMk/>
-          <pc:sldMk cId="0" sldId="272"/>
-        </pc:sldMkLst>
-        <pc:spChg chg="mod">
-          <ac:chgData name="Salcido O'ferra, Cesar" userId="9d6d544b-1422-4a76-8f1b-6459aa5ae530" providerId="ADAL" clId="{EB7CE27A-5EC2-5202-99F6-B24EC35CCE99}" dt="2026-09-25T18:59:02.872" v="1" actId="20577"/>
-          <ac:spMkLst>
-            <pc:docMk/>
-            <pc:sldMk cId="0" sldId="272"/>
-            <ac:spMk id="5" creationId="{00000000-0000-0000-0000-000000000000}"/>
-          </ac:spMkLst>
-        </pc:spChg>
-      </pc:sldChg>
-    </pc:docChg>
-  </pc:docChgLst>
-</pc:chgInfo>
 </file>
 
 <file path=ppt/slideLayouts/slideLayout1.xml><?xml version="1.0" encoding="utf-8"?>
@@ -207,9 +163,10 @@
           <a:lstStyle/>
           <a:p>
             <a:r>
-              <a:rPr lang="en-US"/>
+              <a:rPr lang="en-US" smtClean="0"/>
               <a:t>Click to edit Master title style</a:t>
             </a:r>
+            <a:endParaRPr lang="en-US"/>
           </a:p>
         </p:txBody>
       </p:sp>
@@ -325,9 +282,10 @@
           </a:lstStyle>
           <a:p>
             <a:r>
-              <a:rPr lang="en-US"/>
+              <a:rPr lang="en-US" smtClean="0"/>
               <a:t>Click to edit Master subtitle style</a:t>
             </a:r>
+            <a:endParaRPr lang="en-US"/>
           </a:p>
         </p:txBody>
       </p:sp>
@@ -348,7 +306,7 @@
           <a:p>
             <a:fld id="{5BCAD085-E8A6-8845-BD4E-CB4CCA059FC4}" type="datetimeFigureOut">
               <a:rPr lang="en-US" smtClean="0"/>
-              <a:t>9/25/26</a:t>
+              <a:t>1/27/13</a:t>
             </a:fld>
             <a:endParaRPr lang="en-US"/>
           </a:p>
@@ -442,9 +400,10 @@
           <a:lstStyle/>
           <a:p>
             <a:r>
-              <a:rPr lang="en-US"/>
+              <a:rPr lang="en-US" smtClean="0"/>
               <a:t>Click to edit Master title style</a:t>
             </a:r>
+            <a:endParaRPr lang="en-US"/>
           </a:p>
         </p:txBody>
       </p:sp>
@@ -465,37 +424,38 @@
           <a:p>
             <a:pPr lvl="0"/>
             <a:r>
-              <a:rPr lang="en-US"/>
+              <a:rPr lang="en-US" smtClean="0"/>
               <a:t>Click to edit Master text styles</a:t>
             </a:r>
           </a:p>
           <a:p>
             <a:pPr lvl="1"/>
             <a:r>
-              <a:rPr lang="en-US"/>
+              <a:rPr lang="en-US" smtClean="0"/>
               <a:t>Second level</a:t>
             </a:r>
           </a:p>
           <a:p>
             <a:pPr lvl="2"/>
             <a:r>
-              <a:rPr lang="en-US"/>
+              <a:rPr lang="en-US" smtClean="0"/>
               <a:t>Third level</a:t>
             </a:r>
           </a:p>
           <a:p>
             <a:pPr lvl="3"/>
             <a:r>
-              <a:rPr lang="en-US"/>
+              <a:rPr lang="en-US" smtClean="0"/>
               <a:t>Fourth level</a:t>
             </a:r>
           </a:p>
           <a:p>
             <a:pPr lvl="4"/>
             <a:r>
-              <a:rPr lang="en-US"/>
+              <a:rPr lang="en-US" smtClean="0"/>
               <a:t>Fifth level</a:t>
             </a:r>
+            <a:endParaRPr lang="en-US"/>
           </a:p>
         </p:txBody>
       </p:sp>
@@ -516,7 +476,7 @@
           <a:p>
             <a:fld id="{5BCAD085-E8A6-8845-BD4E-CB4CCA059FC4}" type="datetimeFigureOut">
               <a:rPr lang="en-US" smtClean="0"/>
-              <a:t>9/25/26</a:t>
+              <a:t>1/27/13</a:t>
             </a:fld>
             <a:endParaRPr lang="en-US"/>
           </a:p>
@@ -615,9 +575,10 @@
           <a:lstStyle/>
           <a:p>
             <a:r>
-              <a:rPr lang="en-US"/>
+              <a:rPr lang="en-US" smtClean="0"/>
               <a:t>Click to edit Master title style</a:t>
             </a:r>
+            <a:endParaRPr lang="en-US"/>
           </a:p>
         </p:txBody>
       </p:sp>
@@ -643,37 +604,38 @@
           <a:p>
             <a:pPr lvl="0"/>
             <a:r>
-              <a:rPr lang="en-US"/>
+              <a:rPr lang="en-US" smtClean="0"/>
               <a:t>Click to edit Master text styles</a:t>
             </a:r>
           </a:p>
           <a:p>
             <a:pPr lvl="1"/>
             <a:r>
-              <a:rPr lang="en-US"/>
+              <a:rPr lang="en-US" smtClean="0"/>
               <a:t>Second level</a:t>
             </a:r>
           </a:p>
           <a:p>
             <a:pPr lvl="2"/>
             <a:r>
-              <a:rPr lang="en-US"/>
+              <a:rPr lang="en-US" smtClean="0"/>
               <a:t>Third level</a:t>
             </a:r>
           </a:p>
           <a:p>
             <a:pPr lvl="3"/>
             <a:r>
-              <a:rPr lang="en-US"/>
+              <a:rPr lang="en-US" smtClean="0"/>
               <a:t>Fourth level</a:t>
             </a:r>
           </a:p>
           <a:p>
             <a:pPr lvl="4"/>
             <a:r>
-              <a:rPr lang="en-US"/>
+              <a:rPr lang="en-US" smtClean="0"/>
               <a:t>Fifth level</a:t>
             </a:r>
+            <a:endParaRPr lang="en-US"/>
           </a:p>
         </p:txBody>
       </p:sp>
@@ -694,7 +656,7 @@
           <a:p>
             <a:fld id="{5BCAD085-E8A6-8845-BD4E-CB4CCA059FC4}" type="datetimeFigureOut">
               <a:rPr lang="en-US" smtClean="0"/>
-              <a:t>9/25/26</a:t>
+              <a:t>1/27/13</a:t>
             </a:fld>
             <a:endParaRPr lang="en-US"/>
           </a:p>
@@ -788,9 +750,10 @@
           <a:lstStyle/>
           <a:p>
             <a:r>
-              <a:rPr lang="en-US"/>
+              <a:rPr lang="en-US" smtClean="0"/>
               <a:t>Click to edit Master title style</a:t>
             </a:r>
+            <a:endParaRPr lang="en-US"/>
           </a:p>
         </p:txBody>
       </p:sp>
@@ -811,37 +774,38 @@
           <a:p>
             <a:pPr lvl="0"/>
             <a:r>
-              <a:rPr lang="en-US"/>
+              <a:rPr lang="en-US" smtClean="0"/>
               <a:t>Click to edit Master text styles</a:t>
             </a:r>
           </a:p>
           <a:p>
             <a:pPr lvl="1"/>
             <a:r>
-              <a:rPr lang="en-US"/>
+              <a:rPr lang="en-US" smtClean="0"/>
               <a:t>Second level</a:t>
             </a:r>
           </a:p>
           <a:p>
             <a:pPr lvl="2"/>
             <a:r>
-              <a:rPr lang="en-US"/>
+              <a:rPr lang="en-US" smtClean="0"/>
               <a:t>Third level</a:t>
             </a:r>
           </a:p>
           <a:p>
             <a:pPr lvl="3"/>
             <a:r>
-              <a:rPr lang="en-US"/>
+              <a:rPr lang="en-US" smtClean="0"/>
               <a:t>Fourth level</a:t>
             </a:r>
           </a:p>
           <a:p>
             <a:pPr lvl="4"/>
             <a:r>
-              <a:rPr lang="en-US"/>
+              <a:rPr lang="en-US" smtClean="0"/>
               <a:t>Fifth level</a:t>
             </a:r>
+            <a:endParaRPr lang="en-US"/>
           </a:p>
         </p:txBody>
       </p:sp>
@@ -862,7 +826,7 @@
           <a:p>
             <a:fld id="{5BCAD085-E8A6-8845-BD4E-CB4CCA059FC4}" type="datetimeFigureOut">
               <a:rPr lang="en-US" smtClean="0"/>
-              <a:t>9/25/26</a:t>
+              <a:t>1/27/13</a:t>
             </a:fld>
             <a:endParaRPr lang="en-US"/>
           </a:p>
@@ -965,9 +929,10 @@
           </a:lstStyle>
           <a:p>
             <a:r>
-              <a:rPr lang="en-US"/>
+              <a:rPr lang="en-US" smtClean="0"/>
               <a:t>Click to edit Master title style</a:t>
             </a:r>
+            <a:endParaRPr lang="en-US"/>
           </a:p>
         </p:txBody>
       </p:sp>
@@ -1084,7 +1049,7 @@
           <a:p>
             <a:pPr lvl="0"/>
             <a:r>
-              <a:rPr lang="en-US"/>
+              <a:rPr lang="en-US" smtClean="0"/>
               <a:t>Click to edit Master text styles</a:t>
             </a:r>
           </a:p>
@@ -1107,7 +1072,7 @@
           <a:p>
             <a:fld id="{5BCAD085-E8A6-8845-BD4E-CB4CCA059FC4}" type="datetimeFigureOut">
               <a:rPr lang="en-US" smtClean="0"/>
-              <a:t>9/25/26</a:t>
+              <a:t>1/27/13</a:t>
             </a:fld>
             <a:endParaRPr lang="en-US"/>
           </a:p>
@@ -1201,9 +1166,10 @@
           <a:lstStyle/>
           <a:p>
             <a:r>
-              <a:rPr lang="en-US"/>
+              <a:rPr lang="en-US" smtClean="0"/>
               <a:t>Click to edit Master title style</a:t>
             </a:r>
+            <a:endParaRPr lang="en-US"/>
           </a:p>
         </p:txBody>
       </p:sp>
@@ -1257,37 +1223,38 @@
           <a:p>
             <a:pPr lvl="0"/>
             <a:r>
-              <a:rPr lang="en-US"/>
+              <a:rPr lang="en-US" smtClean="0"/>
               <a:t>Click to edit Master text styles</a:t>
             </a:r>
           </a:p>
           <a:p>
             <a:pPr lvl="1"/>
             <a:r>
-              <a:rPr lang="en-US"/>
+              <a:rPr lang="en-US" smtClean="0"/>
               <a:t>Second level</a:t>
             </a:r>
           </a:p>
           <a:p>
             <a:pPr lvl="2"/>
             <a:r>
-              <a:rPr lang="en-US"/>
+              <a:rPr lang="en-US" smtClean="0"/>
               <a:t>Third level</a:t>
             </a:r>
           </a:p>
           <a:p>
             <a:pPr lvl="3"/>
             <a:r>
-              <a:rPr lang="en-US"/>
+              <a:rPr lang="en-US" smtClean="0"/>
               <a:t>Fourth level</a:t>
             </a:r>
           </a:p>
           <a:p>
             <a:pPr lvl="4"/>
             <a:r>
-              <a:rPr lang="en-US"/>
+              <a:rPr lang="en-US" smtClean="0"/>
               <a:t>Fifth level</a:t>
             </a:r>
+            <a:endParaRPr lang="en-US"/>
           </a:p>
         </p:txBody>
       </p:sp>
@@ -1341,37 +1308,38 @@
           <a:p>
             <a:pPr lvl="0"/>
             <a:r>
-              <a:rPr lang="en-US"/>
+              <a:rPr lang="en-US" smtClean="0"/>
               <a:t>Click to edit Master text styles</a:t>
             </a:r>
           </a:p>
           <a:p>
             <a:pPr lvl="1"/>
             <a:r>
-              <a:rPr lang="en-US"/>
+              <a:rPr lang="en-US" smtClean="0"/>
               <a:t>Second level</a:t>
             </a:r>
           </a:p>
           <a:p>
             <a:pPr lvl="2"/>
             <a:r>
-              <a:rPr lang="en-US"/>
+              <a:rPr lang="en-US" smtClean="0"/>
               <a:t>Third level</a:t>
             </a:r>
           </a:p>
           <a:p>
             <a:pPr lvl="3"/>
             <a:r>
-              <a:rPr lang="en-US"/>
+              <a:rPr lang="en-US" smtClean="0"/>
               <a:t>Fourth level</a:t>
             </a:r>
           </a:p>
           <a:p>
             <a:pPr lvl="4"/>
             <a:r>
-              <a:rPr lang="en-US"/>
+              <a:rPr lang="en-US" smtClean="0"/>
               <a:t>Fifth level</a:t>
             </a:r>
+            <a:endParaRPr lang="en-US"/>
           </a:p>
         </p:txBody>
       </p:sp>
@@ -1392,7 +1360,7 @@
           <a:p>
             <a:fld id="{5BCAD085-E8A6-8845-BD4E-CB4CCA059FC4}" type="datetimeFigureOut">
               <a:rPr lang="en-US" smtClean="0"/>
-              <a:t>9/25/26</a:t>
+              <a:t>1/27/13</a:t>
             </a:fld>
             <a:endParaRPr lang="en-US"/>
           </a:p>
@@ -1490,9 +1458,10 @@
           </a:lstStyle>
           <a:p>
             <a:r>
-              <a:rPr lang="en-US"/>
+              <a:rPr lang="en-US" smtClean="0"/>
               <a:t>Click to edit Master title style</a:t>
             </a:r>
+            <a:endParaRPr lang="en-US"/>
           </a:p>
         </p:txBody>
       </p:sp>
@@ -1555,7 +1524,7 @@
           <a:p>
             <a:pPr lvl="0"/>
             <a:r>
-              <a:rPr lang="en-US"/>
+              <a:rPr lang="en-US" smtClean="0"/>
               <a:t>Click to edit Master text styles</a:t>
             </a:r>
           </a:p>
@@ -1611,37 +1580,38 @@
           <a:p>
             <a:pPr lvl="0"/>
             <a:r>
-              <a:rPr lang="en-US"/>
+              <a:rPr lang="en-US" smtClean="0"/>
               <a:t>Click to edit Master text styles</a:t>
             </a:r>
           </a:p>
           <a:p>
             <a:pPr lvl="1"/>
             <a:r>
-              <a:rPr lang="en-US"/>
+              <a:rPr lang="en-US" smtClean="0"/>
               <a:t>Second level</a:t>
             </a:r>
           </a:p>
           <a:p>
             <a:pPr lvl="2"/>
             <a:r>
-              <a:rPr lang="en-US"/>
+              <a:rPr lang="en-US" smtClean="0"/>
               <a:t>Third level</a:t>
             </a:r>
           </a:p>
           <a:p>
             <a:pPr lvl="3"/>
             <a:r>
-              <a:rPr lang="en-US"/>
+              <a:rPr lang="en-US" smtClean="0"/>
               <a:t>Fourth level</a:t>
             </a:r>
           </a:p>
           <a:p>
             <a:pPr lvl="4"/>
             <a:r>
-              <a:rPr lang="en-US"/>
+              <a:rPr lang="en-US" smtClean="0"/>
               <a:t>Fifth level</a:t>
             </a:r>
+            <a:endParaRPr lang="en-US"/>
           </a:p>
         </p:txBody>
       </p:sp>
@@ -1704,7 +1674,7 @@
           <a:p>
             <a:pPr lvl="0"/>
             <a:r>
-              <a:rPr lang="en-US"/>
+              <a:rPr lang="en-US" smtClean="0"/>
               <a:t>Click to edit Master text styles</a:t>
             </a:r>
           </a:p>
@@ -1760,37 +1730,38 @@
           <a:p>
             <a:pPr lvl="0"/>
             <a:r>
-              <a:rPr lang="en-US"/>
+              <a:rPr lang="en-US" smtClean="0"/>
               <a:t>Click to edit Master text styles</a:t>
             </a:r>
           </a:p>
           <a:p>
             <a:pPr lvl="1"/>
             <a:r>
-              <a:rPr lang="en-US"/>
+              <a:rPr lang="en-US" smtClean="0"/>
               <a:t>Second level</a:t>
             </a:r>
           </a:p>
           <a:p>
             <a:pPr lvl="2"/>
             <a:r>
-              <a:rPr lang="en-US"/>
+              <a:rPr lang="en-US" smtClean="0"/>
               <a:t>Third level</a:t>
             </a:r>
           </a:p>
           <a:p>
             <a:pPr lvl="3"/>
             <a:r>
-              <a:rPr lang="en-US"/>
+              <a:rPr lang="en-US" smtClean="0"/>
               <a:t>Fourth level</a:t>
             </a:r>
           </a:p>
           <a:p>
             <a:pPr lvl="4"/>
             <a:r>
-              <a:rPr lang="en-US"/>
+              <a:rPr lang="en-US" smtClean="0"/>
               <a:t>Fifth level</a:t>
             </a:r>
+            <a:endParaRPr lang="en-US"/>
           </a:p>
         </p:txBody>
       </p:sp>
@@ -1811,7 +1782,7 @@
           <a:p>
             <a:fld id="{5BCAD085-E8A6-8845-BD4E-CB4CCA059FC4}" type="datetimeFigureOut">
               <a:rPr lang="en-US" smtClean="0"/>
-              <a:t>9/25/26</a:t>
+              <a:t>1/27/13</a:t>
             </a:fld>
             <a:endParaRPr lang="en-US"/>
           </a:p>
@@ -1905,9 +1876,10 @@
           <a:lstStyle/>
           <a:p>
             <a:r>
-              <a:rPr lang="en-US"/>
+              <a:rPr lang="en-US" smtClean="0"/>
               <a:t>Click to edit Master title style</a:t>
             </a:r>
+            <a:endParaRPr lang="en-US"/>
           </a:p>
         </p:txBody>
       </p:sp>
@@ -1928,7 +1900,7 @@
           <a:p>
             <a:fld id="{5BCAD085-E8A6-8845-BD4E-CB4CCA059FC4}" type="datetimeFigureOut">
               <a:rPr lang="en-US" smtClean="0"/>
-              <a:t>9/25/26</a:t>
+              <a:t>1/27/13</a:t>
             </a:fld>
             <a:endParaRPr lang="en-US"/>
           </a:p>
@@ -2023,7 +1995,7 @@
           <a:p>
             <a:fld id="{5BCAD085-E8A6-8845-BD4E-CB4CCA059FC4}" type="datetimeFigureOut">
               <a:rPr lang="en-US" smtClean="0"/>
-              <a:t>9/25/26</a:t>
+              <a:t>1/27/13</a:t>
             </a:fld>
             <a:endParaRPr lang="en-US"/>
           </a:p>
@@ -2126,9 +2098,10 @@
           </a:lstStyle>
           <a:p>
             <a:r>
-              <a:rPr lang="en-US"/>
+              <a:rPr lang="en-US" smtClean="0"/>
               <a:t>Click to edit Master title style</a:t>
             </a:r>
+            <a:endParaRPr lang="en-US"/>
           </a:p>
         </p:txBody>
       </p:sp>
@@ -2182,37 +2155,38 @@
           <a:p>
             <a:pPr lvl="0"/>
             <a:r>
-              <a:rPr lang="en-US"/>
+              <a:rPr lang="en-US" smtClean="0"/>
               <a:t>Click to edit Master text styles</a:t>
             </a:r>
           </a:p>
           <a:p>
             <a:pPr lvl="1"/>
             <a:r>
-              <a:rPr lang="en-US"/>
+              <a:rPr lang="en-US" smtClean="0"/>
               <a:t>Second level</a:t>
             </a:r>
           </a:p>
           <a:p>
             <a:pPr lvl="2"/>
             <a:r>
-              <a:rPr lang="en-US"/>
+              <a:rPr lang="en-US" smtClean="0"/>
               <a:t>Third level</a:t>
             </a:r>
           </a:p>
           <a:p>
             <a:pPr lvl="3"/>
             <a:r>
-              <a:rPr lang="en-US"/>
+              <a:rPr lang="en-US" smtClean="0"/>
               <a:t>Fourth level</a:t>
             </a:r>
           </a:p>
           <a:p>
             <a:pPr lvl="4"/>
             <a:r>
-              <a:rPr lang="en-US"/>
+              <a:rPr lang="en-US" smtClean="0"/>
               <a:t>Fifth level</a:t>
             </a:r>
+            <a:endParaRPr lang="en-US"/>
           </a:p>
         </p:txBody>
       </p:sp>
@@ -2275,7 +2249,7 @@
           <a:p>
             <a:pPr lvl="0"/>
             <a:r>
-              <a:rPr lang="en-US"/>
+              <a:rPr lang="en-US" smtClean="0"/>
               <a:t>Click to edit Master text styles</a:t>
             </a:r>
           </a:p>
@@ -2298,7 +2272,7 @@
           <a:p>
             <a:fld id="{5BCAD085-E8A6-8845-BD4E-CB4CCA059FC4}" type="datetimeFigureOut">
               <a:rPr lang="en-US" smtClean="0"/>
-              <a:t>9/25/26</a:t>
+              <a:t>1/27/13</a:t>
             </a:fld>
             <a:endParaRPr lang="en-US"/>
           </a:p>
@@ -2401,9 +2375,10 @@
           </a:lstStyle>
           <a:p>
             <a:r>
-              <a:rPr lang="en-US"/>
+              <a:rPr lang="en-US" smtClean="0"/>
               <a:t>Click to edit Master title style</a:t>
             </a:r>
+            <a:endParaRPr lang="en-US"/>
           </a:p>
         </p:txBody>
       </p:sp>
@@ -2527,7 +2502,7 @@
           <a:p>
             <a:pPr lvl="0"/>
             <a:r>
-              <a:rPr lang="en-US"/>
+              <a:rPr lang="en-US" smtClean="0"/>
               <a:t>Click to edit Master text styles</a:t>
             </a:r>
           </a:p>
@@ -2550,7 +2525,7 @@
           <a:p>
             <a:fld id="{5BCAD085-E8A6-8845-BD4E-CB4CCA059FC4}" type="datetimeFigureOut">
               <a:rPr lang="en-US" smtClean="0"/>
-              <a:t>9/25/26</a:t>
+              <a:t>1/27/13</a:t>
             </a:fld>
             <a:endParaRPr lang="en-US"/>
           </a:p>
@@ -2659,9 +2634,10 @@
           <a:lstStyle/>
           <a:p>
             <a:r>
-              <a:rPr lang="en-US"/>
+              <a:rPr lang="en-US" smtClean="0"/>
               <a:t>Click to edit Master title style</a:t>
             </a:r>
+            <a:endParaRPr lang="en-US"/>
           </a:p>
         </p:txBody>
       </p:sp>
@@ -2692,37 +2668,38 @@
           <a:p>
             <a:pPr lvl="0"/>
             <a:r>
-              <a:rPr lang="en-US"/>
+              <a:rPr lang="en-US" smtClean="0"/>
               <a:t>Click to edit Master text styles</a:t>
             </a:r>
           </a:p>
           <a:p>
             <a:pPr lvl="1"/>
             <a:r>
-              <a:rPr lang="en-US"/>
+              <a:rPr lang="en-US" smtClean="0"/>
               <a:t>Second level</a:t>
             </a:r>
           </a:p>
           <a:p>
             <a:pPr lvl="2"/>
             <a:r>
-              <a:rPr lang="en-US"/>
+              <a:rPr lang="en-US" smtClean="0"/>
               <a:t>Third level</a:t>
             </a:r>
           </a:p>
           <a:p>
             <a:pPr lvl="3"/>
             <a:r>
-              <a:rPr lang="en-US"/>
+              <a:rPr lang="en-US" smtClean="0"/>
               <a:t>Fourth level</a:t>
             </a:r>
           </a:p>
           <a:p>
             <a:pPr lvl="4"/>
             <a:r>
-              <a:rPr lang="en-US"/>
+              <a:rPr lang="en-US" smtClean="0"/>
               <a:t>Fifth level</a:t>
             </a:r>
+            <a:endParaRPr lang="en-US"/>
           </a:p>
         </p:txBody>
       </p:sp>
@@ -2761,7 +2738,7 @@
           <a:p>
             <a:fld id="{5BCAD085-E8A6-8845-BD4E-CB4CCA059FC4}" type="datetimeFigureOut">
               <a:rPr lang="en-US" smtClean="0"/>
-              <a:t>9/25/26</a:t>
+              <a:t>1/27/13</a:t>
             </a:fld>
             <a:endParaRPr lang="en-US"/>
           </a:p>
@@ -3120,7 +3097,7 @@
 </file>
 
 <file path=ppt/slides/slide1.xml><?xml version="1.0" encoding="utf-8"?>
-<p:sld xmlns:a="http://schemas.openxmlformats.org/drawingml/2006/main" xmlns:r="http://schemas.openxmlformats.org/officeDocument/2006/relationships" xmlns:p="http://schemas.openxmlformats.org/presentationml/2006/main">
+<p:sld xmlns:a="http://schemas.openxmlformats.org/drawingml/2006/main" xmlns:p="http://schemas.openxmlformats.org/presentationml/2006/main" xmlns:r="http://schemas.openxmlformats.org/officeDocument/2006/relationships">
   <p:cSld>
     <p:bg>
       <p:bgPr>
@@ -3136,14 +3113,7 @@
         <p:cNvGrpSpPr/>
         <p:nvPr/>
       </p:nvGrpSpPr>
-      <p:grpSpPr>
-        <a:xfrm>
-          <a:off x="0" y="0"/>
-          <a:ext cx="0" cy="0"/>
-          <a:chOff x="0" y="0"/>
-          <a:chExt cx="0" cy="0"/>
-        </a:xfrm>
-      </p:grpSpPr>
+      <p:grpSpPr/>
       <p:sp>
         <p:nvSpPr>
           <p:cNvPr id="2" name="TextBox 1"/>
@@ -3252,7 +3222,7 @@
 </file>
 
 <file path=ppt/slides/slide10.xml><?xml version="1.0" encoding="utf-8"?>
-<p:sld xmlns:a="http://schemas.openxmlformats.org/drawingml/2006/main" xmlns:r="http://schemas.openxmlformats.org/officeDocument/2006/relationships" xmlns:p="http://schemas.openxmlformats.org/presentationml/2006/main">
+<p:sld xmlns:a="http://schemas.openxmlformats.org/drawingml/2006/main" xmlns:p="http://schemas.openxmlformats.org/presentationml/2006/main" xmlns:r="http://schemas.openxmlformats.org/officeDocument/2006/relationships">
   <p:cSld>
     <p:bg>
       <p:bgPr>
@@ -3268,14 +3238,7 @@
         <p:cNvGrpSpPr/>
         <p:nvPr/>
       </p:nvGrpSpPr>
-      <p:grpSpPr>
-        <a:xfrm>
-          <a:off x="0" y="0"/>
-          <a:ext cx="0" cy="0"/>
-          <a:chOff x="0" y="0"/>
-          <a:chExt cx="0" cy="0"/>
-        </a:xfrm>
-      </p:grpSpPr>
+      <p:grpSpPr/>
       <p:sp>
         <p:nvSpPr>
           <p:cNvPr id="2" name="Rectangle 1"/>
@@ -3316,7 +3279,6 @@
           <a:lstStyle/>
           <a:p>
             <a:pPr algn="ctr"/>
-            <a:endParaRPr/>
           </a:p>
         </p:txBody>
       </p:sp>
@@ -3393,7 +3355,6 @@
           <a:lstStyle/>
           <a:p>
             <a:pPr algn="ctr"/>
-            <a:endParaRPr/>
           </a:p>
         </p:txBody>
       </p:sp>
@@ -3534,7 +3495,7 @@
           <a:lstStyle/>
           <a:p>
             <a:r>
-              <a:rPr sz="1400" b="1" i="1">
+              <a:rPr sz="1400" i="1" b="1">
                 <a:solidFill>
                   <a:srgbClr val="993300"/>
                 </a:solidFill>
@@ -3553,7 +3514,7 @@
 </file>
 
 <file path=ppt/slides/slide11.xml><?xml version="1.0" encoding="utf-8"?>
-<p:sld xmlns:a="http://schemas.openxmlformats.org/drawingml/2006/main" xmlns:r="http://schemas.openxmlformats.org/officeDocument/2006/relationships" xmlns:p="http://schemas.openxmlformats.org/presentationml/2006/main">
+<p:sld xmlns:a="http://schemas.openxmlformats.org/drawingml/2006/main" xmlns:p="http://schemas.openxmlformats.org/presentationml/2006/main" xmlns:r="http://schemas.openxmlformats.org/officeDocument/2006/relationships">
   <p:cSld>
     <p:bg>
       <p:bgPr>
@@ -3569,14 +3530,7 @@
         <p:cNvGrpSpPr/>
         <p:nvPr/>
       </p:nvGrpSpPr>
-      <p:grpSpPr>
-        <a:xfrm>
-          <a:off x="0" y="0"/>
-          <a:ext cx="0" cy="0"/>
-          <a:chOff x="0" y="0"/>
-          <a:chExt cx="0" cy="0"/>
-        </a:xfrm>
-      </p:grpSpPr>
+      <p:grpSpPr/>
       <p:sp>
         <p:nvSpPr>
           <p:cNvPr id="2" name="Rectangle 1"/>
@@ -3617,7 +3571,6 @@
           <a:lstStyle/>
           <a:p>
             <a:pPr algn="ctr"/>
-            <a:endParaRPr/>
           </a:p>
         </p:txBody>
       </p:sp>
@@ -3694,7 +3647,6 @@
           <a:lstStyle/>
           <a:p>
             <a:pPr algn="ctr"/>
-            <a:endParaRPr/>
           </a:p>
         </p:txBody>
       </p:sp>
@@ -3937,7 +3889,7 @@
 </file>
 
 <file path=ppt/slides/slide12.xml><?xml version="1.0" encoding="utf-8"?>
-<p:sld xmlns:a="http://schemas.openxmlformats.org/drawingml/2006/main" xmlns:r="http://schemas.openxmlformats.org/officeDocument/2006/relationships" xmlns:p="http://schemas.openxmlformats.org/presentationml/2006/main">
+<p:sld xmlns:a="http://schemas.openxmlformats.org/drawingml/2006/main" xmlns:p="http://schemas.openxmlformats.org/presentationml/2006/main" xmlns:r="http://schemas.openxmlformats.org/officeDocument/2006/relationships">
   <p:cSld>
     <p:bg>
       <p:bgPr>
@@ -3953,14 +3905,7 @@
         <p:cNvGrpSpPr/>
         <p:nvPr/>
       </p:nvGrpSpPr>
-      <p:grpSpPr>
-        <a:xfrm>
-          <a:off x="0" y="0"/>
-          <a:ext cx="0" cy="0"/>
-          <a:chOff x="0" y="0"/>
-          <a:chExt cx="0" cy="0"/>
-        </a:xfrm>
-      </p:grpSpPr>
+      <p:grpSpPr/>
       <p:sp>
         <p:nvSpPr>
           <p:cNvPr id="2" name="Rectangle 1"/>
@@ -4001,7 +3946,6 @@
           <a:lstStyle/>
           <a:p>
             <a:pPr algn="ctr"/>
-            <a:endParaRPr/>
           </a:p>
         </p:txBody>
       </p:sp>
@@ -4078,7 +4022,6 @@
           <a:lstStyle/>
           <a:p>
             <a:pPr algn="ctr"/>
-            <a:endParaRPr/>
           </a:p>
         </p:txBody>
       </p:sp>
@@ -4106,11 +4049,11 @@
           <a:p>
             <a:pPr>
               <a:spcAft>
-                <a:spcPts val="1400"/>
+                <a:spcPts val="1300"/>
               </a:spcAft>
             </a:pPr>
             <a:r>
-              <a:rPr sz="2000" b="1">
+              <a:rPr sz="1900" b="1">
                 <a:solidFill>
                   <a:srgbClr val="E05A2E"/>
                 </a:solidFill>
@@ -4118,7 +4061,7 @@
               <a:t>●  Classification:</a:t>
             </a:r>
             <a:r>
-              <a:rPr sz="2000" b="0">
+              <a:rPr sz="1900" b="0">
                 <a:solidFill>
                   <a:srgbClr val="14182B"/>
                 </a:solidFill>
@@ -4129,70 +4072,70 @@
           <a:p>
             <a:pPr>
               <a:spcAft>
-                <a:spcPts val="1400"/>
+                <a:spcPts val="1300"/>
               </a:spcAft>
             </a:pPr>
             <a:r>
-              <a:rPr sz="2000" b="1">
+              <a:rPr sz="1900" b="1">
                 <a:solidFill>
                   <a:srgbClr val="E05A2E"/>
                 </a:solidFill>
               </a:rPr>
-              <a:t>●  Generation (MVP):</a:t>
-            </a:r>
-            <a:r>
-              <a:rPr sz="2000" b="0">
+              <a:t>●  Generation — reconstruction:</a:t>
+            </a:r>
+            <a:r>
+              <a:rPr sz="1900" b="0">
                 <a:solidFill>
                   <a:srgbClr val="14182B"/>
                 </a:solidFill>
               </a:rPr>
-              <a:t>  Meshy API handles reconstruction, PBR texturing, and auto-rigging.</a:t>
+              <a:t>  diffusion model reads shape/material/depth from the photo, then multi-view synthesis predicts the angles the photo never showed.</a:t>
             </a:r>
           </a:p>
           <a:p>
             <a:pPr>
               <a:spcAft>
-                <a:spcPts val="1400"/>
+                <a:spcPts val="1300"/>
               </a:spcAft>
             </a:pPr>
             <a:r>
-              <a:rPr sz="2000" b="1">
+              <a:rPr sz="1900" b="1">
                 <a:solidFill>
                   <a:srgbClr val="E05A2E"/>
                 </a:solidFill>
               </a:rPr>
-              <a:t>●  Generation (future candidates):</a:t>
-            </a:r>
-            <a:r>
-              <a:rPr sz="2000" b="0">
+              <a:t>●  Generation — rigging:</a:t>
+            </a:r>
+            <a:r>
+              <a:rPr sz="1900" b="0">
                 <a:solidFill>
                   <a:srgbClr val="14182B"/>
                 </a:solidFill>
               </a:rPr>
-              <a:t>  photogrammetry or NeRF-based reconstruction + a separate rigging tool, benchmarked against Meshy.</a:t>
+              <a:t>  detects body plan (humanoid/quadruped/custom), builds bone hierarchy, computes skinning weights automatically.</a:t>
             </a:r>
           </a:p>
           <a:p>
             <a:pPr>
               <a:spcAft>
-                <a:spcPts val="1400"/>
+                <a:spcPts val="1300"/>
               </a:spcAft>
             </a:pPr>
             <a:r>
-              <a:rPr sz="2000" b="1">
+              <a:rPr sz="1900" b="1">
                 <a:solidFill>
                   <a:srgbClr val="E05A2E"/>
                 </a:solidFill>
               </a:rPr>
-              <a:t>●  Sensor fusion (LiDAR + thermal + visual):</a:t>
-            </a:r>
-            <a:r>
-              <a:rPr sz="2000" b="0">
+              <a:t>●  Future candidates:</a:t>
+            </a:r>
+            <a:r>
+              <a:rPr sz="1900" b="0">
                 <a:solidFill>
                   <a:srgbClr val="14182B"/>
                 </a:solidFill>
               </a:rPr>
-              <a:t>  approach TBD, depends on hardware side-project specifics.</a:t>
+              <a:t>  photogrammetry or NeRF-based reconstruction, benchmarked against Meshy's output.</a:t>
             </a:r>
           </a:p>
         </p:txBody>
@@ -4206,7 +4149,7 @@
 </file>
 
 <file path=ppt/slides/slide13.xml><?xml version="1.0" encoding="utf-8"?>
-<p:sld xmlns:a="http://schemas.openxmlformats.org/drawingml/2006/main" xmlns:r="http://schemas.openxmlformats.org/officeDocument/2006/relationships" xmlns:p="http://schemas.openxmlformats.org/presentationml/2006/main">
+<p:sld xmlns:a="http://schemas.openxmlformats.org/drawingml/2006/main" xmlns:p="http://schemas.openxmlformats.org/presentationml/2006/main" xmlns:r="http://schemas.openxmlformats.org/officeDocument/2006/relationships">
   <p:cSld>
     <p:bg>
       <p:bgPr>
@@ -4222,14 +4165,7 @@
         <p:cNvGrpSpPr/>
         <p:nvPr/>
       </p:nvGrpSpPr>
-      <p:grpSpPr>
-        <a:xfrm>
-          <a:off x="0" y="0"/>
-          <a:ext cx="0" cy="0"/>
-          <a:chOff x="0" y="0"/>
-          <a:chExt cx="0" cy="0"/>
-        </a:xfrm>
-      </p:grpSpPr>
+      <p:grpSpPr/>
       <p:sp>
         <p:nvSpPr>
           <p:cNvPr id="2" name="Rectangle 1"/>
@@ -4270,7 +4206,6 @@
           <a:lstStyle/>
           <a:p>
             <a:pPr algn="ctr"/>
-            <a:endParaRPr/>
           </a:p>
         </p:txBody>
       </p:sp>
@@ -4302,7 +4237,7 @@
                   <a:srgbClr val="14182B"/>
                 </a:solidFill>
               </a:rPr>
-              <a:t>Code &amp; Architecture</a:t>
+              <a:t>Meshy: Efficiency &amp; Benchmarks</a:t>
             </a:r>
           </a:p>
         </p:txBody>
@@ -4347,7 +4282,6 @@
           <a:lstStyle/>
           <a:p>
             <a:pPr algn="ctr"/>
-            <a:endParaRPr/>
           </a:p>
         </p:txBody>
       </p:sp>
@@ -4360,7 +4294,7 @@
         <p:spPr>
           <a:xfrm>
             <a:off x="685800" y="1554480"/>
-            <a:ext cx="10698480" cy="1371600"/>
+            <a:ext cx="10607040" cy="4480560"/>
           </a:xfrm>
           <a:prstGeom prst="rect">
             <a:avLst/>
@@ -4373,13 +4307,95 @@
           </a:bodyPr>
           <a:lstStyle/>
           <a:p>
+            <a:pPr>
+              <a:spcAft>
+                <a:spcPts val="1300"/>
+              </a:spcAft>
+            </a:pPr>
             <a:r>
               <a:rPr sz="1900" b="1">
                 <a:solidFill>
+                  <a:srgbClr val="E05A2E"/>
+                </a:solidFill>
+              </a:rPr>
+              <a:t>●  Speed:</a:t>
+            </a:r>
+            <a:r>
+              <a:rPr sz="1900" b="0">
+                <a:solidFill>
                   <a:srgbClr val="14182B"/>
                 </a:solidFill>
               </a:rPr>
-              <a:t>Capture (phone / drone / sensor)  →  Backend (classify + orchestrate)  →  Desktop hub (queue, preview, target picker)  →  Engine import (Unity / Blender / Unreal)</a:t>
+              <a:t>  ~90 seconds for a full textured model on Meshy 7; auto-rigging adds under 30 seconds.</a:t>
+            </a:r>
+          </a:p>
+          <a:p>
+            <a:pPr>
+              <a:spcAft>
+                <a:spcPts val="1300"/>
+              </a:spcAft>
+            </a:pPr>
+            <a:r>
+              <a:rPr sz="1900" b="1">
+                <a:solidFill>
+                  <a:srgbClr val="E05A2E"/>
+                </a:solidFill>
+              </a:rPr>
+              <a:t>●  Benchmark:</a:t>
+            </a:r>
+            <a:r>
+              <a:rPr sz="1900" b="0">
+                <a:solidFill>
+                  <a:srgbClr val="14182B"/>
+                </a:solidFill>
+              </a:rPr>
+              <a:t>  Meshy 7 leads published single-view reconstruction scores against Tripo 3.1 and Rodin 2.5 — 81.0% overall shape accuracy, 59.8% on surface detail.</a:t>
+            </a:r>
+          </a:p>
+          <a:p>
+            <a:pPr>
+              <a:spcAft>
+                <a:spcPts val="1300"/>
+              </a:spcAft>
+            </a:pPr>
+            <a:r>
+              <a:rPr sz="1900" b="1">
+                <a:solidFill>
+                  <a:srgbClr val="E05A2E"/>
+                </a:solidFill>
+              </a:rPr>
+              <a:t>●  Cost:</a:t>
+            </a:r>
+            <a:r>
+              <a:rPr sz="1900" b="0">
+                <a:solidFill>
+                  <a:srgbClr val="14182B"/>
+                </a:solidFill>
+              </a:rPr>
+              <a:t>  20-30 credits per generation (~$0.60/model); API access needs the Pro tier, $20/mo for 1,000 credits — about 30-50 generations/month.</a:t>
+            </a:r>
+          </a:p>
+          <a:p>
+            <a:pPr>
+              <a:spcAft>
+                <a:spcPts val="1300"/>
+              </a:spcAft>
+            </a:pPr>
+            <a:r>
+              <a:rPr sz="1900" b="1">
+                <a:solidFill>
+                  <a:srgbClr val="E05A2E"/>
+                </a:solidFill>
+              </a:rPr>
+              <a:t>●  What that means for us:</a:t>
+            </a:r>
+            <a:r>
+              <a:rPr sz="1900" b="0">
+                <a:solidFill>
+                  <a:srgbClr val="14182B"/>
+                </a:solidFill>
+              </a:rPr>
+              <a:t>  our full 15-25 object test set fits comfortably in one month's credits, with room for retries.</a:t>
             </a:r>
           </a:p>
         </p:txBody>
@@ -4392,8 +4408,8 @@
         </p:nvSpPr>
         <p:spPr>
           <a:xfrm>
-            <a:off x="685800" y="3108960"/>
-            <a:ext cx="10607040" cy="2743200"/>
+            <a:off x="640080" y="6309360"/>
+            <a:ext cx="10881360" cy="457200"/>
           </a:xfrm>
           <a:prstGeom prst="rect">
             <a:avLst/>
@@ -4401,54 +4417,18 @@
           <a:noFill/>
         </p:spPr>
         <p:txBody>
-          <a:bodyPr wrap="square">
+          <a:bodyPr wrap="none">
             <a:spAutoFit/>
           </a:bodyPr>
           <a:lstStyle/>
           <a:p>
-            <a:pPr>
-              <a:spcAft>
-                <a:spcPts val="1600"/>
-              </a:spcAft>
-            </a:pPr>
-            <a:r>
-              <a:rPr sz="2100" b="1">
-                <a:solidFill>
-                  <a:srgbClr val="E05A2E"/>
-                </a:solidFill>
-              </a:rPr>
-              <a:t>●  Repo layout:</a:t>
-            </a:r>
-            <a:r>
-              <a:rPr sz="2100" b="0">
-                <a:solidFill>
-                  <a:srgbClr val="14182B"/>
-                </a:solidFill>
-              </a:rPr>
-              <a:t>  capture app, backend orchestrator, classifier module, desktop hub, per-engine import packages.</a:t>
-            </a:r>
-          </a:p>
-          <a:p>
-            <a:pPr>
-              <a:spcAft>
-                <a:spcPts val="1600"/>
-              </a:spcAft>
-            </a:pPr>
-            <a:r>
-              <a:rPr sz="2100" b="1">
-                <a:solidFill>
-                  <a:srgbClr val="E05A2E"/>
-                </a:solidFill>
-              </a:rPr>
-              <a:t>●  Hardware hook-in:</a:t>
-            </a:r>
-            <a:r>
-              <a:rPr sz="2100" b="0">
-                <a:solidFill>
-                  <a:srgbClr val="14182B"/>
-                </a:solidFill>
-              </a:rPr>
-              <a:t>  drone/LiDAR/thermal code plugs in at the capture stage as an alternate front-end to the same backend.</a:t>
+            <a:r>
+              <a:rPr sz="1100" i="1">
+                <a:solidFill>
+                  <a:srgbClr val="4A4A4A"/>
+                </a:solidFill>
+              </a:rPr>
+              <a:t>Sources: meshy.ai/features/image-to-3d · meshy.ai/features/ai-auto-rigging · framesixty.com Meshy review · docs.meshy.ai</a:t>
             </a:r>
           </a:p>
         </p:txBody>
@@ -4462,7 +4442,7 @@
 </file>
 
 <file path=ppt/slides/slide14.xml><?xml version="1.0" encoding="utf-8"?>
-<p:sld xmlns:a="http://schemas.openxmlformats.org/drawingml/2006/main" xmlns:r="http://schemas.openxmlformats.org/officeDocument/2006/relationships" xmlns:p="http://schemas.openxmlformats.org/presentationml/2006/main">
+<p:sld xmlns:a="http://schemas.openxmlformats.org/drawingml/2006/main" xmlns:p="http://schemas.openxmlformats.org/presentationml/2006/main" xmlns:r="http://schemas.openxmlformats.org/officeDocument/2006/relationships">
   <p:cSld>
     <p:bg>
       <p:bgPr>
@@ -4478,14 +4458,7 @@
         <p:cNvGrpSpPr/>
         <p:nvPr/>
       </p:nvGrpSpPr>
-      <p:grpSpPr>
-        <a:xfrm>
-          <a:off x="0" y="0"/>
-          <a:ext cx="0" cy="0"/>
-          <a:chOff x="0" y="0"/>
-          <a:chExt cx="0" cy="0"/>
-        </a:xfrm>
-      </p:grpSpPr>
+      <p:grpSpPr/>
       <p:sp>
         <p:nvSpPr>
           <p:cNvPr id="2" name="Rectangle 1"/>
@@ -4526,7 +4499,6 @@
           <a:lstStyle/>
           <a:p>
             <a:pPr algn="ctr"/>
-            <a:endParaRPr/>
           </a:p>
         </p:txBody>
       </p:sp>
@@ -4558,7 +4530,7 @@
                   <a:srgbClr val="14182B"/>
                 </a:solidFill>
               </a:rPr>
-              <a:t>How We'll Know It Works</a:t>
+              <a:t>Code &amp; Architecture</a:t>
             </a:r>
           </a:p>
         </p:txBody>
@@ -4603,7 +4575,6 @@
           <a:lstStyle/>
           <a:p>
             <a:pPr algn="ctr"/>
-            <a:endParaRPr/>
           </a:p>
         </p:txBody>
       </p:sp>
@@ -4615,8 +4586,8 @@
         </p:nvSpPr>
         <p:spPr>
           <a:xfrm>
-            <a:off x="685800" y="1645920"/>
-            <a:ext cx="10607040" cy="3931920"/>
+            <a:off x="685800" y="1554480"/>
+            <a:ext cx="10698480" cy="1371600"/>
           </a:xfrm>
           <a:prstGeom prst="rect">
             <a:avLst/>
@@ -4629,9 +4600,42 @@
           </a:bodyPr>
           <a:lstStyle/>
           <a:p>
+            <a:r>
+              <a:rPr sz="1900" b="1">
+                <a:solidFill>
+                  <a:srgbClr val="14182B"/>
+                </a:solidFill>
+              </a:rPr>
+              <a:t>Capture (phone / drone / sensor)  →  Backend (classify + orchestrate)  →  Desktop hub (queue, preview, target picker)  →  Engine import (Unity / Blender / Unreal)</a:t>
+            </a:r>
+          </a:p>
+        </p:txBody>
+      </p:sp>
+      <p:sp>
+        <p:nvSpPr>
+          <p:cNvPr id="6" name="TextBox 5"/>
+          <p:cNvSpPr txBox="1"/>
+          <p:nvPr/>
+        </p:nvSpPr>
+        <p:spPr>
+          <a:xfrm>
+            <a:off x="685800" y="3108960"/>
+            <a:ext cx="10607040" cy="2743200"/>
+          </a:xfrm>
+          <a:prstGeom prst="rect">
+            <a:avLst/>
+          </a:prstGeom>
+          <a:noFill/>
+        </p:spPr>
+        <p:txBody>
+          <a:bodyPr wrap="square">
+            <a:spAutoFit/>
+          </a:bodyPr>
+          <a:lstStyle/>
+          <a:p>
             <a:pPr>
               <a:spcAft>
-                <a:spcPts val="1400"/>
+                <a:spcPts val="1600"/>
               </a:spcAft>
             </a:pPr>
             <a:r>
@@ -4640,7 +4644,7 @@
                   <a:srgbClr val="E05A2E"/>
                 </a:solidFill>
               </a:rPr>
-              <a:t>●  Classification accuracy —</a:t>
+              <a:t>●  Repo layout:</a:t>
             </a:r>
             <a:r>
               <a:rPr sz="2100" b="0">
@@ -4648,13 +4652,13 @@
                   <a:srgbClr val="14182B"/>
                 </a:solidFill>
               </a:rPr>
-              <a:t>  how often the object gets sorted correctly.</a:t>
+              <a:t>  capture app, backend orchestrator, classifier module, desktop hub, per-engine import packages.</a:t>
             </a:r>
           </a:p>
           <a:p>
             <a:pPr>
               <a:spcAft>
-                <a:spcPts val="1400"/>
+                <a:spcPts val="1600"/>
               </a:spcAft>
             </a:pPr>
             <a:r>
@@ -4663,7 +4667,7 @@
                   <a:srgbClr val="E05A2E"/>
                 </a:solidFill>
               </a:rPr>
-              <a:t>●  End-to-end success rate —</a:t>
+              <a:t>●  Hardware hook-in:</a:t>
             </a:r>
             <a:r>
               <a:rPr sz="2100" b="0">
@@ -4671,53 +4675,7 @@
                   <a:srgbClr val="14182B"/>
                 </a:solidFill>
               </a:rPr>
-              <a:t>  how many test captures come out as a working, unbroken Unity asset.</a:t>
-            </a:r>
-          </a:p>
-          <a:p>
-            <a:pPr>
-              <a:spcAft>
-                <a:spcPts val="1400"/>
-              </a:spcAft>
-            </a:pPr>
-            <a:r>
-              <a:rPr sz="2100" b="1">
-                <a:solidFill>
-                  <a:srgbClr val="E05A2E"/>
-                </a:solidFill>
-              </a:rPr>
-              <a:t>●  Time per asset —</a:t>
-            </a:r>
-            <a:r>
-              <a:rPr sz="2100" b="0">
-                <a:solidFill>
-                  <a:srgbClr val="14182B"/>
-                </a:solidFill>
-              </a:rPr>
-              <a:t>  how long it takes, start to finish, versus doing it by hand.</a:t>
-            </a:r>
-          </a:p>
-          <a:p>
-            <a:pPr>
-              <a:spcAft>
-                <a:spcPts val="1400"/>
-              </a:spcAft>
-            </a:pPr>
-            <a:r>
-              <a:rPr sz="2100" b="1">
-                <a:solidFill>
-                  <a:srgbClr val="E05A2E"/>
-                </a:solidFill>
-              </a:rPr>
-              <a:t>●  Definition of done —</a:t>
-            </a:r>
-            <a:r>
-              <a:rPr sz="2100" b="0">
-                <a:solidFill>
-                  <a:srgbClr val="14182B"/>
-                </a:solidFill>
-              </a:rPr>
-              <a:t>  a finished Unity game object with physics, rigging, and colliders already set up, ready to drop into a scene.</a:t>
+              <a:t>  drone/LiDAR/thermal code plugs in at the capture stage as an alternate front-end to the same backend.</a:t>
             </a:r>
           </a:p>
         </p:txBody>
@@ -4731,7 +4689,7 @@
 </file>
 
 <file path=ppt/slides/slide15.xml><?xml version="1.0" encoding="utf-8"?>
-<p:sld xmlns:a="http://schemas.openxmlformats.org/drawingml/2006/main" xmlns:r="http://schemas.openxmlformats.org/officeDocument/2006/relationships" xmlns:p="http://schemas.openxmlformats.org/presentationml/2006/main">
+<p:sld xmlns:a="http://schemas.openxmlformats.org/drawingml/2006/main" xmlns:p="http://schemas.openxmlformats.org/presentationml/2006/main" xmlns:r="http://schemas.openxmlformats.org/officeDocument/2006/relationships">
   <p:cSld>
     <p:bg>
       <p:bgPr>
@@ -4747,14 +4705,7 @@
         <p:cNvGrpSpPr/>
         <p:nvPr/>
       </p:nvGrpSpPr>
-      <p:grpSpPr>
-        <a:xfrm>
-          <a:off x="0" y="0"/>
-          <a:ext cx="0" cy="0"/>
-          <a:chOff x="0" y="0"/>
-          <a:chExt cx="0" cy="0"/>
-        </a:xfrm>
-      </p:grpSpPr>
+      <p:grpSpPr/>
       <p:sp>
         <p:nvSpPr>
           <p:cNvPr id="2" name="Rectangle 1"/>
@@ -4795,7 +4746,6 @@
           <a:lstStyle/>
           <a:p>
             <a:pPr algn="ctr"/>
-            <a:endParaRPr/>
           </a:p>
         </p:txBody>
       </p:sp>
@@ -4827,7 +4777,7 @@
                   <a:srgbClr val="14182B"/>
                 </a:solidFill>
               </a:rPr>
-              <a:t>Timeline</a:t>
+              <a:t>How We'll Know It Works</a:t>
             </a:r>
           </a:p>
         </p:txBody>
@@ -4872,7 +4822,6 @@
           <a:lstStyle/>
           <a:p>
             <a:pPr algn="ctr"/>
-            <a:endParaRPr/>
           </a:p>
         </p:txBody>
       </p:sp>
@@ -4884,8 +4833,8 @@
         </p:nvSpPr>
         <p:spPr>
           <a:xfrm>
-            <a:off x="685800" y="1600200"/>
-            <a:ext cx="2377440" cy="594360"/>
+            <a:off x="685800" y="1645920"/>
+            <a:ext cx="10607040" cy="3931920"/>
           </a:xfrm>
           <a:prstGeom prst="rect">
             <a:avLst/>
@@ -4893,381 +4842,100 @@
           <a:noFill/>
         </p:spPr>
         <p:txBody>
-          <a:bodyPr wrap="none">
+          <a:bodyPr wrap="square">
             <a:spAutoFit/>
           </a:bodyPr>
           <a:lstStyle/>
           <a:p>
-            <a:r>
-              <a:rPr sz="1900" b="1">
+            <a:pPr>
+              <a:spcAft>
+                <a:spcPts val="1400"/>
+              </a:spcAft>
+            </a:pPr>
+            <a:r>
+              <a:rPr sz="2100" b="1">
                 <a:solidFill>
                   <a:srgbClr val="E05A2E"/>
                 </a:solidFill>
               </a:rPr>
-              <a:t>Week of Sep 29</a:t>
-            </a:r>
-          </a:p>
-        </p:txBody>
-      </p:sp>
-      <p:sp>
-        <p:nvSpPr>
-          <p:cNvPr id="6" name="TextBox 5"/>
-          <p:cNvSpPr txBox="1"/>
-          <p:nvPr/>
-        </p:nvSpPr>
-        <p:spPr>
-          <a:xfrm>
-            <a:off x="3200400" y="1600200"/>
-            <a:ext cx="8046720" cy="594360"/>
-          </a:xfrm>
-          <a:prstGeom prst="rect">
-            <a:avLst/>
-          </a:prstGeom>
-          <a:noFill/>
-        </p:spPr>
-        <p:txBody>
-          <a:bodyPr wrap="none">
-            <a:spAutoFit/>
-          </a:bodyPr>
-          <a:lstStyle/>
-          <a:p>
-            <a:r>
-              <a:rPr sz="1900" b="1">
+              <a:t>●  Classification accuracy —</a:t>
+            </a:r>
+            <a:r>
+              <a:rPr sz="2100" b="0">
                 <a:solidFill>
                   <a:srgbClr val="14182B"/>
                 </a:solidFill>
               </a:rPr>
-              <a:t>Validate Meshy API end-to-end, lock MVP scope</a:t>
-            </a:r>
-          </a:p>
-        </p:txBody>
-      </p:sp>
-      <p:sp>
-        <p:nvSpPr>
-          <p:cNvPr id="7" name="TextBox 6"/>
-          <p:cNvSpPr txBox="1"/>
-          <p:nvPr/>
-        </p:nvSpPr>
-        <p:spPr>
-          <a:xfrm>
-            <a:off x="685800" y="2350008"/>
-            <a:ext cx="2377440" cy="594360"/>
-          </a:xfrm>
-          <a:prstGeom prst="rect">
-            <a:avLst/>
-          </a:prstGeom>
-          <a:noFill/>
-        </p:spPr>
-        <p:txBody>
-          <a:bodyPr wrap="none">
-            <a:spAutoFit/>
-          </a:bodyPr>
-          <a:lstStyle/>
-          <a:p>
-            <a:r>
-              <a:rPr sz="1900" b="1">
+              <a:t>  how often the object gets sorted correctly.</a:t>
+            </a:r>
+          </a:p>
+          <a:p>
+            <a:pPr>
+              <a:spcAft>
+                <a:spcPts val="1400"/>
+              </a:spcAft>
+            </a:pPr>
+            <a:r>
+              <a:rPr sz="2100" b="1">
                 <a:solidFill>
                   <a:srgbClr val="E05A2E"/>
                 </a:solidFill>
               </a:rPr>
-              <a:t>October</a:t>
-            </a:r>
-          </a:p>
-        </p:txBody>
-      </p:sp>
-      <p:sp>
-        <p:nvSpPr>
-          <p:cNvPr id="8" name="TextBox 7"/>
-          <p:cNvSpPr txBox="1"/>
-          <p:nvPr/>
-        </p:nvSpPr>
-        <p:spPr>
-          <a:xfrm>
-            <a:off x="3200400" y="2350008"/>
-            <a:ext cx="8046720" cy="594360"/>
-          </a:xfrm>
-          <a:prstGeom prst="rect">
-            <a:avLst/>
-          </a:prstGeom>
-          <a:noFill/>
-        </p:spPr>
-        <p:txBody>
-          <a:bodyPr wrap="none">
-            <a:spAutoFit/>
-          </a:bodyPr>
-          <a:lstStyle/>
-          <a:p>
-            <a:r>
-              <a:rPr sz="1900" b="1">
+              <a:t>●  End-to-end success rate —</a:t>
+            </a:r>
+            <a:r>
+              <a:rPr sz="2100" b="0">
                 <a:solidFill>
                   <a:srgbClr val="14182B"/>
                 </a:solidFill>
               </a:rPr>
-              <a:t>Capture app, backend, classifier, desktop app</a:t>
-            </a:r>
-          </a:p>
-        </p:txBody>
-      </p:sp>
-      <p:sp>
-        <p:nvSpPr>
-          <p:cNvPr id="9" name="TextBox 8"/>
-          <p:cNvSpPr txBox="1"/>
-          <p:nvPr/>
-        </p:nvSpPr>
-        <p:spPr>
-          <a:xfrm>
-            <a:off x="685800" y="3099816"/>
-            <a:ext cx="2377440" cy="594360"/>
-          </a:xfrm>
-          <a:prstGeom prst="rect">
-            <a:avLst/>
-          </a:prstGeom>
-          <a:noFill/>
-        </p:spPr>
-        <p:txBody>
-          <a:bodyPr wrap="none">
-            <a:spAutoFit/>
-          </a:bodyPr>
-          <a:lstStyle/>
-          <a:p>
-            <a:r>
-              <a:rPr sz="1900" b="1">
+              <a:t>  how many test captures come out as a working, unbroken Unity asset.</a:t>
+            </a:r>
+          </a:p>
+          <a:p>
+            <a:pPr>
+              <a:spcAft>
+                <a:spcPts val="1400"/>
+              </a:spcAft>
+            </a:pPr>
+            <a:r>
+              <a:rPr sz="2100" b="1">
                 <a:solidFill>
                   <a:srgbClr val="E05A2E"/>
                 </a:solidFill>
               </a:rPr>
-              <a:t>Early Nov</a:t>
-            </a:r>
-          </a:p>
-        </p:txBody>
-      </p:sp>
-      <p:sp>
-        <p:nvSpPr>
-          <p:cNvPr id="10" name="TextBox 9"/>
-          <p:cNvSpPr txBox="1"/>
-          <p:nvPr/>
-        </p:nvSpPr>
-        <p:spPr>
-          <a:xfrm>
-            <a:off x="3200400" y="3099816"/>
-            <a:ext cx="8046720" cy="594360"/>
-          </a:xfrm>
-          <a:prstGeom prst="rect">
-            <a:avLst/>
-          </a:prstGeom>
-          <a:noFill/>
-        </p:spPr>
-        <p:txBody>
-          <a:bodyPr wrap="none">
-            <a:spAutoFit/>
-          </a:bodyPr>
-          <a:lstStyle/>
-          <a:p>
-            <a:r>
-              <a:rPr sz="1900" b="1">
+              <a:t>●  Time per asset —</a:t>
+            </a:r>
+            <a:r>
+              <a:rPr sz="2100" b="0">
                 <a:solidFill>
                   <a:srgbClr val="14182B"/>
                 </a:solidFill>
               </a:rPr>
-              <a:t>Unity import automation</a:t>
-            </a:r>
-          </a:p>
-        </p:txBody>
-      </p:sp>
-      <p:sp>
-        <p:nvSpPr>
-          <p:cNvPr id="11" name="TextBox 10"/>
-          <p:cNvSpPr txBox="1"/>
-          <p:nvPr/>
-        </p:nvSpPr>
-        <p:spPr>
-          <a:xfrm>
-            <a:off x="685800" y="3849624"/>
-            <a:ext cx="2377440" cy="594360"/>
-          </a:xfrm>
-          <a:prstGeom prst="rect">
-            <a:avLst/>
-          </a:prstGeom>
-          <a:noFill/>
-        </p:spPr>
-        <p:txBody>
-          <a:bodyPr wrap="none">
-            <a:spAutoFit/>
-          </a:bodyPr>
-          <a:lstStyle/>
-          <a:p>
-            <a:r>
-              <a:rPr sz="1900" b="1">
+              <a:t>  how long it takes, start to finish, versus doing it by hand.</a:t>
+            </a:r>
+          </a:p>
+          <a:p>
+            <a:pPr>
+              <a:spcAft>
+                <a:spcPts val="1400"/>
+              </a:spcAft>
+            </a:pPr>
+            <a:r>
+              <a:rPr sz="2100" b="1">
                 <a:solidFill>
                   <a:srgbClr val="E05A2E"/>
                 </a:solidFill>
               </a:rPr>
-              <a:t>Mid Nov</a:t>
-            </a:r>
-          </a:p>
-        </p:txBody>
-      </p:sp>
-      <p:sp>
-        <p:nvSpPr>
-          <p:cNvPr id="12" name="TextBox 11"/>
-          <p:cNvSpPr txBox="1"/>
-          <p:nvPr/>
-        </p:nvSpPr>
-        <p:spPr>
-          <a:xfrm>
-            <a:off x="3200400" y="3849624"/>
-            <a:ext cx="8046720" cy="594360"/>
-          </a:xfrm>
-          <a:prstGeom prst="rect">
-            <a:avLst/>
-          </a:prstGeom>
-          <a:noFill/>
-        </p:spPr>
-        <p:txBody>
-          <a:bodyPr wrap="none">
-            <a:spAutoFit/>
-          </a:bodyPr>
-          <a:lstStyle/>
-          <a:p>
-            <a:r>
-              <a:rPr sz="1900" b="1">
+              <a:t>●  Definition of done —</a:t>
+            </a:r>
+            <a:r>
+              <a:rPr sz="2100" b="0">
                 <a:solidFill>
                   <a:srgbClr val="14182B"/>
                 </a:solidFill>
               </a:rPr>
-              <a:t>Full pipeline test; hardware integration spike</a:t>
-            </a:r>
-          </a:p>
-        </p:txBody>
-      </p:sp>
-      <p:sp>
-        <p:nvSpPr>
-          <p:cNvPr id="13" name="TextBox 12"/>
-          <p:cNvSpPr txBox="1"/>
-          <p:nvPr/>
-        </p:nvSpPr>
-        <p:spPr>
-          <a:xfrm>
-            <a:off x="685800" y="4599432"/>
-            <a:ext cx="2377440" cy="594360"/>
-          </a:xfrm>
-          <a:prstGeom prst="rect">
-            <a:avLst/>
-          </a:prstGeom>
-          <a:noFill/>
-        </p:spPr>
-        <p:txBody>
-          <a:bodyPr wrap="none">
-            <a:spAutoFit/>
-          </a:bodyPr>
-          <a:lstStyle/>
-          <a:p>
-            <a:r>
-              <a:rPr sz="1900" b="1">
-                <a:solidFill>
-                  <a:srgbClr val="E05A2E"/>
-                </a:solidFill>
-              </a:rPr>
-              <a:t>Late Nov</a:t>
-            </a:r>
-          </a:p>
-        </p:txBody>
-      </p:sp>
-      <p:sp>
-        <p:nvSpPr>
-          <p:cNvPr id="14" name="TextBox 13"/>
-          <p:cNvSpPr txBox="1"/>
-          <p:nvPr/>
-        </p:nvSpPr>
-        <p:spPr>
-          <a:xfrm>
-            <a:off x="3200400" y="4599432"/>
-            <a:ext cx="8046720" cy="594360"/>
-          </a:xfrm>
-          <a:prstGeom prst="rect">
-            <a:avLst/>
-          </a:prstGeom>
-          <a:noFill/>
-        </p:spPr>
-        <p:txBody>
-          <a:bodyPr wrap="none">
-            <a:spAutoFit/>
-          </a:bodyPr>
-          <a:lstStyle/>
-          <a:p>
-            <a:r>
-              <a:rPr sz="1900" b="1">
-                <a:solidFill>
-                  <a:srgbClr val="14182B"/>
-                </a:solidFill>
-              </a:rPr>
-              <a:t>Stretch targets (Blender/Unreal, in-house client eval)</a:t>
-            </a:r>
-          </a:p>
-        </p:txBody>
-      </p:sp>
-      <p:sp>
-        <p:nvSpPr>
-          <p:cNvPr id="15" name="TextBox 14"/>
-          <p:cNvSpPr txBox="1"/>
-          <p:nvPr/>
-        </p:nvSpPr>
-        <p:spPr>
-          <a:xfrm>
-            <a:off x="685800" y="5349240"/>
-            <a:ext cx="2377440" cy="594360"/>
-          </a:xfrm>
-          <a:prstGeom prst="rect">
-            <a:avLst/>
-          </a:prstGeom>
-          <a:noFill/>
-        </p:spPr>
-        <p:txBody>
-          <a:bodyPr wrap="none">
-            <a:spAutoFit/>
-          </a:bodyPr>
-          <a:lstStyle/>
-          <a:p>
-            <a:r>
-              <a:rPr sz="1900" b="1">
-                <a:solidFill>
-                  <a:srgbClr val="E05A2E"/>
-                </a:solidFill>
-              </a:rPr>
-              <a:t>Early Dec</a:t>
-            </a:r>
-          </a:p>
-        </p:txBody>
-      </p:sp>
-      <p:sp>
-        <p:nvSpPr>
-          <p:cNvPr id="16" name="TextBox 15"/>
-          <p:cNvSpPr txBox="1"/>
-          <p:nvPr/>
-        </p:nvSpPr>
-        <p:spPr>
-          <a:xfrm>
-            <a:off x="3200400" y="5349240"/>
-            <a:ext cx="8046720" cy="594360"/>
-          </a:xfrm>
-          <a:prstGeom prst="rect">
-            <a:avLst/>
-          </a:prstGeom>
-          <a:noFill/>
-        </p:spPr>
-        <p:txBody>
-          <a:bodyPr wrap="none">
-            <a:spAutoFit/>
-          </a:bodyPr>
-          <a:lstStyle/>
-          <a:p>
-            <a:r>
-              <a:rPr sz="1900" b="1">
-                <a:solidFill>
-                  <a:srgbClr val="14182B"/>
-                </a:solidFill>
-              </a:rPr>
-              <a:t>Final demo + writeup</a:t>
+              <a:t>  a finished Unity game object with physics, rigging, and colliders already set up, ready to drop into a scene.</a:t>
             </a:r>
           </a:p>
         </p:txBody>
@@ -5281,7 +4949,7 @@
 </file>
 
 <file path=ppt/slides/slide16.xml><?xml version="1.0" encoding="utf-8"?>
-<p:sld xmlns:a="http://schemas.openxmlformats.org/drawingml/2006/main" xmlns:r="http://schemas.openxmlformats.org/officeDocument/2006/relationships" xmlns:p="http://schemas.openxmlformats.org/presentationml/2006/main">
+<p:sld xmlns:a="http://schemas.openxmlformats.org/drawingml/2006/main" xmlns:p="http://schemas.openxmlformats.org/presentationml/2006/main" xmlns:r="http://schemas.openxmlformats.org/officeDocument/2006/relationships">
   <p:cSld>
     <p:bg>
       <p:bgPr>
@@ -5297,14 +4965,7 @@
         <p:cNvGrpSpPr/>
         <p:nvPr/>
       </p:nvGrpSpPr>
-      <p:grpSpPr>
-        <a:xfrm>
-          <a:off x="0" y="0"/>
-          <a:ext cx="0" cy="0"/>
-          <a:chOff x="0" y="0"/>
-          <a:chExt cx="0" cy="0"/>
-        </a:xfrm>
-      </p:grpSpPr>
+      <p:grpSpPr/>
       <p:sp>
         <p:nvSpPr>
           <p:cNvPr id="2" name="Rectangle 1"/>
@@ -5345,7 +5006,6 @@
           <a:lstStyle/>
           <a:p>
             <a:pPr algn="ctr"/>
-            <a:endParaRPr/>
           </a:p>
         </p:txBody>
       </p:sp>
@@ -5377,7 +5037,7 @@
                   <a:srgbClr val="14182B"/>
                 </a:solidFill>
               </a:rPr>
-              <a:t>What We Expect to Learn</a:t>
+              <a:t>Timeline</a:t>
             </a:r>
           </a:p>
         </p:txBody>
@@ -5422,7 +5082,6 @@
           <a:lstStyle/>
           <a:p>
             <a:pPr algn="ctr"/>
-            <a:endParaRPr/>
           </a:p>
         </p:txBody>
       </p:sp>
@@ -5434,8 +5093,8 @@
         </p:nvSpPr>
         <p:spPr>
           <a:xfrm>
-            <a:off x="685800" y="1554480"/>
-            <a:ext cx="10607040" cy="4480560"/>
+            <a:off x="685800" y="1600200"/>
+            <a:ext cx="2377440" cy="594360"/>
           </a:xfrm>
           <a:prstGeom prst="rect">
             <a:avLst/>
@@ -5443,100 +5102,381 @@
           <a:noFill/>
         </p:spPr>
         <p:txBody>
-          <a:bodyPr wrap="square">
+          <a:bodyPr wrap="none">
             <a:spAutoFit/>
           </a:bodyPr>
           <a:lstStyle/>
           <a:p>
-            <a:pPr>
-              <a:spcAft>
-                <a:spcPts val="1400"/>
-              </a:spcAft>
-            </a:pPr>
-            <a:r>
-              <a:rPr sz="2100" b="1">
+            <a:r>
+              <a:rPr b="1" sz="1900">
                 <a:solidFill>
                   <a:srgbClr val="E05A2E"/>
                 </a:solidFill>
               </a:rPr>
-              <a:t>●  Generalization:</a:t>
-            </a:r>
-            <a:r>
-              <a:rPr sz="2100" b="0">
+              <a:t>Week of Sep 29</a:t>
+            </a:r>
+          </a:p>
+        </p:txBody>
+      </p:sp>
+      <p:sp>
+        <p:nvSpPr>
+          <p:cNvPr id="6" name="TextBox 5"/>
+          <p:cNvSpPr txBox="1"/>
+          <p:nvPr/>
+        </p:nvSpPr>
+        <p:spPr>
+          <a:xfrm>
+            <a:off x="3200400" y="1600200"/>
+            <a:ext cx="8046720" cy="594360"/>
+          </a:xfrm>
+          <a:prstGeom prst="rect">
+            <a:avLst/>
+          </a:prstGeom>
+          <a:noFill/>
+        </p:spPr>
+        <p:txBody>
+          <a:bodyPr wrap="none">
+            <a:spAutoFit/>
+          </a:bodyPr>
+          <a:lstStyle/>
+          <a:p>
+            <a:r>
+              <a:rPr sz="1900" b="1">
                 <a:solidFill>
                   <a:srgbClr val="14182B"/>
                 </a:solidFill>
               </a:rPr>
-              <a:t>  how well existing reconstruction/rigging tools hold up across object types they weren't built for.</a:t>
-            </a:r>
-          </a:p>
-          <a:p>
-            <a:pPr>
-              <a:spcAft>
-                <a:spcPts val="1400"/>
-              </a:spcAft>
-            </a:pPr>
-            <a:r>
-              <a:rPr sz="2100" b="1">
+              <a:t>Validate Meshy API end-to-end, lock MVP scope</a:t>
+            </a:r>
+          </a:p>
+        </p:txBody>
+      </p:sp>
+      <p:sp>
+        <p:nvSpPr>
+          <p:cNvPr id="7" name="TextBox 6"/>
+          <p:cNvSpPr txBox="1"/>
+          <p:nvPr/>
+        </p:nvSpPr>
+        <p:spPr>
+          <a:xfrm>
+            <a:off x="685800" y="2350008"/>
+            <a:ext cx="2377440" cy="594360"/>
+          </a:xfrm>
+          <a:prstGeom prst="rect">
+            <a:avLst/>
+          </a:prstGeom>
+          <a:noFill/>
+        </p:spPr>
+        <p:txBody>
+          <a:bodyPr wrap="none">
+            <a:spAutoFit/>
+          </a:bodyPr>
+          <a:lstStyle/>
+          <a:p>
+            <a:r>
+              <a:rPr b="1" sz="1900">
                 <a:solidFill>
                   <a:srgbClr val="E05A2E"/>
                 </a:solidFill>
               </a:rPr>
-              <a:t>●  Build vs. buy:</a:t>
-            </a:r>
-            <a:r>
-              <a:rPr sz="2100" b="0">
+              <a:t>October</a:t>
+            </a:r>
+          </a:p>
+        </p:txBody>
+      </p:sp>
+      <p:sp>
+        <p:nvSpPr>
+          <p:cNvPr id="8" name="TextBox 7"/>
+          <p:cNvSpPr txBox="1"/>
+          <p:nvPr/>
+        </p:nvSpPr>
+        <p:spPr>
+          <a:xfrm>
+            <a:off x="3200400" y="2350008"/>
+            <a:ext cx="8046720" cy="594360"/>
+          </a:xfrm>
+          <a:prstGeom prst="rect">
+            <a:avLst/>
+          </a:prstGeom>
+          <a:noFill/>
+        </p:spPr>
+        <p:txBody>
+          <a:bodyPr wrap="none">
+            <a:spAutoFit/>
+          </a:bodyPr>
+          <a:lstStyle/>
+          <a:p>
+            <a:r>
+              <a:rPr sz="1900" b="1">
                 <a:solidFill>
                   <a:srgbClr val="14182B"/>
                 </a:solidFill>
               </a:rPr>
-              <a:t>  whether an in-house client would ever pay off, or Meshy remains the right call.</a:t>
-            </a:r>
-          </a:p>
-          <a:p>
-            <a:pPr>
-              <a:spcAft>
-                <a:spcPts val="1400"/>
-              </a:spcAft>
-            </a:pPr>
-            <a:r>
-              <a:rPr sz="2100" b="1">
+              <a:t>Capture app, backend, classifier, desktop app</a:t>
+            </a:r>
+          </a:p>
+        </p:txBody>
+      </p:sp>
+      <p:sp>
+        <p:nvSpPr>
+          <p:cNvPr id="9" name="TextBox 8"/>
+          <p:cNvSpPr txBox="1"/>
+          <p:nvPr/>
+        </p:nvSpPr>
+        <p:spPr>
+          <a:xfrm>
+            <a:off x="685800" y="3099816"/>
+            <a:ext cx="2377440" cy="594360"/>
+          </a:xfrm>
+          <a:prstGeom prst="rect">
+            <a:avLst/>
+          </a:prstGeom>
+          <a:noFill/>
+        </p:spPr>
+        <p:txBody>
+          <a:bodyPr wrap="none">
+            <a:spAutoFit/>
+          </a:bodyPr>
+          <a:lstStyle/>
+          <a:p>
+            <a:r>
+              <a:rPr b="1" sz="1900">
                 <a:solidFill>
                   <a:srgbClr val="E05A2E"/>
                 </a:solidFill>
               </a:rPr>
-              <a:t>●  Hardware ROI:</a:t>
-            </a:r>
-            <a:r>
-              <a:rPr sz="2100" b="0">
+              <a:t>Early Nov</a:t>
+            </a:r>
+          </a:p>
+        </p:txBody>
+      </p:sp>
+      <p:sp>
+        <p:nvSpPr>
+          <p:cNvPr id="10" name="TextBox 9"/>
+          <p:cNvSpPr txBox="1"/>
+          <p:nvPr/>
+        </p:nvSpPr>
+        <p:spPr>
+          <a:xfrm>
+            <a:off x="3200400" y="3099816"/>
+            <a:ext cx="8046720" cy="594360"/>
+          </a:xfrm>
+          <a:prstGeom prst="rect">
+            <a:avLst/>
+          </a:prstGeom>
+          <a:noFill/>
+        </p:spPr>
+        <p:txBody>
+          <a:bodyPr wrap="none">
+            <a:spAutoFit/>
+          </a:bodyPr>
+          <a:lstStyle/>
+          <a:p>
+            <a:r>
+              <a:rPr sz="1900" b="1">
                 <a:solidFill>
                   <a:srgbClr val="14182B"/>
                 </a:solidFill>
               </a:rPr>
-              <a:t>  where richer capture (drone, LiDAR, thermal) meaningfully improves output vs. just adding complexity.</a:t>
-            </a:r>
-          </a:p>
-          <a:p>
-            <a:pPr>
-              <a:spcAft>
-                <a:spcPts val="1400"/>
-              </a:spcAft>
-            </a:pPr>
-            <a:r>
-              <a:rPr sz="2100" b="1">
+              <a:t>Unity import automation</a:t>
+            </a:r>
+          </a:p>
+        </p:txBody>
+      </p:sp>
+      <p:sp>
+        <p:nvSpPr>
+          <p:cNvPr id="11" name="TextBox 10"/>
+          <p:cNvSpPr txBox="1"/>
+          <p:nvPr/>
+        </p:nvSpPr>
+        <p:spPr>
+          <a:xfrm>
+            <a:off x="685800" y="3849624"/>
+            <a:ext cx="2377440" cy="594360"/>
+          </a:xfrm>
+          <a:prstGeom prst="rect">
+            <a:avLst/>
+          </a:prstGeom>
+          <a:noFill/>
+        </p:spPr>
+        <p:txBody>
+          <a:bodyPr wrap="none">
+            <a:spAutoFit/>
+          </a:bodyPr>
+          <a:lstStyle/>
+          <a:p>
+            <a:r>
+              <a:rPr b="1" sz="1900">
                 <a:solidFill>
                   <a:srgbClr val="E05A2E"/>
                 </a:solidFill>
               </a:rPr>
-              <a:t>●  Failure modes:</a:t>
-            </a:r>
-            <a:r>
-              <a:rPr sz="2100" b="0">
+              <a:t>Mid Nov</a:t>
+            </a:r>
+          </a:p>
+        </p:txBody>
+      </p:sp>
+      <p:sp>
+        <p:nvSpPr>
+          <p:cNvPr id="12" name="TextBox 11"/>
+          <p:cNvSpPr txBox="1"/>
+          <p:nvPr/>
+        </p:nvSpPr>
+        <p:spPr>
+          <a:xfrm>
+            <a:off x="3200400" y="3849624"/>
+            <a:ext cx="8046720" cy="594360"/>
+          </a:xfrm>
+          <a:prstGeom prst="rect">
+            <a:avLst/>
+          </a:prstGeom>
+          <a:noFill/>
+        </p:spPr>
+        <p:txBody>
+          <a:bodyPr wrap="none">
+            <a:spAutoFit/>
+          </a:bodyPr>
+          <a:lstStyle/>
+          <a:p>
+            <a:r>
+              <a:rPr sz="1900" b="1">
                 <a:solidFill>
                   <a:srgbClr val="14182B"/>
                 </a:solidFill>
               </a:rPr>
-              <a:t>  where the pipeline breaks most, and what that tells us about where to invest next.</a:t>
+              <a:t>Full pipeline test; hardware integration spike</a:t>
+            </a:r>
+          </a:p>
+        </p:txBody>
+      </p:sp>
+      <p:sp>
+        <p:nvSpPr>
+          <p:cNvPr id="13" name="TextBox 12"/>
+          <p:cNvSpPr txBox="1"/>
+          <p:nvPr/>
+        </p:nvSpPr>
+        <p:spPr>
+          <a:xfrm>
+            <a:off x="685800" y="4599432"/>
+            <a:ext cx="2377440" cy="594360"/>
+          </a:xfrm>
+          <a:prstGeom prst="rect">
+            <a:avLst/>
+          </a:prstGeom>
+          <a:noFill/>
+        </p:spPr>
+        <p:txBody>
+          <a:bodyPr wrap="none">
+            <a:spAutoFit/>
+          </a:bodyPr>
+          <a:lstStyle/>
+          <a:p>
+            <a:r>
+              <a:rPr b="1" sz="1900">
+                <a:solidFill>
+                  <a:srgbClr val="E05A2E"/>
+                </a:solidFill>
+              </a:rPr>
+              <a:t>Late Nov</a:t>
+            </a:r>
+          </a:p>
+        </p:txBody>
+      </p:sp>
+      <p:sp>
+        <p:nvSpPr>
+          <p:cNvPr id="14" name="TextBox 13"/>
+          <p:cNvSpPr txBox="1"/>
+          <p:nvPr/>
+        </p:nvSpPr>
+        <p:spPr>
+          <a:xfrm>
+            <a:off x="3200400" y="4599432"/>
+            <a:ext cx="8046720" cy="594360"/>
+          </a:xfrm>
+          <a:prstGeom prst="rect">
+            <a:avLst/>
+          </a:prstGeom>
+          <a:noFill/>
+        </p:spPr>
+        <p:txBody>
+          <a:bodyPr wrap="none">
+            <a:spAutoFit/>
+          </a:bodyPr>
+          <a:lstStyle/>
+          <a:p>
+            <a:r>
+              <a:rPr sz="1900" b="1">
+                <a:solidFill>
+                  <a:srgbClr val="14182B"/>
+                </a:solidFill>
+              </a:rPr>
+              <a:t>Stretch targets (Blender/Unreal, in-house client eval)</a:t>
+            </a:r>
+          </a:p>
+        </p:txBody>
+      </p:sp>
+      <p:sp>
+        <p:nvSpPr>
+          <p:cNvPr id="15" name="TextBox 14"/>
+          <p:cNvSpPr txBox="1"/>
+          <p:nvPr/>
+        </p:nvSpPr>
+        <p:spPr>
+          <a:xfrm>
+            <a:off x="685800" y="5349240"/>
+            <a:ext cx="2377440" cy="594360"/>
+          </a:xfrm>
+          <a:prstGeom prst="rect">
+            <a:avLst/>
+          </a:prstGeom>
+          <a:noFill/>
+        </p:spPr>
+        <p:txBody>
+          <a:bodyPr wrap="none">
+            <a:spAutoFit/>
+          </a:bodyPr>
+          <a:lstStyle/>
+          <a:p>
+            <a:r>
+              <a:rPr b="1" sz="1900">
+                <a:solidFill>
+                  <a:srgbClr val="E05A2E"/>
+                </a:solidFill>
+              </a:rPr>
+              <a:t>Early Dec</a:t>
+            </a:r>
+          </a:p>
+        </p:txBody>
+      </p:sp>
+      <p:sp>
+        <p:nvSpPr>
+          <p:cNvPr id="16" name="TextBox 15"/>
+          <p:cNvSpPr txBox="1"/>
+          <p:nvPr/>
+        </p:nvSpPr>
+        <p:spPr>
+          <a:xfrm>
+            <a:off x="3200400" y="5349240"/>
+            <a:ext cx="8046720" cy="594360"/>
+          </a:xfrm>
+          <a:prstGeom prst="rect">
+            <a:avLst/>
+          </a:prstGeom>
+          <a:noFill/>
+        </p:spPr>
+        <p:txBody>
+          <a:bodyPr wrap="none">
+            <a:spAutoFit/>
+          </a:bodyPr>
+          <a:lstStyle/>
+          <a:p>
+            <a:r>
+              <a:rPr sz="1900" b="1">
+                <a:solidFill>
+                  <a:srgbClr val="14182B"/>
+                </a:solidFill>
+              </a:rPr>
+              <a:t>Final demo + writeup</a:t>
             </a:r>
           </a:p>
         </p:txBody>
@@ -5550,7 +5490,7 @@
 </file>
 
 <file path=ppt/slides/slide17.xml><?xml version="1.0" encoding="utf-8"?>
-<p:sld xmlns:a="http://schemas.openxmlformats.org/drawingml/2006/main" xmlns:r="http://schemas.openxmlformats.org/officeDocument/2006/relationships" xmlns:p="http://schemas.openxmlformats.org/presentationml/2006/main">
+<p:sld xmlns:a="http://schemas.openxmlformats.org/drawingml/2006/main" xmlns:p="http://schemas.openxmlformats.org/presentationml/2006/main" xmlns:r="http://schemas.openxmlformats.org/officeDocument/2006/relationships">
   <p:cSld>
     <p:bg>
       <p:bgPr>
@@ -5566,14 +5506,7 @@
         <p:cNvGrpSpPr/>
         <p:nvPr/>
       </p:nvGrpSpPr>
-      <p:grpSpPr>
-        <a:xfrm>
-          <a:off x="0" y="0"/>
-          <a:ext cx="0" cy="0"/>
-          <a:chOff x="0" y="0"/>
-          <a:chExt cx="0" cy="0"/>
-        </a:xfrm>
-      </p:grpSpPr>
+      <p:grpSpPr/>
       <p:sp>
         <p:nvSpPr>
           <p:cNvPr id="2" name="Rectangle 1"/>
@@ -5614,7 +5547,6 @@
           <a:lstStyle/>
           <a:p>
             <a:pPr algn="ctr"/>
-            <a:endParaRPr/>
           </a:p>
         </p:txBody>
       </p:sp>
@@ -5646,7 +5578,7 @@
                   <a:srgbClr val="14182B"/>
                 </a:solidFill>
               </a:rPr>
-              <a:t>Team</a:t>
+              <a:t>What We Expect to Learn</a:t>
             </a:r>
           </a:p>
         </p:txBody>
@@ -5691,7 +5623,6 @@
           <a:lstStyle/>
           <a:p>
             <a:pPr algn="ctr"/>
-            <a:endParaRPr/>
           </a:p>
         </p:txBody>
       </p:sp>
@@ -5703,8 +5634,8 @@
         </p:nvSpPr>
         <p:spPr>
           <a:xfrm>
-            <a:off x="685800" y="1645920"/>
-            <a:ext cx="10607040" cy="1066959"/>
+            <a:off x="685800" y="1554480"/>
+            <a:ext cx="10607040" cy="4480560"/>
           </a:xfrm>
           <a:prstGeom prst="rect">
             <a:avLst/>
@@ -5719,55 +5650,93 @@
           <a:p>
             <a:pPr>
               <a:spcAft>
-                <a:spcPts val="1600"/>
+                <a:spcPts val="1400"/>
               </a:spcAft>
             </a:pPr>
             <a:r>
-              <a:rPr sz="2500" b="1" dirty="0">
+              <a:rPr sz="2100" b="1">
                 <a:solidFill>
                   <a:srgbClr val="E05A2E"/>
                 </a:solidFill>
               </a:rPr>
-              <a:t>●  Cesar Salcido</a:t>
-            </a:r>
-            <a:r>
-              <a:rPr sz="2500" b="0" dirty="0">
+              <a:t>●  Generalization:</a:t>
+            </a:r>
+            <a:r>
+              <a:rPr sz="2100" b="0">
                 <a:solidFill>
                   <a:srgbClr val="14182B"/>
                 </a:solidFill>
               </a:rPr>
-              <a:t>  — Phone/capture app + backend API</a:t>
+              <a:t>  how well existing reconstruction/rigging tools hold up across object types they weren't built for.</a:t>
             </a:r>
           </a:p>
           <a:p>
             <a:pPr>
               <a:spcAft>
-                <a:spcPts val="1600"/>
+                <a:spcPts val="1400"/>
               </a:spcAft>
             </a:pPr>
             <a:r>
-              <a:rPr sz="2500" b="1" dirty="0">
+              <a:rPr sz="2100" b="1">
                 <a:solidFill>
                   <a:srgbClr val="E05A2E"/>
                 </a:solidFill>
               </a:rPr>
-              <a:t>●  Daniel Silva</a:t>
-            </a:r>
-            <a:r>
-              <a:rPr lang="en-US" sz="2500" b="1" dirty="0">
+              <a:t>●  Build vs. buy:</a:t>
+            </a:r>
+            <a:r>
+              <a:rPr sz="2100" b="0">
+                <a:solidFill>
+                  <a:srgbClr val="14182B"/>
+                </a:solidFill>
+              </a:rPr>
+              <a:t>  whether an in-house client would ever pay off, or Meshy remains the right call.</a:t>
+            </a:r>
+          </a:p>
+          <a:p>
+            <a:pPr>
+              <a:spcAft>
+                <a:spcPts val="1400"/>
+              </a:spcAft>
+            </a:pPr>
+            <a:r>
+              <a:rPr sz="2100" b="1">
                 <a:solidFill>
                   <a:srgbClr val="E05A2E"/>
                 </a:solidFill>
               </a:rPr>
-              <a:t>s</a:t>
-            </a:r>
-            <a:r>
-              <a:rPr sz="2500" b="0" dirty="0">
+              <a:t>●  Hardware ROI:</a:t>
+            </a:r>
+            <a:r>
+              <a:rPr sz="2100" b="0">
                 <a:solidFill>
                   <a:srgbClr val="14182B"/>
                 </a:solidFill>
               </a:rPr>
-              <a:t>  — Desktop app GUI + Unity Editor package</a:t>
+              <a:t>  where richer capture (drone, LiDAR, thermal) meaningfully improves output vs. just adding complexity.</a:t>
+            </a:r>
+          </a:p>
+          <a:p>
+            <a:pPr>
+              <a:spcAft>
+                <a:spcPts val="1400"/>
+              </a:spcAft>
+            </a:pPr>
+            <a:r>
+              <a:rPr sz="2100" b="1">
+                <a:solidFill>
+                  <a:srgbClr val="E05A2E"/>
+                </a:solidFill>
+              </a:rPr>
+              <a:t>●  Failure modes:</a:t>
+            </a:r>
+            <a:r>
+              <a:rPr sz="2100" b="0">
+                <a:solidFill>
+                  <a:srgbClr val="14182B"/>
+                </a:solidFill>
+              </a:rPr>
+              <a:t>  where the pipeline breaks most, and what that tells us about where to invest next.</a:t>
             </a:r>
           </a:p>
         </p:txBody>
@@ -5781,7 +5750,221 @@
 </file>
 
 <file path=ppt/slides/slide18.xml><?xml version="1.0" encoding="utf-8"?>
-<p:sld xmlns:a="http://schemas.openxmlformats.org/drawingml/2006/main" xmlns:r="http://schemas.openxmlformats.org/officeDocument/2006/relationships" xmlns:p="http://schemas.openxmlformats.org/presentationml/2006/main">
+<p:sld xmlns:a="http://schemas.openxmlformats.org/drawingml/2006/main" xmlns:p="http://schemas.openxmlformats.org/presentationml/2006/main" xmlns:r="http://schemas.openxmlformats.org/officeDocument/2006/relationships">
+  <p:cSld>
+    <p:bg>
+      <p:bgPr>
+        <a:solidFill>
+          <a:srgbClr val="FFFFFF"/>
+        </a:solidFill>
+        <a:effectLst/>
+      </p:bgPr>
+    </p:bg>
+    <p:spTree>
+      <p:nvGrpSpPr>
+        <p:cNvPr id="1" name=""/>
+        <p:cNvGrpSpPr/>
+        <p:nvPr/>
+      </p:nvGrpSpPr>
+      <p:grpSpPr/>
+      <p:sp>
+        <p:nvSpPr>
+          <p:cNvPr id="2" name="Rectangle 1"/>
+          <p:cNvSpPr/>
+          <p:nvPr/>
+        </p:nvSpPr>
+        <p:spPr>
+          <a:xfrm>
+            <a:off x="0" y="0"/>
+            <a:ext cx="201168" cy="6858000"/>
+          </a:xfrm>
+          <a:prstGeom prst="rect">
+            <a:avLst/>
+          </a:prstGeom>
+          <a:solidFill>
+            <a:srgbClr val="E05A2E"/>
+          </a:solidFill>
+          <a:ln>
+            <a:noFill/>
+          </a:ln>
+        </p:spPr>
+        <p:style>
+          <a:lnRef idx="1">
+            <a:schemeClr val="accent1"/>
+          </a:lnRef>
+          <a:fillRef idx="3">
+            <a:schemeClr val="accent1"/>
+          </a:fillRef>
+          <a:effectRef idx="2">
+            <a:schemeClr val="accent1"/>
+          </a:effectRef>
+          <a:fontRef idx="minor">
+            <a:schemeClr val="lt1"/>
+          </a:fontRef>
+        </p:style>
+        <p:txBody>
+          <a:bodyPr rtlCol="0" anchor="ctr"/>
+          <a:lstStyle/>
+          <a:p>
+            <a:pPr algn="ctr"/>
+          </a:p>
+        </p:txBody>
+      </p:sp>
+      <p:sp>
+        <p:nvSpPr>
+          <p:cNvPr id="3" name="TextBox 2"/>
+          <p:cNvSpPr txBox="1"/>
+          <p:nvPr/>
+        </p:nvSpPr>
+        <p:spPr>
+          <a:xfrm>
+            <a:off x="640080" y="365760"/>
+            <a:ext cx="10881360" cy="914400"/>
+          </a:xfrm>
+          <a:prstGeom prst="rect">
+            <a:avLst/>
+          </a:prstGeom>
+          <a:noFill/>
+        </p:spPr>
+        <p:txBody>
+          <a:bodyPr wrap="none">
+            <a:spAutoFit/>
+          </a:bodyPr>
+          <a:lstStyle/>
+          <a:p>
+            <a:r>
+              <a:rPr sz="3400" b="1">
+                <a:solidFill>
+                  <a:srgbClr val="14182B"/>
+                </a:solidFill>
+              </a:rPr>
+              <a:t>Team</a:t>
+            </a:r>
+          </a:p>
+        </p:txBody>
+      </p:sp>
+      <p:sp>
+        <p:nvSpPr>
+          <p:cNvPr id="4" name="Rectangle 3"/>
+          <p:cNvSpPr/>
+          <p:nvPr/>
+        </p:nvSpPr>
+        <p:spPr>
+          <a:xfrm>
+            <a:off x="658368" y="1170432"/>
+            <a:ext cx="1463040" cy="50800"/>
+          </a:xfrm>
+          <a:prstGeom prst="rect">
+            <a:avLst/>
+          </a:prstGeom>
+          <a:solidFill>
+            <a:srgbClr val="E05A2E"/>
+          </a:solidFill>
+          <a:ln>
+            <a:noFill/>
+          </a:ln>
+        </p:spPr>
+        <p:style>
+          <a:lnRef idx="1">
+            <a:schemeClr val="accent1"/>
+          </a:lnRef>
+          <a:fillRef idx="3">
+            <a:schemeClr val="accent1"/>
+          </a:fillRef>
+          <a:effectRef idx="2">
+            <a:schemeClr val="accent1"/>
+          </a:effectRef>
+          <a:fontRef idx="minor">
+            <a:schemeClr val="lt1"/>
+          </a:fontRef>
+        </p:style>
+        <p:txBody>
+          <a:bodyPr rtlCol="0" anchor="ctr"/>
+          <a:lstStyle/>
+          <a:p>
+            <a:pPr algn="ctr"/>
+          </a:p>
+        </p:txBody>
+      </p:sp>
+      <p:sp>
+        <p:nvSpPr>
+          <p:cNvPr id="5" name="TextBox 4"/>
+          <p:cNvSpPr txBox="1"/>
+          <p:nvPr/>
+        </p:nvSpPr>
+        <p:spPr>
+          <a:xfrm>
+            <a:off x="685800" y="1645920"/>
+            <a:ext cx="10607040" cy="3931920"/>
+          </a:xfrm>
+          <a:prstGeom prst="rect">
+            <a:avLst/>
+          </a:prstGeom>
+          <a:noFill/>
+        </p:spPr>
+        <p:txBody>
+          <a:bodyPr wrap="square">
+            <a:spAutoFit/>
+          </a:bodyPr>
+          <a:lstStyle/>
+          <a:p>
+            <a:pPr>
+              <a:spcAft>
+                <a:spcPts val="1600"/>
+              </a:spcAft>
+            </a:pPr>
+            <a:r>
+              <a:rPr sz="2500" b="1">
+                <a:solidFill>
+                  <a:srgbClr val="E05A2E"/>
+                </a:solidFill>
+              </a:rPr>
+              <a:t>●  Cesar Salcido</a:t>
+            </a:r>
+            <a:r>
+              <a:rPr sz="2500" b="0">
+                <a:solidFill>
+                  <a:srgbClr val="14182B"/>
+                </a:solidFill>
+              </a:rPr>
+              <a:t>  — Phone/capture app + backend API</a:t>
+            </a:r>
+          </a:p>
+          <a:p>
+            <a:pPr>
+              <a:spcAft>
+                <a:spcPts val="1600"/>
+              </a:spcAft>
+            </a:pPr>
+            <a:r>
+              <a:rPr sz="2500" b="1">
+                <a:solidFill>
+                  <a:srgbClr val="E05A2E"/>
+                </a:solidFill>
+              </a:rPr>
+              <a:t>●  Daniel Silvas</a:t>
+            </a:r>
+            <a:r>
+              <a:rPr sz="2500" b="0">
+                <a:solidFill>
+                  <a:srgbClr val="14182B"/>
+                </a:solidFill>
+              </a:rPr>
+              <a:t>  — Desktop app GUI + Unity Editor package</a:t>
+            </a:r>
+          </a:p>
+        </p:txBody>
+      </p:sp>
+    </p:spTree>
+  </p:cSld>
+  <p:clrMapOvr>
+    <a:masterClrMapping/>
+  </p:clrMapOvr>
+</p:sld>
+</file>
+
+<file path=ppt/slides/slide19.xml><?xml version="1.0" encoding="utf-8"?>
+<p:sld xmlns:a="http://schemas.openxmlformats.org/drawingml/2006/main" xmlns:p="http://schemas.openxmlformats.org/presentationml/2006/main" xmlns:r="http://schemas.openxmlformats.org/officeDocument/2006/relationships">
   <p:cSld>
     <p:bg>
       <p:bgPr>
@@ -5797,14 +5980,7 @@
         <p:cNvGrpSpPr/>
         <p:nvPr/>
       </p:nvGrpSpPr>
-      <p:grpSpPr>
-        <a:xfrm>
-          <a:off x="0" y="0"/>
-          <a:ext cx="0" cy="0"/>
-          <a:chOff x="0" y="0"/>
-          <a:chExt cx="0" cy="0"/>
-        </a:xfrm>
-      </p:grpSpPr>
+      <p:grpSpPr/>
       <p:sp>
         <p:nvSpPr>
           <p:cNvPr id="2" name="TextBox 1"/>
@@ -5880,7 +6056,7 @@
 </file>
 
 <file path=ppt/slides/slide2.xml><?xml version="1.0" encoding="utf-8"?>
-<p:sld xmlns:a="http://schemas.openxmlformats.org/drawingml/2006/main" xmlns:r="http://schemas.openxmlformats.org/officeDocument/2006/relationships" xmlns:p="http://schemas.openxmlformats.org/presentationml/2006/main">
+<p:sld xmlns:a="http://schemas.openxmlformats.org/drawingml/2006/main" xmlns:p="http://schemas.openxmlformats.org/presentationml/2006/main" xmlns:r="http://schemas.openxmlformats.org/officeDocument/2006/relationships">
   <p:cSld>
     <p:bg>
       <p:bgPr>
@@ -5896,14 +6072,7 @@
         <p:cNvGrpSpPr/>
         <p:nvPr/>
       </p:nvGrpSpPr>
-      <p:grpSpPr>
-        <a:xfrm>
-          <a:off x="0" y="0"/>
-          <a:ext cx="0" cy="0"/>
-          <a:chOff x="0" y="0"/>
-          <a:chExt cx="0" cy="0"/>
-        </a:xfrm>
-      </p:grpSpPr>
+      <p:grpSpPr/>
       <p:sp>
         <p:nvSpPr>
           <p:cNvPr id="2" name="Rectangle 1"/>
@@ -5944,7 +6113,6 @@
           <a:lstStyle/>
           <a:p>
             <a:pPr algn="ctr"/>
-            <a:endParaRPr/>
           </a:p>
         </p:txBody>
       </p:sp>
@@ -6021,7 +6189,6 @@
           <a:lstStyle/>
           <a:p>
             <a:pPr algn="ctr"/>
-            <a:endParaRPr/>
           </a:p>
         </p:txBody>
       </p:sp>
@@ -6149,7 +6316,7 @@
 </file>
 
 <file path=ppt/slides/slide3.xml><?xml version="1.0" encoding="utf-8"?>
-<p:sld xmlns:a="http://schemas.openxmlformats.org/drawingml/2006/main" xmlns:r="http://schemas.openxmlformats.org/officeDocument/2006/relationships" xmlns:p="http://schemas.openxmlformats.org/presentationml/2006/main">
+<p:sld xmlns:a="http://schemas.openxmlformats.org/drawingml/2006/main" xmlns:p="http://schemas.openxmlformats.org/presentationml/2006/main" xmlns:r="http://schemas.openxmlformats.org/officeDocument/2006/relationships">
   <p:cSld>
     <p:bg>
       <p:bgPr>
@@ -6165,14 +6332,7 @@
         <p:cNvGrpSpPr/>
         <p:nvPr/>
       </p:nvGrpSpPr>
-      <p:grpSpPr>
-        <a:xfrm>
-          <a:off x="0" y="0"/>
-          <a:ext cx="0" cy="0"/>
-          <a:chOff x="0" y="0"/>
-          <a:chExt cx="0" cy="0"/>
-        </a:xfrm>
-      </p:grpSpPr>
+      <p:grpSpPr/>
       <p:sp>
         <p:nvSpPr>
           <p:cNvPr id="2" name="Rectangle 1"/>
@@ -6213,7 +6373,6 @@
           <a:lstStyle/>
           <a:p>
             <a:pPr algn="ctr"/>
-            <a:endParaRPr/>
           </a:p>
         </p:txBody>
       </p:sp>
@@ -6290,7 +6449,6 @@
           <a:lstStyle/>
           <a:p>
             <a:pPr algn="ctr"/>
-            <a:endParaRPr/>
           </a:p>
         </p:txBody>
       </p:sp>
@@ -6395,7 +6553,7 @@
 </file>
 
 <file path=ppt/slides/slide4.xml><?xml version="1.0" encoding="utf-8"?>
-<p:sld xmlns:a="http://schemas.openxmlformats.org/drawingml/2006/main" xmlns:r="http://schemas.openxmlformats.org/officeDocument/2006/relationships" xmlns:p="http://schemas.openxmlformats.org/presentationml/2006/main">
+<p:sld xmlns:a="http://schemas.openxmlformats.org/drawingml/2006/main" xmlns:p="http://schemas.openxmlformats.org/presentationml/2006/main" xmlns:r="http://schemas.openxmlformats.org/officeDocument/2006/relationships">
   <p:cSld>
     <p:bg>
       <p:bgPr>
@@ -6411,14 +6569,7 @@
         <p:cNvGrpSpPr/>
         <p:nvPr/>
       </p:nvGrpSpPr>
-      <p:grpSpPr>
-        <a:xfrm>
-          <a:off x="0" y="0"/>
-          <a:ext cx="0" cy="0"/>
-          <a:chOff x="0" y="0"/>
-          <a:chExt cx="0" cy="0"/>
-        </a:xfrm>
-      </p:grpSpPr>
+      <p:grpSpPr/>
       <p:sp>
         <p:nvSpPr>
           <p:cNvPr id="2" name="Rectangle 1"/>
@@ -6459,7 +6610,6 @@
           <a:lstStyle/>
           <a:p>
             <a:pPr algn="ctr"/>
-            <a:endParaRPr/>
           </a:p>
         </p:txBody>
       </p:sp>
@@ -6538,7 +6688,7 @@
 </file>
 
 <file path=ppt/slides/slide5.xml><?xml version="1.0" encoding="utf-8"?>
-<p:sld xmlns:a="http://schemas.openxmlformats.org/drawingml/2006/main" xmlns:r="http://schemas.openxmlformats.org/officeDocument/2006/relationships" xmlns:p="http://schemas.openxmlformats.org/presentationml/2006/main">
+<p:sld xmlns:a="http://schemas.openxmlformats.org/drawingml/2006/main" xmlns:p="http://schemas.openxmlformats.org/presentationml/2006/main" xmlns:r="http://schemas.openxmlformats.org/officeDocument/2006/relationships">
   <p:cSld>
     <p:bg>
       <p:bgPr>
@@ -6554,14 +6704,7 @@
         <p:cNvGrpSpPr/>
         <p:nvPr/>
       </p:nvGrpSpPr>
-      <p:grpSpPr>
-        <a:xfrm>
-          <a:off x="0" y="0"/>
-          <a:ext cx="0" cy="0"/>
-          <a:chOff x="0" y="0"/>
-          <a:chExt cx="0" cy="0"/>
-        </a:xfrm>
-      </p:grpSpPr>
+      <p:grpSpPr/>
       <p:sp>
         <p:nvSpPr>
           <p:cNvPr id="2" name="Rectangle 1"/>
@@ -6602,7 +6745,6 @@
           <a:lstStyle/>
           <a:p>
             <a:pPr algn="ctr"/>
-            <a:endParaRPr/>
           </a:p>
         </p:txBody>
       </p:sp>
@@ -6679,7 +6821,6 @@
           <a:lstStyle/>
           <a:p>
             <a:pPr algn="ctr"/>
-            <a:endParaRPr/>
           </a:p>
         </p:txBody>
       </p:sp>
@@ -6784,7 +6925,7 @@
 </file>
 
 <file path=ppt/slides/slide6.xml><?xml version="1.0" encoding="utf-8"?>
-<p:sld xmlns:a="http://schemas.openxmlformats.org/drawingml/2006/main" xmlns:r="http://schemas.openxmlformats.org/officeDocument/2006/relationships" xmlns:p="http://schemas.openxmlformats.org/presentationml/2006/main">
+<p:sld xmlns:a="http://schemas.openxmlformats.org/drawingml/2006/main" xmlns:p="http://schemas.openxmlformats.org/presentationml/2006/main" xmlns:r="http://schemas.openxmlformats.org/officeDocument/2006/relationships">
   <p:cSld>
     <p:bg>
       <p:bgPr>
@@ -6800,14 +6941,7 @@
         <p:cNvGrpSpPr/>
         <p:nvPr/>
       </p:nvGrpSpPr>
-      <p:grpSpPr>
-        <a:xfrm>
-          <a:off x="0" y="0"/>
-          <a:ext cx="0" cy="0"/>
-          <a:chOff x="0" y="0"/>
-          <a:chExt cx="0" cy="0"/>
-        </a:xfrm>
-      </p:grpSpPr>
+      <p:grpSpPr/>
       <p:sp>
         <p:nvSpPr>
           <p:cNvPr id="2" name="Rectangle 1"/>
@@ -6848,7 +6982,6 @@
           <a:lstStyle/>
           <a:p>
             <a:pPr algn="ctr"/>
-            <a:endParaRPr/>
           </a:p>
         </p:txBody>
       </p:sp>
@@ -6925,7 +7058,6 @@
           <a:lstStyle/>
           <a:p>
             <a:pPr algn="ctr"/>
-            <a:endParaRPr/>
           </a:p>
         </p:txBody>
       </p:sp>
@@ -7053,7 +7185,7 @@
 </file>
 
 <file path=ppt/slides/slide7.xml><?xml version="1.0" encoding="utf-8"?>
-<p:sld xmlns:a="http://schemas.openxmlformats.org/drawingml/2006/main" xmlns:r="http://schemas.openxmlformats.org/officeDocument/2006/relationships" xmlns:p="http://schemas.openxmlformats.org/presentationml/2006/main">
+<p:sld xmlns:a="http://schemas.openxmlformats.org/drawingml/2006/main" xmlns:p="http://schemas.openxmlformats.org/presentationml/2006/main" xmlns:r="http://schemas.openxmlformats.org/officeDocument/2006/relationships">
   <p:cSld>
     <p:bg>
       <p:bgPr>
@@ -7069,14 +7201,7 @@
         <p:cNvGrpSpPr/>
         <p:nvPr/>
       </p:nvGrpSpPr>
-      <p:grpSpPr>
-        <a:xfrm>
-          <a:off x="0" y="0"/>
-          <a:ext cx="0" cy="0"/>
-          <a:chOff x="0" y="0"/>
-          <a:chExt cx="0" cy="0"/>
-        </a:xfrm>
-      </p:grpSpPr>
+      <p:grpSpPr/>
       <p:sp>
         <p:nvSpPr>
           <p:cNvPr id="2" name="Rectangle 1"/>
@@ -7117,7 +7242,6 @@
           <a:lstStyle/>
           <a:p>
             <a:pPr algn="ctr"/>
-            <a:endParaRPr/>
           </a:p>
         </p:txBody>
       </p:sp>
@@ -7194,7 +7318,6 @@
           <a:lstStyle/>
           <a:p>
             <a:pPr algn="ctr"/>
-            <a:endParaRPr/>
           </a:p>
         </p:txBody>
       </p:sp>
@@ -7322,7 +7445,7 @@
 </file>
 
 <file path=ppt/slides/slide8.xml><?xml version="1.0" encoding="utf-8"?>
-<p:sld xmlns:a="http://schemas.openxmlformats.org/drawingml/2006/main" xmlns:r="http://schemas.openxmlformats.org/officeDocument/2006/relationships" xmlns:p="http://schemas.openxmlformats.org/presentationml/2006/main">
+<p:sld xmlns:a="http://schemas.openxmlformats.org/drawingml/2006/main" xmlns:p="http://schemas.openxmlformats.org/presentationml/2006/main" xmlns:r="http://schemas.openxmlformats.org/officeDocument/2006/relationships">
   <p:cSld>
     <p:bg>
       <p:bgPr>
@@ -7338,14 +7461,7 @@
         <p:cNvGrpSpPr/>
         <p:nvPr/>
       </p:nvGrpSpPr>
-      <p:grpSpPr>
-        <a:xfrm>
-          <a:off x="0" y="0"/>
-          <a:ext cx="0" cy="0"/>
-          <a:chOff x="0" y="0"/>
-          <a:chExt cx="0" cy="0"/>
-        </a:xfrm>
-      </p:grpSpPr>
+      <p:grpSpPr/>
       <p:sp>
         <p:nvSpPr>
           <p:cNvPr id="2" name="Rectangle 1"/>
@@ -7386,7 +7502,6 @@
           <a:lstStyle/>
           <a:p>
             <a:pPr algn="ctr"/>
-            <a:endParaRPr/>
           </a:p>
         </p:txBody>
       </p:sp>
@@ -7463,7 +7578,6 @@
           <a:lstStyle/>
           <a:p>
             <a:pPr algn="ctr"/>
-            <a:endParaRPr/>
           </a:p>
         </p:txBody>
       </p:sp>
@@ -7591,7 +7705,7 @@
 </file>
 
 <file path=ppt/slides/slide9.xml><?xml version="1.0" encoding="utf-8"?>
-<p:sld xmlns:a="http://schemas.openxmlformats.org/drawingml/2006/main" xmlns:r="http://schemas.openxmlformats.org/officeDocument/2006/relationships" xmlns:p="http://schemas.openxmlformats.org/presentationml/2006/main">
+<p:sld xmlns:a="http://schemas.openxmlformats.org/drawingml/2006/main" xmlns:p="http://schemas.openxmlformats.org/presentationml/2006/main" xmlns:r="http://schemas.openxmlformats.org/officeDocument/2006/relationships">
   <p:cSld>
     <p:bg>
       <p:bgPr>
@@ -7607,14 +7721,7 @@
         <p:cNvGrpSpPr/>
         <p:nvPr/>
       </p:nvGrpSpPr>
-      <p:grpSpPr>
-        <a:xfrm>
-          <a:off x="0" y="0"/>
-          <a:ext cx="0" cy="0"/>
-          <a:chOff x="0" y="0"/>
-          <a:chExt cx="0" cy="0"/>
-        </a:xfrm>
-      </p:grpSpPr>
+      <p:grpSpPr/>
       <p:sp>
         <p:nvSpPr>
           <p:cNvPr id="2" name="Rectangle 1"/>
@@ -7655,7 +7762,6 @@
           <a:lstStyle/>
           <a:p>
             <a:pPr algn="ctr"/>
-            <a:endParaRPr/>
           </a:p>
         </p:txBody>
       </p:sp>
@@ -7732,7 +7838,6 @@
           <a:lstStyle/>
           <a:p>
             <a:pPr algn="ctr"/>
-            <a:endParaRPr/>
           </a:p>
         </p:txBody>
       </p:sp>
@@ -7851,7 +7956,7 @@
           <a:lstStyle/>
           <a:p>
             <a:r>
-              <a:rPr sz="1400" b="1" i="1">
+              <a:rPr sz="1400" i="1" b="1">
                 <a:solidFill>
                   <a:srgbClr val="993300"/>
                 </a:solidFill>

</xml_diff>

<commit_message>
Add clickable inline citations and a References slide to the deck
</commit_message>
<xml_diff>
--- a/presentation.pptx
+++ b/presentation.pptx
@@ -24,6 +24,7 @@
     <p:sldId id="272" r:id="rId23"/>
     <p:sldId id="273" r:id="rId24"/>
     <p:sldId id="274" r:id="rId25"/>
+    <p:sldId id="275" r:id="rId26"/>
   </p:sldIdLst>
   <p:sldSz cx="12191695" cy="6858000" type="screen4x3"/>
   <p:notesSz cx="6858000" cy="9144000"/>
@@ -4049,7 +4050,7 @@
           <a:p>
             <a:pPr>
               <a:spcAft>
-                <a:spcPts val="1300"/>
+                <a:spcPts val="1400"/>
               </a:spcAft>
             </a:pPr>
             <a:r>
@@ -4072,7 +4073,7 @@
           <a:p>
             <a:pPr>
               <a:spcAft>
-                <a:spcPts val="1300"/>
+                <a:spcPts val="1400"/>
               </a:spcAft>
             </a:pPr>
             <a:r>
@@ -4091,11 +4092,20 @@
               </a:rPr>
               <a:t>  diffusion model reads shape/material/depth from the photo, then multi-view synthesis predicts the angles the photo never showed.</a:t>
             </a:r>
+            <a:r>
+              <a:rPr sz="1400" b="1">
+                <a:solidFill>
+                  <a:srgbClr val="1F5C9E"/>
+                </a:solidFill>
+                <a:hlinkClick r:id="rId2"/>
+              </a:rPr>
+              <a:t> [1]</a:t>
+            </a:r>
           </a:p>
           <a:p>
             <a:pPr>
               <a:spcAft>
-                <a:spcPts val="1300"/>
+                <a:spcPts val="1400"/>
               </a:spcAft>
             </a:pPr>
             <a:r>
@@ -4114,11 +4124,20 @@
               </a:rPr>
               <a:t>  detects body plan (humanoid/quadruped/custom), builds bone hierarchy, computes skinning weights automatically.</a:t>
             </a:r>
+            <a:r>
+              <a:rPr sz="1400" b="1">
+                <a:solidFill>
+                  <a:srgbClr val="1F5C9E"/>
+                </a:solidFill>
+                <a:hlinkClick r:id="rId3"/>
+              </a:rPr>
+              <a:t> [2]</a:t>
+            </a:r>
           </a:p>
           <a:p>
             <a:pPr>
               <a:spcAft>
-                <a:spcPts val="1300"/>
+                <a:spcPts val="1400"/>
               </a:spcAft>
             </a:pPr>
             <a:r>
@@ -4136,6 +4155,39 @@
                 </a:solidFill>
               </a:rPr>
               <a:t>  photogrammetry or NeRF-based reconstruction, benchmarked against Meshy's output.</a:t>
+            </a:r>
+          </a:p>
+        </p:txBody>
+      </p:sp>
+      <p:sp>
+        <p:nvSpPr>
+          <p:cNvPr id="6" name="TextBox 5"/>
+          <p:cNvSpPr txBox="1"/>
+          <p:nvPr/>
+        </p:nvSpPr>
+        <p:spPr>
+          <a:xfrm>
+            <a:off x="640080" y="6309360"/>
+            <a:ext cx="10881360" cy="457200"/>
+          </a:xfrm>
+          <a:prstGeom prst="rect">
+            <a:avLst/>
+          </a:prstGeom>
+          <a:noFill/>
+        </p:spPr>
+        <p:txBody>
+          <a:bodyPr wrap="none">
+            <a:spAutoFit/>
+          </a:bodyPr>
+          <a:lstStyle/>
+          <a:p>
+            <a:r>
+              <a:rPr sz="1100" i="1">
+                <a:solidFill>
+                  <a:srgbClr val="4A4A4A"/>
+                </a:solidFill>
+              </a:rPr>
+              <a:t>Click [n] to open the source · full list on the References slide</a:t>
             </a:r>
           </a:p>
         </p:txBody>
@@ -4309,7 +4361,7 @@
           <a:p>
             <a:pPr>
               <a:spcAft>
-                <a:spcPts val="1300"/>
+                <a:spcPts val="1400"/>
               </a:spcAft>
             </a:pPr>
             <a:r>
@@ -4328,11 +4380,29 @@
               </a:rPr>
               <a:t>  ~90 seconds for a full textured model on Meshy 7; auto-rigging adds under 30 seconds.</a:t>
             </a:r>
+            <a:r>
+              <a:rPr sz="1400" b="1">
+                <a:solidFill>
+                  <a:srgbClr val="1F5C9E"/>
+                </a:solidFill>
+                <a:hlinkClick r:id="rId2"/>
+              </a:rPr>
+              <a:t> [1]</a:t>
+            </a:r>
+            <a:r>
+              <a:rPr sz="1400" b="1">
+                <a:solidFill>
+                  <a:srgbClr val="1F5C9E"/>
+                </a:solidFill>
+                <a:hlinkClick r:id="rId3"/>
+              </a:rPr>
+              <a:t> [2]</a:t>
+            </a:r>
           </a:p>
           <a:p>
             <a:pPr>
               <a:spcAft>
-                <a:spcPts val="1300"/>
+                <a:spcPts val="1400"/>
               </a:spcAft>
             </a:pPr>
             <a:r>
@@ -4351,11 +4421,20 @@
               </a:rPr>
               <a:t>  Meshy 7 leads published single-view reconstruction scores against Tripo 3.1 and Rodin 2.5 — 81.0% overall shape accuracy, 59.8% on surface detail.</a:t>
             </a:r>
+            <a:r>
+              <a:rPr sz="1400" b="1">
+                <a:solidFill>
+                  <a:srgbClr val="1F5C9E"/>
+                </a:solidFill>
+                <a:hlinkClick r:id="rId4"/>
+              </a:rPr>
+              <a:t> [3]</a:t>
+            </a:r>
           </a:p>
           <a:p>
             <a:pPr>
               <a:spcAft>
-                <a:spcPts val="1300"/>
+                <a:spcPts val="1400"/>
               </a:spcAft>
             </a:pPr>
             <a:r>
@@ -4374,11 +4453,29 @@
               </a:rPr>
               <a:t>  20-30 credits per generation (~$0.60/model); API access needs the Pro tier, $20/mo for 1,000 credits — about 30-50 generations/month.</a:t>
             </a:r>
+            <a:r>
+              <a:rPr sz="1400" b="1">
+                <a:solidFill>
+                  <a:srgbClr val="1F5C9E"/>
+                </a:solidFill>
+                <a:hlinkClick r:id="rId5"/>
+              </a:rPr>
+              <a:t> [4]</a:t>
+            </a:r>
+            <a:r>
+              <a:rPr sz="1400" b="1">
+                <a:solidFill>
+                  <a:srgbClr val="1F5C9E"/>
+                </a:solidFill>
+                <a:hlinkClick r:id="rId6"/>
+              </a:rPr>
+              <a:t> [5]</a:t>
+            </a:r>
           </a:p>
           <a:p>
             <a:pPr>
               <a:spcAft>
-                <a:spcPts val="1300"/>
+                <a:spcPts val="1400"/>
               </a:spcAft>
             </a:pPr>
             <a:r>
@@ -4428,7 +4525,7 @@
                   <a:srgbClr val="4A4A4A"/>
                 </a:solidFill>
               </a:rPr>
-              <a:t>Sources: meshy.ai/features/image-to-3d · meshy.ai/features/ai-auto-rigging · framesixty.com Meshy review · docs.meshy.ai</a:t>
+              <a:t>Click [n] to open the source · full list on the References slide</a:t>
             </a:r>
           </a:p>
         </p:txBody>
@@ -5969,7 +6066,7 @@
     <p:bg>
       <p:bgPr>
         <a:solidFill>
-          <a:srgbClr val="14182B"/>
+          <a:srgbClr val="FFFFFF"/>
         </a:solidFill>
         <a:effectLst/>
       </p:bgPr>
@@ -5983,14 +6080,57 @@
       <p:grpSpPr/>
       <p:sp>
         <p:nvSpPr>
-          <p:cNvPr id="2" name="TextBox 1"/>
+          <p:cNvPr id="2" name="Rectangle 1"/>
+          <p:cNvSpPr/>
+          <p:nvPr/>
+        </p:nvSpPr>
+        <p:spPr>
+          <a:xfrm>
+            <a:off x="0" y="0"/>
+            <a:ext cx="201168" cy="6858000"/>
+          </a:xfrm>
+          <a:prstGeom prst="rect">
+            <a:avLst/>
+          </a:prstGeom>
+          <a:solidFill>
+            <a:srgbClr val="E05A2E"/>
+          </a:solidFill>
+          <a:ln>
+            <a:noFill/>
+          </a:ln>
+        </p:spPr>
+        <p:style>
+          <a:lnRef idx="1">
+            <a:schemeClr val="accent1"/>
+          </a:lnRef>
+          <a:fillRef idx="3">
+            <a:schemeClr val="accent1"/>
+          </a:fillRef>
+          <a:effectRef idx="2">
+            <a:schemeClr val="accent1"/>
+          </a:effectRef>
+          <a:fontRef idx="minor">
+            <a:schemeClr val="lt1"/>
+          </a:fontRef>
+        </p:style>
+        <p:txBody>
+          <a:bodyPr rtlCol="0" anchor="ctr"/>
+          <a:lstStyle/>
+          <a:p>
+            <a:pPr algn="ctr"/>
+          </a:p>
+        </p:txBody>
+      </p:sp>
+      <p:sp>
+        <p:nvSpPr>
+          <p:cNvPr id="3" name="TextBox 2"/>
           <p:cNvSpPr txBox="1"/>
           <p:nvPr/>
         </p:nvSpPr>
         <p:spPr>
           <a:xfrm>
-            <a:off x="822960" y="2743200"/>
-            <a:ext cx="10515600" cy="1005840"/>
+            <a:off x="640080" y="365760"/>
+            <a:ext cx="10881360" cy="914400"/>
           </a:xfrm>
           <a:prstGeom prst="rect">
             <a:avLst/>
@@ -6004,26 +6144,69 @@
           <a:lstStyle/>
           <a:p>
             <a:r>
-              <a:rPr sz="4200" b="1">
-                <a:solidFill>
-                  <a:srgbClr val="FFFFFF"/>
-                </a:solidFill>
-              </a:rPr>
-              <a:t>Questions?</a:t>
-            </a:r>
-          </a:p>
-        </p:txBody>
-      </p:sp>
-      <p:sp>
-        <p:nvSpPr>
-          <p:cNvPr id="3" name="TextBox 2"/>
+              <a:rPr sz="3400" b="1">
+                <a:solidFill>
+                  <a:srgbClr val="14182B"/>
+                </a:solidFill>
+              </a:rPr>
+              <a:t>References</a:t>
+            </a:r>
+          </a:p>
+        </p:txBody>
+      </p:sp>
+      <p:sp>
+        <p:nvSpPr>
+          <p:cNvPr id="4" name="Rectangle 3"/>
+          <p:cNvSpPr/>
+          <p:nvPr/>
+        </p:nvSpPr>
+        <p:spPr>
+          <a:xfrm>
+            <a:off x="658368" y="1170432"/>
+            <a:ext cx="1463040" cy="50800"/>
+          </a:xfrm>
+          <a:prstGeom prst="rect">
+            <a:avLst/>
+          </a:prstGeom>
+          <a:solidFill>
+            <a:srgbClr val="E05A2E"/>
+          </a:solidFill>
+          <a:ln>
+            <a:noFill/>
+          </a:ln>
+        </p:spPr>
+        <p:style>
+          <a:lnRef idx="1">
+            <a:schemeClr val="accent1"/>
+          </a:lnRef>
+          <a:fillRef idx="3">
+            <a:schemeClr val="accent1"/>
+          </a:fillRef>
+          <a:effectRef idx="2">
+            <a:schemeClr val="accent1"/>
+          </a:effectRef>
+          <a:fontRef idx="minor">
+            <a:schemeClr val="lt1"/>
+          </a:fontRef>
+        </p:style>
+        <p:txBody>
+          <a:bodyPr rtlCol="0" anchor="ctr"/>
+          <a:lstStyle/>
+          <a:p>
+            <a:pPr algn="ctr"/>
+          </a:p>
+        </p:txBody>
+      </p:sp>
+      <p:sp>
+        <p:nvSpPr>
+          <p:cNvPr id="5" name="TextBox 4"/>
           <p:cNvSpPr txBox="1"/>
           <p:nvPr/>
         </p:nvSpPr>
         <p:spPr>
           <a:xfrm>
-            <a:off x="822960" y="3703320"/>
-            <a:ext cx="10515600" cy="548640"/>
+            <a:off x="685800" y="1554480"/>
+            <a:ext cx="10607040" cy="4480560"/>
           </a:xfrm>
           <a:prstGeom prst="rect">
             <a:avLst/>
@@ -6031,18 +6214,128 @@
           <a:noFill/>
         </p:spPr>
         <p:txBody>
-          <a:bodyPr wrap="none">
+          <a:bodyPr wrap="square">
             <a:spAutoFit/>
           </a:bodyPr>
           <a:lstStyle/>
           <a:p>
-            <a:r>
-              <a:rPr sz="2000">
-                <a:solidFill>
-                  <a:srgbClr val="D8D8D8"/>
-                </a:solidFill>
-              </a:rPr>
-              <a:t>Photo-to-Game-Asset Pipeline</a:t>
+            <a:pPr>
+              <a:spcAft>
+                <a:spcPts val="1400"/>
+              </a:spcAft>
+            </a:pPr>
+            <a:r>
+              <a:rPr sz="1900">
+                <a:solidFill>
+                  <a:srgbClr val="14182B"/>
+                </a:solidFill>
+              </a:rPr>
+              <a:t>[1]  Meshy — “Image to 3D” — </a:t>
+            </a:r>
+            <a:r>
+              <a:rPr sz="1900" u="sng">
+                <a:solidFill>
+                  <a:srgbClr val="1F5C9E"/>
+                </a:solidFill>
+                <a:hlinkClick r:id="rId2"/>
+              </a:rPr>
+              <a:t>https://www.meshy.ai/features/image-to-3d</a:t>
+            </a:r>
+          </a:p>
+          <a:p>
+            <a:pPr>
+              <a:spcAft>
+                <a:spcPts val="1400"/>
+              </a:spcAft>
+            </a:pPr>
+            <a:r>
+              <a:rPr sz="1900">
+                <a:solidFill>
+                  <a:srgbClr val="14182B"/>
+                </a:solidFill>
+              </a:rPr>
+              <a:t>[2]  Meshy — “AI Auto Rigging” — </a:t>
+            </a:r>
+            <a:r>
+              <a:rPr sz="1900" u="sng">
+                <a:solidFill>
+                  <a:srgbClr val="1F5C9E"/>
+                </a:solidFill>
+                <a:hlinkClick r:id="rId3"/>
+              </a:rPr>
+              <a:t>https://www.meshy.ai/features/ai-auto-rigging</a:t>
+            </a:r>
+          </a:p>
+          <a:p>
+            <a:pPr>
+              <a:spcAft>
+                <a:spcPts val="1400"/>
+              </a:spcAft>
+            </a:pPr>
+            <a:r>
+              <a:rPr sz="1900">
+                <a:solidFill>
+                  <a:srgbClr val="14182B"/>
+                </a:solidFill>
+              </a:rPr>
+              <a:t>[3]  FrameSixty — “Meshy AI for Developers: Reviewing Generative 3D Asset Generation” — </a:t>
+            </a:r>
+            <a:r>
+              <a:rPr sz="1900" u="sng">
+                <a:solidFill>
+                  <a:srgbClr val="1F5C9E"/>
+                </a:solidFill>
+                <a:hlinkClick r:id="rId4"/>
+              </a:rPr>
+              <a:t>https://framesixty.com/meshy-ai-3d-review/</a:t>
+            </a:r>
+          </a:p>
+          <a:p>
+            <a:pPr>
+              <a:spcAft>
+                <a:spcPts val="1400"/>
+              </a:spcAft>
+            </a:pPr>
+            <a:r>
+              <a:rPr sz="1900">
+                <a:solidFill>
+                  <a:srgbClr val="14182B"/>
+                </a:solidFill>
+              </a:rPr>
+              <a:t>[4]  Meshy API Documentation — </a:t>
+            </a:r>
+            <a:r>
+              <a:rPr sz="1900" u="sng">
+                <a:solidFill>
+                  <a:srgbClr val="1F5C9E"/>
+                </a:solidFill>
+                <a:hlinkClick r:id="rId5"/>
+              </a:rPr>
+              <a:t>https://docs.meshy.ai/en</a:t>
+            </a:r>
+          </a:p>
+          <a:p>
+            <a:pPr>
+              <a:spcAft>
+                <a:spcPts val="1400"/>
+              </a:spcAft>
+            </a:pPr>
+            <a:r>
+              <a:rPr sz="1900">
+                <a:solidFill>
+                  <a:srgbClr val="14182B"/>
+                </a:solidFill>
+              </a:rPr>
+              <a:t>[5]  Meshy Pricing — </a:t>
+            </a:r>
+            <a:r>
+              <a:rPr sz="1900" u="sng">
+                <a:solidFill>
+                  <a:srgbClr val="1F5C9E"/>
+                </a:solidFill>
+                <a:hlinkClick r:id="rId6"/>
+              </a:rPr>
+              <a:t>https://www.meshy.ai/pricing</a:t>
             </a:r>
           </a:p>
         </p:txBody>
@@ -6303,6 +6596,98 @@
                 </a:solidFill>
               </a:rPr>
               <a:t>  Drones, LiDAR, and thermal/visual mapping are an active side effort that plug into this pipeline — or stand alone as their own mapping service.</a:t>
+            </a:r>
+          </a:p>
+        </p:txBody>
+      </p:sp>
+    </p:spTree>
+  </p:cSld>
+  <p:clrMapOvr>
+    <a:masterClrMapping/>
+  </p:clrMapOvr>
+</p:sld>
+</file>
+
+<file path=ppt/slides/slide20.xml><?xml version="1.0" encoding="utf-8"?>
+<p:sld xmlns:a="http://schemas.openxmlformats.org/drawingml/2006/main" xmlns:p="http://schemas.openxmlformats.org/presentationml/2006/main" xmlns:r="http://schemas.openxmlformats.org/officeDocument/2006/relationships">
+  <p:cSld>
+    <p:bg>
+      <p:bgPr>
+        <a:solidFill>
+          <a:srgbClr val="14182B"/>
+        </a:solidFill>
+        <a:effectLst/>
+      </p:bgPr>
+    </p:bg>
+    <p:spTree>
+      <p:nvGrpSpPr>
+        <p:cNvPr id="1" name=""/>
+        <p:cNvGrpSpPr/>
+        <p:nvPr/>
+      </p:nvGrpSpPr>
+      <p:grpSpPr/>
+      <p:sp>
+        <p:nvSpPr>
+          <p:cNvPr id="2" name="TextBox 1"/>
+          <p:cNvSpPr txBox="1"/>
+          <p:nvPr/>
+        </p:nvSpPr>
+        <p:spPr>
+          <a:xfrm>
+            <a:off x="822960" y="2743200"/>
+            <a:ext cx="10515600" cy="1005840"/>
+          </a:xfrm>
+          <a:prstGeom prst="rect">
+            <a:avLst/>
+          </a:prstGeom>
+          <a:noFill/>
+        </p:spPr>
+        <p:txBody>
+          <a:bodyPr wrap="none">
+            <a:spAutoFit/>
+          </a:bodyPr>
+          <a:lstStyle/>
+          <a:p>
+            <a:r>
+              <a:rPr sz="4200" b="1">
+                <a:solidFill>
+                  <a:srgbClr val="FFFFFF"/>
+                </a:solidFill>
+              </a:rPr>
+              <a:t>Questions?</a:t>
+            </a:r>
+          </a:p>
+        </p:txBody>
+      </p:sp>
+      <p:sp>
+        <p:nvSpPr>
+          <p:cNvPr id="3" name="TextBox 2"/>
+          <p:cNvSpPr txBox="1"/>
+          <p:nvPr/>
+        </p:nvSpPr>
+        <p:spPr>
+          <a:xfrm>
+            <a:off x="822960" y="3703320"/>
+            <a:ext cx="10515600" cy="548640"/>
+          </a:xfrm>
+          <a:prstGeom prst="rect">
+            <a:avLst/>
+          </a:prstGeom>
+          <a:noFill/>
+        </p:spPr>
+        <p:txBody>
+          <a:bodyPr wrap="none">
+            <a:spAutoFit/>
+          </a:bodyPr>
+          <a:lstStyle/>
+          <a:p>
+            <a:r>
+              <a:rPr sz="2000">
+                <a:solidFill>
+                  <a:srgbClr val="D8D8D8"/>
+                </a:solidFill>
+              </a:rPr>
+              <a:t>Photo-to-Game-Asset Pipeline</a:t>
             </a:r>
           </a:p>
         </p:txBody>

</xml_diff>

<commit_message>
Add LiDAR/scan and Blender sculpt images to the deck
Background image on the Hardware section divider (dark overlay for
readability), side images on the problem-breakdown, hardware overview,
drone, LiDAR/thermal/visual, and build-it-ourselves slides.
</commit_message>
<xml_diff>
--- a/presentation.pptx
+++ b/presentation.pptx
@@ -3368,7 +3368,7 @@
         <p:spPr>
           <a:xfrm>
             <a:off x="685800" y="1554480"/>
-            <a:ext cx="10607040" cy="2377440"/>
+            <a:ext cx="6858000" cy="1828800"/>
           </a:xfrm>
           <a:prstGeom prst="rect">
             <a:avLst/>
@@ -3387,7 +3387,7 @@
               </a:spcAft>
             </a:pPr>
             <a:r>
-              <a:rPr sz="2200" b="1">
+              <a:rPr sz="1900" b="1">
                 <a:solidFill>
                   <a:srgbClr val="E05A2E"/>
                 </a:solidFill>
@@ -3395,7 +3395,7 @@
               <a:t>●  Adds</a:t>
             </a:r>
             <a:r>
-              <a:rPr sz="2200" b="0">
+              <a:rPr sz="1900" b="0">
                 <a:solidFill>
                   <a:srgbClr val="14182B"/>
                 </a:solidFill>
@@ -3413,8 +3413,8 @@
         </p:nvSpPr>
         <p:spPr>
           <a:xfrm>
-            <a:off x="868680" y="3200400"/>
-            <a:ext cx="10241280" cy="2468880"/>
+            <a:off x="777240" y="2880360"/>
+            <a:ext cx="6766560" cy="2651760"/>
           </a:xfrm>
           <a:prstGeom prst="rect">
             <a:avLst/>
@@ -3428,7 +3428,7 @@
           <a:lstStyle/>
           <a:p>
             <a:r>
-              <a:rPr sz="2200" b="1">
+              <a:rPr sz="1900" b="1">
                 <a:solidFill>
                   <a:srgbClr val="E05A2E"/>
                 </a:solidFill>
@@ -3439,11 +3439,11 @@
           <a:p>
             <a:pPr>
               <a:spcAft>
-                <a:spcPts val="1800"/>
+                <a:spcPts val="1600"/>
               </a:spcAft>
             </a:pPr>
             <a:r>
-              <a:rPr sz="2000">
+              <a:rPr sz="1700">
                 <a:solidFill>
                   <a:srgbClr val="14182B"/>
                 </a:solidFill>
@@ -3453,7 +3453,7 @@
           </a:p>
           <a:p>
             <a:r>
-              <a:rPr sz="2200" b="1">
+              <a:rPr sz="1900" b="1">
                 <a:solidFill>
                   <a:srgbClr val="E05A2E"/>
                 </a:solidFill>
@@ -3463,7 +3463,7 @@
           </a:p>
           <a:p>
             <a:r>
-              <a:rPr sz="2000">
+              <a:rPr sz="1700">
                 <a:solidFill>
                   <a:srgbClr val="14182B"/>
                 </a:solidFill>
@@ -3481,7 +3481,7 @@
         </p:nvSpPr>
         <p:spPr>
           <a:xfrm>
-            <a:off x="640080" y="6126480"/>
+            <a:off x="640080" y="5943600"/>
             <a:ext cx="10881360" cy="548640"/>
           </a:xfrm>
           <a:prstGeom prst="rect">
@@ -3506,6 +3506,146 @@
           </a:p>
         </p:txBody>
       </p:sp>
+      <p:sp>
+        <p:nvSpPr>
+          <p:cNvPr id="8" name="Rectangle 7"/>
+          <p:cNvSpPr/>
+          <p:nvPr/>
+        </p:nvSpPr>
+        <p:spPr>
+          <a:xfrm>
+            <a:off x="8079774" y="1503680"/>
+            <a:ext cx="3134291" cy="2067560"/>
+          </a:xfrm>
+          <a:prstGeom prst="rect">
+            <a:avLst/>
+          </a:prstGeom>
+          <a:solidFill>
+            <a:srgbClr val="FFFFFF"/>
+          </a:solidFill>
+          <a:ln w="12700">
+            <a:solidFill>
+              <a:srgbClr val="DDDDDD"/>
+            </a:solidFill>
+          </a:ln>
+          <a:effectLst/>
+        </p:spPr>
+        <p:style>
+          <a:lnRef idx="1">
+            <a:schemeClr val="accent1"/>
+          </a:lnRef>
+          <a:fillRef idx="3">
+            <a:schemeClr val="accent1"/>
+          </a:fillRef>
+          <a:effectRef idx="2">
+            <a:schemeClr val="accent1"/>
+          </a:effectRef>
+          <a:fontRef idx="minor">
+            <a:schemeClr val="lt1"/>
+          </a:fontRef>
+        </p:style>
+        <p:txBody>
+          <a:bodyPr rtlCol="0" anchor="ctr"/>
+          <a:lstStyle/>
+          <a:p>
+            <a:pPr algn="ctr"/>
+          </a:p>
+        </p:txBody>
+      </p:sp>
+      <p:pic>
+        <p:nvPicPr>
+          <p:cNvPr id="9" name="Picture 8" descr="pp2.jpeg"/>
+          <p:cNvPicPr>
+            <a:picLocks noChangeAspect="1"/>
+          </p:cNvPicPr>
+          <p:nvPr/>
+        </p:nvPicPr>
+        <p:blipFill>
+          <a:blip r:embed="rId2"/>
+          <a:stretch>
+            <a:fillRect/>
+          </a:stretch>
+        </p:blipFill>
+        <p:spPr>
+          <a:xfrm>
+            <a:off x="8130574" y="1554480"/>
+            <a:ext cx="3032691" cy="1965960"/>
+          </a:xfrm>
+          <a:prstGeom prst="rect">
+            <a:avLst/>
+          </a:prstGeom>
+        </p:spPr>
+      </p:pic>
+      <p:sp>
+        <p:nvSpPr>
+          <p:cNvPr id="10" name="Rectangle 9"/>
+          <p:cNvSpPr/>
+          <p:nvPr/>
+        </p:nvSpPr>
+        <p:spPr>
+          <a:xfrm>
+            <a:off x="8022795" y="3652520"/>
+            <a:ext cx="3248249" cy="2067560"/>
+          </a:xfrm>
+          <a:prstGeom prst="rect">
+            <a:avLst/>
+          </a:prstGeom>
+          <a:solidFill>
+            <a:srgbClr val="FFFFFF"/>
+          </a:solidFill>
+          <a:ln w="12700">
+            <a:solidFill>
+              <a:srgbClr val="DDDDDD"/>
+            </a:solidFill>
+          </a:ln>
+          <a:effectLst/>
+        </p:spPr>
+        <p:style>
+          <a:lnRef idx="1">
+            <a:schemeClr val="accent1"/>
+          </a:lnRef>
+          <a:fillRef idx="3">
+            <a:schemeClr val="accent1"/>
+          </a:fillRef>
+          <a:effectRef idx="2">
+            <a:schemeClr val="accent1"/>
+          </a:effectRef>
+          <a:fontRef idx="minor">
+            <a:schemeClr val="lt1"/>
+          </a:fontRef>
+        </p:style>
+        <p:txBody>
+          <a:bodyPr rtlCol="0" anchor="ctr"/>
+          <a:lstStyle/>
+          <a:p>
+            <a:pPr algn="ctr"/>
+          </a:p>
+        </p:txBody>
+      </p:sp>
+      <p:pic>
+        <p:nvPicPr>
+          <p:cNvPr id="11" name="Picture 10" descr="pp5.jpeg"/>
+          <p:cNvPicPr>
+            <a:picLocks noChangeAspect="1"/>
+          </p:cNvPicPr>
+          <p:nvPr/>
+        </p:nvPicPr>
+        <p:blipFill>
+          <a:blip r:embed="rId3"/>
+          <a:stretch>
+            <a:fillRect/>
+          </a:stretch>
+        </p:blipFill>
+        <p:spPr>
+          <a:xfrm>
+            <a:off x="8073595" y="3703320"/>
+            <a:ext cx="3146649" cy="1965960"/>
+          </a:xfrm>
+          <a:prstGeom prst="rect">
+            <a:avLst/>
+          </a:prstGeom>
+        </p:spPr>
+      </p:pic>
     </p:spTree>
   </p:cSld>
   <p:clrMapOvr>
@@ -6846,7 +6986,7 @@
         <p:spPr>
           <a:xfrm>
             <a:off x="685800" y="1600200"/>
-            <a:ext cx="10607040" cy="4480560"/>
+            <a:ext cx="6858000" cy="4480560"/>
           </a:xfrm>
           <a:prstGeom prst="rect">
             <a:avLst/>
@@ -6865,7 +7005,7 @@
               </a:spcAft>
             </a:pPr>
             <a:r>
-              <a:rPr sz="2300" b="1">
+              <a:rPr sz="2100" b="1">
                 <a:solidFill>
                   <a:srgbClr val="E05A2E"/>
                 </a:solidFill>
@@ -6873,7 +7013,7 @@
               <a:t>●  01 — Capture.</a:t>
             </a:r>
             <a:r>
-              <a:rPr sz="2300" b="0">
+              <a:rPr sz="2100" b="0">
                 <a:solidFill>
                   <a:srgbClr val="14182B"/>
                 </a:solidFill>
@@ -6888,7 +7028,7 @@
               </a:spcAft>
             </a:pPr>
             <a:r>
-              <a:rPr sz="2300" b="1">
+              <a:rPr sz="2100" b="1">
                 <a:solidFill>
                   <a:srgbClr val="E05A2E"/>
                 </a:solidFill>
@@ -6896,7 +7036,7 @@
               <a:t>●  02 — Reconstruct &amp; rig.</a:t>
             </a:r>
             <a:r>
-              <a:rPr sz="2300" b="0">
+              <a:rPr sz="2100" b="0">
                 <a:solidFill>
                   <a:srgbClr val="14182B"/>
                 </a:solidFill>
@@ -6911,7 +7051,7 @@
               </a:spcAft>
             </a:pPr>
             <a:r>
-              <a:rPr sz="2300" b="1">
+              <a:rPr sz="2100" b="1">
                 <a:solidFill>
                   <a:srgbClr val="E05A2E"/>
                 </a:solidFill>
@@ -6919,7 +7059,7 @@
               <a:t>●  03 — Import &amp; configure.</a:t>
             </a:r>
             <a:r>
-              <a:rPr sz="2300" b="0">
+              <a:rPr sz="2100" b="0">
                 <a:solidFill>
                   <a:srgbClr val="14182B"/>
                 </a:solidFill>
@@ -6929,6 +7069,76 @@
           </a:p>
         </p:txBody>
       </p:sp>
+      <p:sp>
+        <p:nvSpPr>
+          <p:cNvPr id="6" name="Rectangle 5"/>
+          <p:cNvSpPr/>
+          <p:nvPr/>
+        </p:nvSpPr>
+        <p:spPr>
+          <a:xfrm>
+            <a:off x="7813040" y="2418080"/>
+            <a:ext cx="3667760" cy="2479040"/>
+          </a:xfrm>
+          <a:prstGeom prst="rect">
+            <a:avLst/>
+          </a:prstGeom>
+          <a:solidFill>
+            <a:srgbClr val="FFFFFF"/>
+          </a:solidFill>
+          <a:ln w="12700">
+            <a:solidFill>
+              <a:srgbClr val="DDDDDD"/>
+            </a:solidFill>
+          </a:ln>
+          <a:effectLst/>
+        </p:spPr>
+        <p:style>
+          <a:lnRef idx="1">
+            <a:schemeClr val="accent1"/>
+          </a:lnRef>
+          <a:fillRef idx="3">
+            <a:schemeClr val="accent1"/>
+          </a:fillRef>
+          <a:effectRef idx="2">
+            <a:schemeClr val="accent1"/>
+          </a:effectRef>
+          <a:fontRef idx="minor">
+            <a:schemeClr val="lt1"/>
+          </a:fontRef>
+        </p:style>
+        <p:txBody>
+          <a:bodyPr rtlCol="0" anchor="ctr"/>
+          <a:lstStyle/>
+          <a:p>
+            <a:pPr algn="ctr"/>
+          </a:p>
+        </p:txBody>
+      </p:sp>
+      <p:pic>
+        <p:nvPicPr>
+          <p:cNvPr id="7" name="Picture 6" descr="pp1.jpeg"/>
+          <p:cNvPicPr>
+            <a:picLocks noChangeAspect="1"/>
+          </p:cNvPicPr>
+          <p:nvPr/>
+        </p:nvPicPr>
+        <p:blipFill>
+          <a:blip r:embed="rId2"/>
+          <a:stretch>
+            <a:fillRect/>
+          </a:stretch>
+        </p:blipFill>
+        <p:spPr>
+          <a:xfrm>
+            <a:off x="7863840" y="2468880"/>
+            <a:ext cx="3566160" cy="2377440"/>
+          </a:xfrm>
+          <a:prstGeom prst="rect">
+            <a:avLst/>
+          </a:prstGeom>
+        </p:spPr>
+      </p:pic>
     </p:spTree>
   </p:cSld>
   <p:clrMapOvr>
@@ -6955,9 +7165,77 @@
         <p:nvPr/>
       </p:nvGrpSpPr>
       <p:grpSpPr/>
-      <p:sp>
-        <p:nvSpPr>
-          <p:cNvPr id="2" name="Rectangle 1"/>
+      <p:pic>
+        <p:nvPicPr>
+          <p:cNvPr id="2" name="Picture 1" descr="pp6.jpeg"/>
+          <p:cNvPicPr>
+            <a:picLocks noChangeAspect="1"/>
+          </p:cNvPicPr>
+          <p:nvPr/>
+        </p:nvPicPr>
+        <p:blipFill>
+          <a:blip r:embed="rId2"/>
+          <a:stretch>
+            <a:fillRect/>
+          </a:stretch>
+        </p:blipFill>
+        <p:spPr>
+          <a:xfrm>
+            <a:off x="0" y="0"/>
+            <a:ext cx="12191695" cy="6858000"/>
+          </a:xfrm>
+          <a:prstGeom prst="rect">
+            <a:avLst/>
+          </a:prstGeom>
+        </p:spPr>
+      </p:pic>
+      <p:sp>
+        <p:nvSpPr>
+          <p:cNvPr id="3" name="Rectangle 2"/>
+          <p:cNvSpPr/>
+          <p:nvPr/>
+        </p:nvSpPr>
+        <p:spPr>
+          <a:xfrm>
+            <a:off x="0" y="0"/>
+            <a:ext cx="12191695" cy="6858000"/>
+          </a:xfrm>
+          <a:prstGeom prst="rect">
+            <a:avLst/>
+          </a:prstGeom>
+          <a:solidFill>
+            <a:srgbClr val="14182B"/>
+            <a:alpha val="60000"/>
+          </a:solidFill>
+          <a:ln>
+            <a:noFill/>
+          </a:ln>
+        </p:spPr>
+        <p:style>
+          <a:lnRef idx="1">
+            <a:schemeClr val="accent1"/>
+          </a:lnRef>
+          <a:fillRef idx="3">
+            <a:schemeClr val="accent1"/>
+          </a:fillRef>
+          <a:effectRef idx="2">
+            <a:schemeClr val="accent1"/>
+          </a:effectRef>
+          <a:fontRef idx="minor">
+            <a:schemeClr val="lt1"/>
+          </a:fontRef>
+        </p:style>
+        <p:txBody>
+          <a:bodyPr rtlCol="0" anchor="ctr"/>
+          <a:lstStyle/>
+          <a:p>
+            <a:pPr algn="ctr"/>
+          </a:p>
+        </p:txBody>
+      </p:sp>
+      <p:sp>
+        <p:nvSpPr>
+          <p:cNvPr id="4" name="Rectangle 3"/>
           <p:cNvSpPr/>
           <p:nvPr/>
         </p:nvSpPr>
@@ -7000,7 +7278,7 @@
       </p:sp>
       <p:sp>
         <p:nvSpPr>
-          <p:cNvPr id="3" name="TextBox 2"/>
+          <p:cNvPr id="5" name="TextBox 4"/>
           <p:cNvSpPr txBox="1"/>
           <p:nvPr/>
         </p:nvSpPr>
@@ -7033,7 +7311,7 @@
       </p:sp>
       <p:sp>
         <p:nvSpPr>
-          <p:cNvPr id="4" name="TextBox 3"/>
+          <p:cNvPr id="6" name="TextBox 5"/>
           <p:cNvSpPr txBox="1"/>
           <p:nvPr/>
         </p:nvSpPr>
@@ -7218,7 +7496,7 @@
         <p:spPr>
           <a:xfrm>
             <a:off x="685800" y="1645920"/>
-            <a:ext cx="10607040" cy="3931920"/>
+            <a:ext cx="6858000" cy="3931920"/>
           </a:xfrm>
           <a:prstGeom prst="rect">
             <a:avLst/>
@@ -7237,7 +7515,7 @@
               </a:spcAft>
             </a:pPr>
             <a:r>
-              <a:rPr sz="2400" b="1">
+              <a:rPr sz="2100" b="1">
                 <a:solidFill>
                   <a:srgbClr val="E05A2E"/>
                 </a:solidFill>
@@ -7245,7 +7523,7 @@
               <a:t>●  What we capture</a:t>
             </a:r>
             <a:r>
-              <a:rPr sz="2400" b="0">
+              <a:rPr sz="2100" b="0">
                 <a:solidFill>
                   <a:srgbClr val="14182B"/>
                 </a:solidFill>
@@ -7260,7 +7538,7 @@
               </a:spcAft>
             </a:pPr>
             <a:r>
-              <a:rPr sz="2400" b="1">
+              <a:rPr sz="2100" b="1">
                 <a:solidFill>
                   <a:srgbClr val="E05A2E"/>
                 </a:solidFill>
@@ -7268,7 +7546,7 @@
               <a:t>●  Beyond that,</a:t>
             </a:r>
             <a:r>
-              <a:rPr sz="2400" b="0">
+              <a:rPr sz="2100" b="0">
                 <a:solidFill>
                   <a:srgbClr val="14182B"/>
                 </a:solidFill>
@@ -7283,7 +7561,7 @@
               </a:spcAft>
             </a:pPr>
             <a:r>
-              <a:rPr sz="2400" b="1">
+              <a:rPr sz="2100" b="1">
                 <a:solidFill>
                   <a:srgbClr val="E05A2E"/>
                 </a:solidFill>
@@ -7291,7 +7569,7 @@
               <a:t>●  The key decision:</a:t>
             </a:r>
             <a:r>
-              <a:rPr sz="2400" b="0">
+              <a:rPr sz="2100" b="0">
                 <a:solidFill>
                   <a:srgbClr val="14182B"/>
                 </a:solidFill>
@@ -7301,6 +7579,76 @@
           </a:p>
         </p:txBody>
       </p:sp>
+      <p:sp>
+        <p:nvSpPr>
+          <p:cNvPr id="6" name="Rectangle 5"/>
+          <p:cNvSpPr/>
+          <p:nvPr/>
+        </p:nvSpPr>
+        <p:spPr>
+          <a:xfrm>
+            <a:off x="7813040" y="2272276"/>
+            <a:ext cx="3667760" cy="2770647"/>
+          </a:xfrm>
+          <a:prstGeom prst="rect">
+            <a:avLst/>
+          </a:prstGeom>
+          <a:solidFill>
+            <a:srgbClr val="FFFFFF"/>
+          </a:solidFill>
+          <a:ln w="12700">
+            <a:solidFill>
+              <a:srgbClr val="DDDDDD"/>
+            </a:solidFill>
+          </a:ln>
+          <a:effectLst/>
+        </p:spPr>
+        <p:style>
+          <a:lnRef idx="1">
+            <a:schemeClr val="accent1"/>
+          </a:lnRef>
+          <a:fillRef idx="3">
+            <a:schemeClr val="accent1"/>
+          </a:fillRef>
+          <a:effectRef idx="2">
+            <a:schemeClr val="accent1"/>
+          </a:effectRef>
+          <a:fontRef idx="minor">
+            <a:schemeClr val="lt1"/>
+          </a:fontRef>
+        </p:style>
+        <p:txBody>
+          <a:bodyPr rtlCol="0" anchor="ctr"/>
+          <a:lstStyle/>
+          <a:p>
+            <a:pPr algn="ctr"/>
+          </a:p>
+        </p:txBody>
+      </p:sp>
+      <p:pic>
+        <p:nvPicPr>
+          <p:cNvPr id="7" name="Picture 6" descr="pp7.jpeg"/>
+          <p:cNvPicPr>
+            <a:picLocks noChangeAspect="1"/>
+          </p:cNvPicPr>
+          <p:nvPr/>
+        </p:nvPicPr>
+        <p:blipFill>
+          <a:blip r:embed="rId2"/>
+          <a:stretch>
+            <a:fillRect/>
+          </a:stretch>
+        </p:blipFill>
+        <p:spPr>
+          <a:xfrm>
+            <a:off x="7863840" y="2323076"/>
+            <a:ext cx="3566160" cy="2669047"/>
+          </a:xfrm>
+          <a:prstGeom prst="rect">
+            <a:avLst/>
+          </a:prstGeom>
+        </p:spPr>
+      </p:pic>
     </p:spTree>
   </p:cSld>
   <p:clrMapOvr>
@@ -7455,7 +7803,7 @@
         <p:spPr>
           <a:xfrm>
             <a:off x="685800" y="1600200"/>
-            <a:ext cx="10607040" cy="4480560"/>
+            <a:ext cx="6858000" cy="4480560"/>
           </a:xfrm>
           <a:prstGeom prst="rect">
             <a:avLst/>
@@ -7470,11 +7818,11 @@
           <a:p>
             <a:pPr>
               <a:spcAft>
-                <a:spcPts val="1400"/>
+                <a:spcPts val="1100"/>
               </a:spcAft>
             </a:pPr>
             <a:r>
-              <a:rPr sz="2000" b="1">
+              <a:rPr sz="1700" b="1">
                 <a:solidFill>
                   <a:srgbClr val="1F5C9E"/>
                 </a:solidFill>
@@ -7482,7 +7830,7 @@
               <a:t>●  Capture app</a:t>
             </a:r>
             <a:r>
-              <a:rPr sz="2000" b="0">
+              <a:rPr sz="1700" b="0">
                 <a:solidFill>
                   <a:srgbClr val="14182B"/>
                 </a:solidFill>
@@ -7493,11 +7841,11 @@
           <a:p>
             <a:pPr>
               <a:spcAft>
-                <a:spcPts val="1400"/>
+                <a:spcPts val="1100"/>
               </a:spcAft>
             </a:pPr>
             <a:r>
-              <a:rPr sz="2000" b="1">
+              <a:rPr sz="1700" b="1">
                 <a:solidFill>
                   <a:srgbClr val="1F5C9E"/>
                 </a:solidFill>
@@ -7505,7 +7853,7 @@
               <a:t>●  Blender script</a:t>
             </a:r>
             <a:r>
-              <a:rPr sz="2000" b="0">
+              <a:rPr sz="1700" b="0">
                 <a:solidFill>
                   <a:srgbClr val="14182B"/>
                 </a:solidFill>
@@ -7516,11 +7864,11 @@
           <a:p>
             <a:pPr>
               <a:spcAft>
-                <a:spcPts val="1400"/>
+                <a:spcPts val="1100"/>
               </a:spcAft>
             </a:pPr>
             <a:r>
-              <a:rPr sz="2000" b="1">
+              <a:rPr sz="1700" b="1">
                 <a:solidFill>
                   <a:srgbClr val="1F5C9E"/>
                 </a:solidFill>
@@ -7528,7 +7876,7 @@
               <a:t>●  Unity script</a:t>
             </a:r>
             <a:r>
-              <a:rPr sz="2000" b="0">
+              <a:rPr sz="1700" b="0">
                 <a:solidFill>
                   <a:srgbClr val="14182B"/>
                 </a:solidFill>
@@ -7539,11 +7887,11 @@
           <a:p>
             <a:pPr>
               <a:spcAft>
-                <a:spcPts val="1400"/>
+                <a:spcPts val="1100"/>
               </a:spcAft>
             </a:pPr>
             <a:r>
-              <a:rPr sz="2000" b="1">
+              <a:rPr sz="1700" b="1">
                 <a:solidFill>
                   <a:srgbClr val="1F5C9E"/>
                 </a:solidFill>
@@ -7551,12 +7899,116 @@
               <a:t>●  What this actually is:</a:t>
             </a:r>
             <a:r>
-              <a:rPr sz="2000" b="0">
+              <a:rPr sz="1700" b="0">
                 <a:solidFill>
                   <a:srgbClr val="14182B"/>
                 </a:solidFill>
               </a:rPr>
               <a:t>  classical scripting/automation against Blender's and Unity's own APIs — no model training required for the rigging/import half.</a:t>
+            </a:r>
+          </a:p>
+        </p:txBody>
+      </p:sp>
+      <p:sp>
+        <p:nvSpPr>
+          <p:cNvPr id="6" name="Rectangle 5"/>
+          <p:cNvSpPr/>
+          <p:nvPr/>
+        </p:nvSpPr>
+        <p:spPr>
+          <a:xfrm>
+            <a:off x="7813040" y="2606536"/>
+            <a:ext cx="3667760" cy="2102128"/>
+          </a:xfrm>
+          <a:prstGeom prst="rect">
+            <a:avLst/>
+          </a:prstGeom>
+          <a:solidFill>
+            <a:srgbClr val="FFFFFF"/>
+          </a:solidFill>
+          <a:ln w="12700">
+            <a:solidFill>
+              <a:srgbClr val="DDDDDD"/>
+            </a:solidFill>
+          </a:ln>
+          <a:effectLst/>
+        </p:spPr>
+        <p:style>
+          <a:lnRef idx="1">
+            <a:schemeClr val="accent1"/>
+          </a:lnRef>
+          <a:fillRef idx="3">
+            <a:schemeClr val="accent1"/>
+          </a:fillRef>
+          <a:effectRef idx="2">
+            <a:schemeClr val="accent1"/>
+          </a:effectRef>
+          <a:fontRef idx="minor">
+            <a:schemeClr val="lt1"/>
+          </a:fontRef>
+        </p:style>
+        <p:txBody>
+          <a:bodyPr rtlCol="0" anchor="ctr"/>
+          <a:lstStyle/>
+          <a:p>
+            <a:pPr algn="ctr"/>
+          </a:p>
+        </p:txBody>
+      </p:sp>
+      <p:pic>
+        <p:nvPicPr>
+          <p:cNvPr id="7" name="Picture 6" descr="pp8.jpeg"/>
+          <p:cNvPicPr>
+            <a:picLocks noChangeAspect="1"/>
+          </p:cNvPicPr>
+          <p:nvPr/>
+        </p:nvPicPr>
+        <p:blipFill>
+          <a:blip r:embed="rId2"/>
+          <a:stretch>
+            <a:fillRect/>
+          </a:stretch>
+        </p:blipFill>
+        <p:spPr>
+          <a:xfrm>
+            <a:off x="7863840" y="2657336"/>
+            <a:ext cx="3566160" cy="2000528"/>
+          </a:xfrm>
+          <a:prstGeom prst="rect">
+            <a:avLst/>
+          </a:prstGeom>
+        </p:spPr>
+      </p:pic>
+      <p:sp>
+        <p:nvSpPr>
+          <p:cNvPr id="8" name="TextBox 7"/>
+          <p:cNvSpPr txBox="1"/>
+          <p:nvPr/>
+        </p:nvSpPr>
+        <p:spPr>
+          <a:xfrm>
+            <a:off x="7863840" y="5623560"/>
+            <a:ext cx="3566160" cy="457200"/>
+          </a:xfrm>
+          <a:prstGeom prst="rect">
+            <a:avLst/>
+          </a:prstGeom>
+          <a:noFill/>
+        </p:spPr>
+        <p:txBody>
+          <a:bodyPr wrap="none">
+            <a:spAutoFit/>
+          </a:bodyPr>
+          <a:lstStyle/>
+          <a:p>
+            <a:pPr algn="ctr"/>
+            <a:r>
+              <a:rPr sz="1100" i="1">
+                <a:solidFill>
+                  <a:srgbClr val="4A4A4A"/>
+                </a:solidFill>
+              </a:rPr>
+              <a:t>Our own Blender sculpting/rigging workspace</a:t>
             </a:r>
           </a:p>
         </p:txBody>
@@ -8235,7 +8687,7 @@
         <p:spPr>
           <a:xfrm>
             <a:off x="685800" y="1554480"/>
-            <a:ext cx="10607040" cy="3291840"/>
+            <a:ext cx="6858000" cy="3291840"/>
           </a:xfrm>
           <a:prstGeom prst="rect">
             <a:avLst/>
@@ -8254,7 +8706,7 @@
               </a:spcAft>
             </a:pPr>
             <a:r>
-              <a:rPr sz="2200" b="1">
+              <a:rPr sz="2000" b="1">
                 <a:solidFill>
                   <a:srgbClr val="E05A2E"/>
                 </a:solidFill>
@@ -8262,7 +8714,7 @@
               <a:t>●  Why drones:</a:t>
             </a:r>
             <a:r>
-              <a:rPr sz="2200" b="0">
+              <a:rPr sz="2000" b="0">
                 <a:solidFill>
                   <a:srgbClr val="14182B"/>
                 </a:solidFill>
@@ -8277,7 +8729,7 @@
               </a:spcAft>
             </a:pPr>
             <a:r>
-              <a:rPr sz="2200" b="1">
+              <a:rPr sz="2000" b="1">
                 <a:solidFill>
                   <a:srgbClr val="E05A2E"/>
                 </a:solidFill>
@@ -8285,7 +8737,7 @@
               <a:t>●  Same pipeline:</a:t>
             </a:r>
             <a:r>
-              <a:rPr sz="2200" b="0">
+              <a:rPr sz="2000" b="0">
                 <a:solidFill>
                   <a:srgbClr val="14182B"/>
                 </a:solidFill>
@@ -8300,7 +8752,7 @@
               </a:spcAft>
             </a:pPr>
             <a:r>
-              <a:rPr sz="2200" b="1">
+              <a:rPr sz="2000" b="1">
                 <a:solidFill>
                   <a:srgbClr val="E05A2E"/>
                 </a:solidFill>
@@ -8308,7 +8760,7 @@
               <a:t>●  Status:</a:t>
             </a:r>
             <a:r>
-              <a:rPr sz="2200" b="0">
+              <a:rPr sz="2000" b="0">
                 <a:solidFill>
                   <a:srgbClr val="14182B"/>
                 </a:solidFill>
@@ -8326,7 +8778,7 @@
         </p:nvSpPr>
         <p:spPr>
           <a:xfrm>
-            <a:off x="640080" y="6126480"/>
+            <a:off x="640080" y="4846320"/>
             <a:ext cx="10881360" cy="548640"/>
           </a:xfrm>
           <a:prstGeom prst="rect">
@@ -8351,6 +8803,76 @@
           </a:p>
         </p:txBody>
       </p:sp>
+      <p:sp>
+        <p:nvSpPr>
+          <p:cNvPr id="7" name="Rectangle 6"/>
+          <p:cNvSpPr/>
+          <p:nvPr/>
+        </p:nvSpPr>
+        <p:spPr>
+          <a:xfrm>
+            <a:off x="7813040" y="2464307"/>
+            <a:ext cx="3667760" cy="2203705"/>
+          </a:xfrm>
+          <a:prstGeom prst="rect">
+            <a:avLst/>
+          </a:prstGeom>
+          <a:solidFill>
+            <a:srgbClr val="FFFFFF"/>
+          </a:solidFill>
+          <a:ln w="12700">
+            <a:solidFill>
+              <a:srgbClr val="DDDDDD"/>
+            </a:solidFill>
+          </a:ln>
+          <a:effectLst/>
+        </p:spPr>
+        <p:style>
+          <a:lnRef idx="1">
+            <a:schemeClr val="accent1"/>
+          </a:lnRef>
+          <a:fillRef idx="3">
+            <a:schemeClr val="accent1"/>
+          </a:fillRef>
+          <a:effectRef idx="2">
+            <a:schemeClr val="accent1"/>
+          </a:effectRef>
+          <a:fontRef idx="minor">
+            <a:schemeClr val="lt1"/>
+          </a:fontRef>
+        </p:style>
+        <p:txBody>
+          <a:bodyPr rtlCol="0" anchor="ctr"/>
+          <a:lstStyle/>
+          <a:p>
+            <a:pPr algn="ctr"/>
+          </a:p>
+        </p:txBody>
+      </p:sp>
+      <p:pic>
+        <p:nvPicPr>
+          <p:cNvPr id="8" name="Picture 7" descr="pp3.jpeg"/>
+          <p:cNvPicPr>
+            <a:picLocks noChangeAspect="1"/>
+          </p:cNvPicPr>
+          <p:nvPr/>
+        </p:nvPicPr>
+        <p:blipFill>
+          <a:blip r:embed="rId2"/>
+          <a:stretch>
+            <a:fillRect/>
+          </a:stretch>
+        </p:blipFill>
+        <p:spPr>
+          <a:xfrm>
+            <a:off x="7863840" y="2515107"/>
+            <a:ext cx="3566160" cy="2102105"/>
+          </a:xfrm>
+          <a:prstGeom prst="rect">
+            <a:avLst/>
+          </a:prstGeom>
+        </p:spPr>
+      </p:pic>
     </p:spTree>
   </p:cSld>
   <p:clrMapOvr>

</xml_diff>